<commit_message>
docs: Joseph asume la seccion del modelo; reparto y diapositivas actualizados
El sistema lo desarrollo Joseph (los 30 commits del repositorio son suyos), pero
el reparto anterior le dejaba solo apertura y cierre y asignaba la seccion de
mayor puntaje a quien no escribio ese codigo. Se corrige:

- Joseph expone ahora tambien el modelo (entrenamiento, seleccion de
  caracteristicas, hiperparametros y evaluacion) e interviene 3 veces, 5:30 de 12.
- Juan pasa a dataset y fuentes de datos (1:30); su guion se reescribe.
- Se acuerda que Joseph responde todas las preguntas tecnicas; se anaden las del
  modelo a su guion.
- Paul deja a un clic Insights > Contributors durante la seccion de IC.
- Nueva diapositiva "Hiperparametros optimizados" con el grid de 24 combinaciones
  y las metricas de evaluacion (8 en total).
- Cierre menciona el informe tecnico como entregable.

Co-Authored-By: Claude Opus 4.8 <noreply@anthropic.com>
</commit_message>
<xml_diff>
--- a/docs/presentacion/FrostPuno_Joseph.pptx
+++ b/docs/presentacion/FrostPuno_Joseph.pptx
@@ -12,9 +12,10 @@
     <p:sldId id="260" r:id="rId6"/>
     <p:sldId id="261" r:id="rId7"/>
     <p:sldId id="262" r:id="rId8"/>
+    <p:sldId id="263" r:id="rId9"/>
   </p:sldIdLst>
   <p:notesMasterIdLst>
-    <p:notesMasterId r:id="rId9"/>
+    <p:notesMasterId r:id="rId10"/>
   </p:notesMasterIdLst>
   <p:sldSz cx="12191695" cy="6858000"/>
   <p:notesSz cx="6858000" cy="12191695"/>
@@ -1060,6 +1061,94 @@
             <a:fld id="{F7021451-1387-4CA6-816F-3879F97B5CBC}" type="slidenum">
               <a:rPr lang="en-US"/>
               <a:t>7</a:t>
+            </a:fld>
+            <a:endParaRPr lang="en-US"/>
+          </a:p>
+        </p:txBody>
+      </p:sp>
+    </p:spTree>
+    <p:extLst>
+      <p:ext uri="{BB962C8B-B14F-4D97-AF65-F5344CB8AC3E}">
+        <p14:creationId xmlns:p14="http://schemas.microsoft.com/office/powerpoint/2010/main" val="1024086991"/>
+      </p:ext>
+    </p:extLst>
+  </p:cSld>
+  <p:clrMapOvr>
+    <a:masterClrMapping/>
+  </p:clrMapOvr>
+</p:notes>
+</file>
+
+<file path=ppt/notesSlides/notesSlide8.xml><?xml version="1.0" encoding="utf-8"?>
+<p:notes xmlns:a="http://schemas.openxmlformats.org/drawingml/2006/main" xmlns:r="http://schemas.openxmlformats.org/officeDocument/2006/relationships" xmlns:p="http://schemas.openxmlformats.org/presentationml/2006/main">
+  <p:cSld>
+    <p:spTree>
+      <p:nvGrpSpPr>
+        <p:cNvPr id="1" name=""/>
+        <p:cNvGrpSpPr/>
+        <p:nvPr/>
+      </p:nvGrpSpPr>
+      <p:grpSpPr>
+        <a:xfrm>
+          <a:off x="0" y="0"/>
+          <a:ext cx="0" cy="0"/>
+          <a:chOff x="0" y="0"/>
+          <a:chExt cx="0" cy="0"/>
+        </a:xfrm>
+      </p:grpSpPr>
+      <p:sp>
+        <p:nvSpPr>
+          <p:cNvPr id="2" name="Slide Image Placeholder 1"/>
+          <p:cNvSpPr>
+            <a:spLocks noGrp="1" noRot="1" noChangeAspect="1"/>
+          </p:cNvSpPr>
+          <p:nvPr>
+            <p:ph type="sldImg"/>
+          </p:nvPr>
+        </p:nvSpPr>
+        <p:spPr/>
+      </p:sp>
+      <p:sp>
+        <p:nvSpPr>
+          <p:cNvPr id="3" name="Notes Placeholder 2"/>
+          <p:cNvSpPr>
+            <a:spLocks noGrp="1"/>
+          </p:cNvSpPr>
+          <p:nvPr>
+            <p:ph type="body" idx="1"/>
+          </p:nvPr>
+        </p:nvSpPr>
+        <p:spPr/>
+        <p:txBody>
+          <a:bodyPr/>
+          <a:lstStyle/>
+          <a:p>
+            <a:r>
+              <a:rPr lang="en-US" dirty="0"/>
+              <a:t/>
+            </a:r>
+            <a:endParaRPr lang="en-US" dirty="0"/>
+          </a:p>
+        </p:txBody>
+      </p:sp>
+      <p:sp>
+        <p:nvSpPr>
+          <p:cNvPr id="4" name="Slide Number Placeholder 3"/>
+          <p:cNvSpPr>
+            <a:spLocks noGrp="1"/>
+          </p:cNvSpPr>
+          <p:nvPr>
+            <p:ph type="sldNum" sz="quarter" idx="10"/>
+          </p:nvPr>
+        </p:nvSpPr>
+        <p:spPr/>
+        <p:txBody>
+          <a:bodyPr/>
+          <a:lstStyle/>
+          <a:p>
+            <a:fld id="{F7021451-1387-4CA6-816F-3879F97B5CBC}" type="slidenum">
+              <a:rPr lang="en-US"/>
+              <a:t>8</a:t>
             </a:fld>
             <a:endParaRPr lang="en-US"/>
           </a:p>
@@ -4779,7 +4868,7 @@
                 <a:ea typeface="Calibri" pitchFamily="34" charset="-122"/>
                 <a:cs typeface="Calibri" pitchFamily="34" charset="-120"/>
               </a:rPr>
-              <a:t>LIMITACIONES</a:t>
+              <a:t>ENTRENAMIENTO</a:t>
             </a:r>
             <a:endParaRPr lang="en-US" sz="1200" dirty="0"/>
           </a:p>
@@ -4818,7 +4907,7 @@
                 <a:ea typeface="Georgia" pitchFamily="34" charset="-122"/>
                 <a:cs typeface="Georgia" pitchFamily="34" charset="-120"/>
               </a:rPr>
-              <a:t>Lo que el sistema todavia no hace</a:t>
+              <a:t>Hiperparametros optimizados</a:t>
             </a:r>
             <a:endParaRPr lang="en-US" sz="3600" dirty="0"/>
           </a:p>
@@ -4857,69 +4946,1105 @@
                 <a:ea typeface="Calibri" pitchFamily="34" charset="-122"/>
                 <a:cs typeface="Calibri" pitchFamily="34" charset="-120"/>
               </a:rPr>
-              <a:t>Un informe honesto vale mas que uno perfecto.</a:t>
+              <a:t>Grid search de 24 combinaciones, maximizando silhouette.</a:t>
             </a:r>
             <a:endParaRPr lang="en-US" sz="1600" dirty="0"/>
           </a:p>
         </p:txBody>
       </p:sp>
-      <p:sp>
-        <p:nvSpPr>
-          <p:cNvPr id="6" name="Shape 4"/>
-          <p:cNvSpPr/>
-          <p:nvPr/>
-        </p:nvSpPr>
-        <p:spPr>
-          <a:xfrm>
-            <a:off x="1143000" y="1920240"/>
-            <a:ext cx="9921240" cy="1097280"/>
+      <p:graphicFrame>
+        <p:nvGraphicFramePr>
+          <p:cNvPr id="7" name="Table 0"/>
+          <p:cNvGraphicFramePr>
+            <a:graphicFrameLocks noGrp="1"/>
+          </p:cNvGraphicFramePr>
+          <p:nvPr>
+            <p:extLst>
+              <p:ext uri="{D42A27DB-BD31-4B8C-83A1-F6EECF244321}">
+                <p14:modId xmlns:p14="http://schemas.microsoft.com/office/powerpoint/2010/main" val="1579011935"/>
+              </p:ext>
+            </p:extLst>
+          </p:nvPr>
+        </p:nvGraphicFramePr>
+        <p:xfrm>
+          <a:off x="1143000" y="1737360"/>
+          <a:ext cx="6537960" cy="2103120"/>
+        </p:xfrm>
+        <a:graphic>
+          <a:graphicData uri="http://schemas.openxmlformats.org/drawingml/2006/table">
+            <a:tbl>
+              <a:tblPr/>
+              <a:tblGrid>
+                <a:gridCol w="2148840"/>
+                <a:gridCol w="3017520"/>
+                <a:gridCol w="1371600"/>
+              </a:tblGrid>
+              <a:tr h="420624">
+                <a:tc>
+                  <a:txBody>
+                    <a:bodyPr/>
+                    <a:lstStyle/>
+                    <a:p>
+                      <a:pPr indent="0" marL="0">
+                        <a:buNone/>
+                      </a:pPr>
+                      <a:r>
+                        <a:rPr lang="en-US" sz="1300" b="1" dirty="0">
+                          <a:solidFill>
+                            <a:srgbClr val="FFFFFF"/>
+                          </a:solidFill>
+                          <a:latin typeface="Calibri" pitchFamily="34" charset="0"/>
+                          <a:ea typeface="Calibri" pitchFamily="34" charset="-122"/>
+                          <a:cs typeface="Calibri" pitchFamily="34" charset="-120"/>
+                        </a:rPr>
+                        <a:t>Hiperparametro</a:t>
+                      </a:r>
+                      <a:endParaRPr lang="en-US" sz="1300" dirty="0">
+                        <a:latin typeface="Calibri" charset="0"/>
+                        <a:ea typeface="Calibri" charset="0"/>
+                        <a:cs typeface="Calibri" charset="0"/>
+                      </a:endParaRPr>
+                    </a:p>
+                  </a:txBody>
+                  <a:tcPr marL="91440" marR="91440" marT="45720" marB="45720" anchor="ctr">
+                    <a:lnL w="12700" cap="flat" cmpd="sng" algn="ctr">
+                      <a:solidFill>
+                        <a:srgbClr val="E1E5E8"/>
+                      </a:solidFill>
+                      <a:prstDash val="solid"/>
+                      <a:round/>
+                      <a:headEnd type="none" w="med" len="med"/>
+                      <a:tailEnd type="none" w="med" len="med"/>
+                    </a:lnL>
+                    <a:lnR w="12700" cap="flat" cmpd="sng" algn="ctr">
+                      <a:solidFill>
+                        <a:srgbClr val="E1E5E8"/>
+                      </a:solidFill>
+                      <a:prstDash val="solid"/>
+                      <a:round/>
+                      <a:headEnd type="none" w="med" len="med"/>
+                      <a:tailEnd type="none" w="med" len="med"/>
+                    </a:lnR>
+                    <a:lnT w="12700" cap="flat" cmpd="sng" algn="ctr">
+                      <a:solidFill>
+                        <a:srgbClr val="E1E5E8"/>
+                      </a:solidFill>
+                      <a:prstDash val="solid"/>
+                      <a:round/>
+                      <a:headEnd type="none" w="med" len="med"/>
+                      <a:tailEnd type="none" w="med" len="med"/>
+                    </a:lnT>
+                    <a:lnB w="12700" cap="flat" cmpd="sng" algn="ctr">
+                      <a:solidFill>
+                        <a:srgbClr val="E1E5E8"/>
+                      </a:solidFill>
+                      <a:prstDash val="solid"/>
+                      <a:round/>
+                      <a:headEnd type="none" w="med" len="med"/>
+                      <a:tailEnd type="none" w="med" len="med"/>
+                    </a:lnB>
+                    <a:solidFill>
+                      <a:srgbClr val="0D1B2A"/>
+                    </a:solidFill>
+                  </a:tcPr>
+                </a:tc>
+                <a:tc>
+                  <a:txBody>
+                    <a:bodyPr/>
+                    <a:lstStyle/>
+                    <a:p>
+                      <a:pPr indent="0" marL="0">
+                        <a:buNone/>
+                      </a:pPr>
+                      <a:r>
+                        <a:rPr lang="en-US" sz="1300" b="1" dirty="0">
+                          <a:solidFill>
+                            <a:srgbClr val="FFFFFF"/>
+                          </a:solidFill>
+                          <a:latin typeface="Calibri" pitchFamily="34" charset="0"/>
+                          <a:ea typeface="Calibri" pitchFamily="34" charset="-122"/>
+                          <a:cs typeface="Calibri" pitchFamily="34" charset="-120"/>
+                        </a:rPr>
+                        <a:t>Valores explorados</a:t>
+                      </a:r>
+                      <a:endParaRPr lang="en-US" sz="1300" dirty="0">
+                        <a:latin typeface="Calibri" charset="0"/>
+                        <a:ea typeface="Calibri" charset="0"/>
+                        <a:cs typeface="Calibri" charset="0"/>
+                      </a:endParaRPr>
+                    </a:p>
+                  </a:txBody>
+                  <a:tcPr marL="91440" marR="91440" marT="45720" marB="45720" anchor="ctr">
+                    <a:lnL w="12700" cap="flat" cmpd="sng" algn="ctr">
+                      <a:solidFill>
+                        <a:srgbClr val="E1E5E8"/>
+                      </a:solidFill>
+                      <a:prstDash val="solid"/>
+                      <a:round/>
+                      <a:headEnd type="none" w="med" len="med"/>
+                      <a:tailEnd type="none" w="med" len="med"/>
+                    </a:lnL>
+                    <a:lnR w="12700" cap="flat" cmpd="sng" algn="ctr">
+                      <a:solidFill>
+                        <a:srgbClr val="E1E5E8"/>
+                      </a:solidFill>
+                      <a:prstDash val="solid"/>
+                      <a:round/>
+                      <a:headEnd type="none" w="med" len="med"/>
+                      <a:tailEnd type="none" w="med" len="med"/>
+                    </a:lnR>
+                    <a:lnT w="12700" cap="flat" cmpd="sng" algn="ctr">
+                      <a:solidFill>
+                        <a:srgbClr val="E1E5E8"/>
+                      </a:solidFill>
+                      <a:prstDash val="solid"/>
+                      <a:round/>
+                      <a:headEnd type="none" w="med" len="med"/>
+                      <a:tailEnd type="none" w="med" len="med"/>
+                    </a:lnT>
+                    <a:lnB w="12700" cap="flat" cmpd="sng" algn="ctr">
+                      <a:solidFill>
+                        <a:srgbClr val="E1E5E8"/>
+                      </a:solidFill>
+                      <a:prstDash val="solid"/>
+                      <a:round/>
+                      <a:headEnd type="none" w="med" len="med"/>
+                      <a:tailEnd type="none" w="med" len="med"/>
+                    </a:lnB>
+                    <a:solidFill>
+                      <a:srgbClr val="0D1B2A"/>
+                    </a:solidFill>
+                  </a:tcPr>
+                </a:tc>
+                <a:tc>
+                  <a:txBody>
+                    <a:bodyPr/>
+                    <a:lstStyle/>
+                    <a:p>
+                      <a:pPr indent="0" marL="0">
+                        <a:buNone/>
+                      </a:pPr>
+                      <a:r>
+                        <a:rPr lang="en-US" sz="1300" b="1" dirty="0">
+                          <a:solidFill>
+                            <a:srgbClr val="FFFFFF"/>
+                          </a:solidFill>
+                          <a:latin typeface="Calibri" pitchFamily="34" charset="0"/>
+                          <a:ea typeface="Calibri" pitchFamily="34" charset="-122"/>
+                          <a:cs typeface="Calibri" pitchFamily="34" charset="-120"/>
+                        </a:rPr>
+                        <a:t>Elegido</a:t>
+                      </a:r>
+                      <a:endParaRPr lang="en-US" sz="1300" dirty="0">
+                        <a:latin typeface="Calibri" charset="0"/>
+                        <a:ea typeface="Calibri" charset="0"/>
+                        <a:cs typeface="Calibri" charset="0"/>
+                      </a:endParaRPr>
+                    </a:p>
+                  </a:txBody>
+                  <a:tcPr marL="91440" marR="91440" marT="45720" marB="45720" anchor="ctr">
+                    <a:lnL w="12700" cap="flat" cmpd="sng" algn="ctr">
+                      <a:solidFill>
+                        <a:srgbClr val="E1E5E8"/>
+                      </a:solidFill>
+                      <a:prstDash val="solid"/>
+                      <a:round/>
+                      <a:headEnd type="none" w="med" len="med"/>
+                      <a:tailEnd type="none" w="med" len="med"/>
+                    </a:lnL>
+                    <a:lnR w="12700" cap="flat" cmpd="sng" algn="ctr">
+                      <a:solidFill>
+                        <a:srgbClr val="E1E5E8"/>
+                      </a:solidFill>
+                      <a:prstDash val="solid"/>
+                      <a:round/>
+                      <a:headEnd type="none" w="med" len="med"/>
+                      <a:tailEnd type="none" w="med" len="med"/>
+                    </a:lnR>
+                    <a:lnT w="12700" cap="flat" cmpd="sng" algn="ctr">
+                      <a:solidFill>
+                        <a:srgbClr val="E1E5E8"/>
+                      </a:solidFill>
+                      <a:prstDash val="solid"/>
+                      <a:round/>
+                      <a:headEnd type="none" w="med" len="med"/>
+                      <a:tailEnd type="none" w="med" len="med"/>
+                    </a:lnT>
+                    <a:lnB w="12700" cap="flat" cmpd="sng" algn="ctr">
+                      <a:solidFill>
+                        <a:srgbClr val="E1E5E8"/>
+                      </a:solidFill>
+                      <a:prstDash val="solid"/>
+                      <a:round/>
+                      <a:headEnd type="none" w="med" len="med"/>
+                      <a:tailEnd type="none" w="med" len="med"/>
+                    </a:lnB>
+                    <a:solidFill>
+                      <a:srgbClr val="0D1B2A"/>
+                    </a:solidFill>
+                  </a:tcPr>
+                </a:tc>
+              </a:tr>
+              <a:tr h="420624">
+                <a:tc>
+                  <a:txBody>
+                    <a:bodyPr/>
+                    <a:lstStyle/>
+                    <a:p>
+                      <a:pPr indent="0" marL="0">
+                        <a:buNone/>
+                      </a:pPr>
+                      <a:r>
+                        <a:rPr lang="en-US" sz="1300" dirty="0">
+                          <a:solidFill>
+                            <a:srgbClr val="1A1C1C"/>
+                          </a:solidFill>
+                          <a:latin typeface="Calibri" pitchFamily="34" charset="0"/>
+                          <a:ea typeface="Calibri" pitchFamily="34" charset="-122"/>
+                          <a:cs typeface="Calibri" pitchFamily="34" charset="-120"/>
+                        </a:rPr>
+                        <a:t>n_clusters (k)</a:t>
+                      </a:r>
+                      <a:endParaRPr lang="en-US" sz="1300" dirty="0">
+                        <a:latin typeface="Calibri" charset="0"/>
+                        <a:ea typeface="Calibri" charset="0"/>
+                        <a:cs typeface="Calibri" charset="0"/>
+                      </a:endParaRPr>
+                    </a:p>
+                  </a:txBody>
+                  <a:tcPr marL="91440" marR="91440" marT="45720" marB="45720" anchor="ctr">
+                    <a:lnL w="12700" cap="flat" cmpd="sng" algn="ctr">
+                      <a:solidFill>
+                        <a:srgbClr val="E1E5E8"/>
+                      </a:solidFill>
+                      <a:prstDash val="solid"/>
+                      <a:round/>
+                      <a:headEnd type="none" w="med" len="med"/>
+                      <a:tailEnd type="none" w="med" len="med"/>
+                    </a:lnL>
+                    <a:lnR w="12700" cap="flat" cmpd="sng" algn="ctr">
+                      <a:solidFill>
+                        <a:srgbClr val="E1E5E8"/>
+                      </a:solidFill>
+                      <a:prstDash val="solid"/>
+                      <a:round/>
+                      <a:headEnd type="none" w="med" len="med"/>
+                      <a:tailEnd type="none" w="med" len="med"/>
+                    </a:lnR>
+                    <a:lnT w="12700" cap="flat" cmpd="sng" algn="ctr">
+                      <a:solidFill>
+                        <a:srgbClr val="E1E5E8"/>
+                      </a:solidFill>
+                      <a:prstDash val="solid"/>
+                      <a:round/>
+                      <a:headEnd type="none" w="med" len="med"/>
+                      <a:tailEnd type="none" w="med" len="med"/>
+                    </a:lnT>
+                    <a:lnB w="12700" cap="flat" cmpd="sng" algn="ctr">
+                      <a:solidFill>
+                        <a:srgbClr val="E1E5E8"/>
+                      </a:solidFill>
+                      <a:prstDash val="solid"/>
+                      <a:round/>
+                      <a:headEnd type="none" w="med" len="med"/>
+                      <a:tailEnd type="none" w="med" len="med"/>
+                    </a:lnB>
+                    <a:solidFill>
+                      <a:srgbClr val="FFFFFF"/>
+                    </a:solidFill>
+                  </a:tcPr>
+                </a:tc>
+                <a:tc>
+                  <a:txBody>
+                    <a:bodyPr/>
+                    <a:lstStyle/>
+                    <a:p>
+                      <a:pPr indent="0" marL="0">
+                        <a:buNone/>
+                      </a:pPr>
+                      <a:r>
+                        <a:rPr lang="en-US" sz="1300" dirty="0">
+                          <a:solidFill>
+                            <a:srgbClr val="1A1C1C"/>
+                          </a:solidFill>
+                          <a:latin typeface="Calibri" pitchFamily="34" charset="0"/>
+                          <a:ea typeface="Calibri" pitchFamily="34" charset="-122"/>
+                          <a:cs typeface="Calibri" pitchFamily="34" charset="-120"/>
+                        </a:rPr>
+                        <a:t>3, 4, 5, 6, 7, 8</a:t>
+                      </a:r>
+                      <a:endParaRPr lang="en-US" sz="1300" dirty="0">
+                        <a:latin typeface="Calibri" charset="0"/>
+                        <a:ea typeface="Calibri" charset="0"/>
+                        <a:cs typeface="Calibri" charset="0"/>
+                      </a:endParaRPr>
+                    </a:p>
+                  </a:txBody>
+                  <a:tcPr marL="91440" marR="91440" marT="45720" marB="45720" anchor="ctr">
+                    <a:lnL w="12700" cap="flat" cmpd="sng" algn="ctr">
+                      <a:solidFill>
+                        <a:srgbClr val="E1E5E8"/>
+                      </a:solidFill>
+                      <a:prstDash val="solid"/>
+                      <a:round/>
+                      <a:headEnd type="none" w="med" len="med"/>
+                      <a:tailEnd type="none" w="med" len="med"/>
+                    </a:lnL>
+                    <a:lnR w="12700" cap="flat" cmpd="sng" algn="ctr">
+                      <a:solidFill>
+                        <a:srgbClr val="E1E5E8"/>
+                      </a:solidFill>
+                      <a:prstDash val="solid"/>
+                      <a:round/>
+                      <a:headEnd type="none" w="med" len="med"/>
+                      <a:tailEnd type="none" w="med" len="med"/>
+                    </a:lnR>
+                    <a:lnT w="12700" cap="flat" cmpd="sng" algn="ctr">
+                      <a:solidFill>
+                        <a:srgbClr val="E1E5E8"/>
+                      </a:solidFill>
+                      <a:prstDash val="solid"/>
+                      <a:round/>
+                      <a:headEnd type="none" w="med" len="med"/>
+                      <a:tailEnd type="none" w="med" len="med"/>
+                    </a:lnT>
+                    <a:lnB w="12700" cap="flat" cmpd="sng" algn="ctr">
+                      <a:solidFill>
+                        <a:srgbClr val="E1E5E8"/>
+                      </a:solidFill>
+                      <a:prstDash val="solid"/>
+                      <a:round/>
+                      <a:headEnd type="none" w="med" len="med"/>
+                      <a:tailEnd type="none" w="med" len="med"/>
+                    </a:lnB>
+                    <a:solidFill>
+                      <a:srgbClr val="FFFFFF"/>
+                    </a:solidFill>
+                  </a:tcPr>
+                </a:tc>
+                <a:tc>
+                  <a:txBody>
+                    <a:bodyPr/>
+                    <a:lstStyle/>
+                    <a:p>
+                      <a:pPr indent="0" marL="0">
+                        <a:buNone/>
+                      </a:pPr>
+                      <a:r>
+                        <a:rPr lang="en-US" sz="1300" dirty="0">
+                          <a:solidFill>
+                            <a:srgbClr val="1A1C1C"/>
+                          </a:solidFill>
+                          <a:latin typeface="Calibri" pitchFamily="34" charset="0"/>
+                          <a:ea typeface="Calibri" pitchFamily="34" charset="-122"/>
+                          <a:cs typeface="Calibri" pitchFamily="34" charset="-120"/>
+                        </a:rPr>
+                        <a:t>3</a:t>
+                      </a:r>
+                      <a:endParaRPr lang="en-US" sz="1300" dirty="0">
+                        <a:latin typeface="Calibri" charset="0"/>
+                        <a:ea typeface="Calibri" charset="0"/>
+                        <a:cs typeface="Calibri" charset="0"/>
+                      </a:endParaRPr>
+                    </a:p>
+                  </a:txBody>
+                  <a:tcPr marL="91440" marR="91440" marT="45720" marB="45720" anchor="ctr">
+                    <a:lnL w="12700" cap="flat" cmpd="sng" algn="ctr">
+                      <a:solidFill>
+                        <a:srgbClr val="E1E5E8"/>
+                      </a:solidFill>
+                      <a:prstDash val="solid"/>
+                      <a:round/>
+                      <a:headEnd type="none" w="med" len="med"/>
+                      <a:tailEnd type="none" w="med" len="med"/>
+                    </a:lnL>
+                    <a:lnR w="12700" cap="flat" cmpd="sng" algn="ctr">
+                      <a:solidFill>
+                        <a:srgbClr val="E1E5E8"/>
+                      </a:solidFill>
+                      <a:prstDash val="solid"/>
+                      <a:round/>
+                      <a:headEnd type="none" w="med" len="med"/>
+                      <a:tailEnd type="none" w="med" len="med"/>
+                    </a:lnR>
+                    <a:lnT w="12700" cap="flat" cmpd="sng" algn="ctr">
+                      <a:solidFill>
+                        <a:srgbClr val="E1E5E8"/>
+                      </a:solidFill>
+                      <a:prstDash val="solid"/>
+                      <a:round/>
+                      <a:headEnd type="none" w="med" len="med"/>
+                      <a:tailEnd type="none" w="med" len="med"/>
+                    </a:lnT>
+                    <a:lnB w="12700" cap="flat" cmpd="sng" algn="ctr">
+                      <a:solidFill>
+                        <a:srgbClr val="E1E5E8"/>
+                      </a:solidFill>
+                      <a:prstDash val="solid"/>
+                      <a:round/>
+                      <a:headEnd type="none" w="med" len="med"/>
+                      <a:tailEnd type="none" w="med" len="med"/>
+                    </a:lnB>
+                    <a:solidFill>
+                      <a:srgbClr val="FFFFFF"/>
+                    </a:solidFill>
+                  </a:tcPr>
+                </a:tc>
+              </a:tr>
+              <a:tr h="420624">
+                <a:tc>
+                  <a:txBody>
+                    <a:bodyPr/>
+                    <a:lstStyle/>
+                    <a:p>
+                      <a:pPr indent="0" marL="0">
+                        <a:buNone/>
+                      </a:pPr>
+                      <a:r>
+                        <a:rPr lang="en-US" sz="1300" dirty="0">
+                          <a:solidFill>
+                            <a:srgbClr val="1A1C1C"/>
+                          </a:solidFill>
+                          <a:latin typeface="Calibri" pitchFamily="34" charset="0"/>
+                          <a:ea typeface="Calibri" pitchFamily="34" charset="-122"/>
+                          <a:cs typeface="Calibri" pitchFamily="34" charset="-120"/>
+                        </a:rPr>
+                        <a:t>init</a:t>
+                      </a:r>
+                      <a:endParaRPr lang="en-US" sz="1300" dirty="0">
+                        <a:latin typeface="Calibri" charset="0"/>
+                        <a:ea typeface="Calibri" charset="0"/>
+                        <a:cs typeface="Calibri" charset="0"/>
+                      </a:endParaRPr>
+                    </a:p>
+                  </a:txBody>
+                  <a:tcPr marL="91440" marR="91440" marT="45720" marB="45720" anchor="ctr">
+                    <a:lnL w="12700" cap="flat" cmpd="sng" algn="ctr">
+                      <a:solidFill>
+                        <a:srgbClr val="E1E5E8"/>
+                      </a:solidFill>
+                      <a:prstDash val="solid"/>
+                      <a:round/>
+                      <a:headEnd type="none" w="med" len="med"/>
+                      <a:tailEnd type="none" w="med" len="med"/>
+                    </a:lnL>
+                    <a:lnR w="12700" cap="flat" cmpd="sng" algn="ctr">
+                      <a:solidFill>
+                        <a:srgbClr val="E1E5E8"/>
+                      </a:solidFill>
+                      <a:prstDash val="solid"/>
+                      <a:round/>
+                      <a:headEnd type="none" w="med" len="med"/>
+                      <a:tailEnd type="none" w="med" len="med"/>
+                    </a:lnR>
+                    <a:lnT w="12700" cap="flat" cmpd="sng" algn="ctr">
+                      <a:solidFill>
+                        <a:srgbClr val="E1E5E8"/>
+                      </a:solidFill>
+                      <a:prstDash val="solid"/>
+                      <a:round/>
+                      <a:headEnd type="none" w="med" len="med"/>
+                      <a:tailEnd type="none" w="med" len="med"/>
+                    </a:lnT>
+                    <a:lnB w="12700" cap="flat" cmpd="sng" algn="ctr">
+                      <a:solidFill>
+                        <a:srgbClr val="E1E5E8"/>
+                      </a:solidFill>
+                      <a:prstDash val="solid"/>
+                      <a:round/>
+                      <a:headEnd type="none" w="med" len="med"/>
+                      <a:tailEnd type="none" w="med" len="med"/>
+                    </a:lnB>
+                    <a:solidFill>
+                      <a:srgbClr val="FFFFFF"/>
+                    </a:solidFill>
+                  </a:tcPr>
+                </a:tc>
+                <a:tc>
+                  <a:txBody>
+                    <a:bodyPr/>
+                    <a:lstStyle/>
+                    <a:p>
+                      <a:pPr indent="0" marL="0">
+                        <a:buNone/>
+                      </a:pPr>
+                      <a:r>
+                        <a:rPr lang="en-US" sz="1300" dirty="0">
+                          <a:solidFill>
+                            <a:srgbClr val="1A1C1C"/>
+                          </a:solidFill>
+                          <a:latin typeface="Calibri" pitchFamily="34" charset="0"/>
+                          <a:ea typeface="Calibri" pitchFamily="34" charset="-122"/>
+                          <a:cs typeface="Calibri" pitchFamily="34" charset="-120"/>
+                        </a:rPr>
+                        <a:t>k-means++, random</a:t>
+                      </a:r>
+                      <a:endParaRPr lang="en-US" sz="1300" dirty="0">
+                        <a:latin typeface="Calibri" charset="0"/>
+                        <a:ea typeface="Calibri" charset="0"/>
+                        <a:cs typeface="Calibri" charset="0"/>
+                      </a:endParaRPr>
+                    </a:p>
+                  </a:txBody>
+                  <a:tcPr marL="91440" marR="91440" marT="45720" marB="45720" anchor="ctr">
+                    <a:lnL w="12700" cap="flat" cmpd="sng" algn="ctr">
+                      <a:solidFill>
+                        <a:srgbClr val="E1E5E8"/>
+                      </a:solidFill>
+                      <a:prstDash val="solid"/>
+                      <a:round/>
+                      <a:headEnd type="none" w="med" len="med"/>
+                      <a:tailEnd type="none" w="med" len="med"/>
+                    </a:lnL>
+                    <a:lnR w="12700" cap="flat" cmpd="sng" algn="ctr">
+                      <a:solidFill>
+                        <a:srgbClr val="E1E5E8"/>
+                      </a:solidFill>
+                      <a:prstDash val="solid"/>
+                      <a:round/>
+                      <a:headEnd type="none" w="med" len="med"/>
+                      <a:tailEnd type="none" w="med" len="med"/>
+                    </a:lnR>
+                    <a:lnT w="12700" cap="flat" cmpd="sng" algn="ctr">
+                      <a:solidFill>
+                        <a:srgbClr val="E1E5E8"/>
+                      </a:solidFill>
+                      <a:prstDash val="solid"/>
+                      <a:round/>
+                      <a:headEnd type="none" w="med" len="med"/>
+                      <a:tailEnd type="none" w="med" len="med"/>
+                    </a:lnT>
+                    <a:lnB w="12700" cap="flat" cmpd="sng" algn="ctr">
+                      <a:solidFill>
+                        <a:srgbClr val="E1E5E8"/>
+                      </a:solidFill>
+                      <a:prstDash val="solid"/>
+                      <a:round/>
+                      <a:headEnd type="none" w="med" len="med"/>
+                      <a:tailEnd type="none" w="med" len="med"/>
+                    </a:lnB>
+                    <a:solidFill>
+                      <a:srgbClr val="FFFFFF"/>
+                    </a:solidFill>
+                  </a:tcPr>
+                </a:tc>
+                <a:tc>
+                  <a:txBody>
+                    <a:bodyPr/>
+                    <a:lstStyle/>
+                    <a:p>
+                      <a:pPr indent="0" marL="0">
+                        <a:buNone/>
+                      </a:pPr>
+                      <a:r>
+                        <a:rPr lang="en-US" sz="1300" dirty="0">
+                          <a:solidFill>
+                            <a:srgbClr val="1A1C1C"/>
+                          </a:solidFill>
+                          <a:latin typeface="Calibri" pitchFamily="34" charset="0"/>
+                          <a:ea typeface="Calibri" pitchFamily="34" charset="-122"/>
+                          <a:cs typeface="Calibri" pitchFamily="34" charset="-120"/>
+                        </a:rPr>
+                        <a:t>random</a:t>
+                      </a:r>
+                      <a:endParaRPr lang="en-US" sz="1300" dirty="0">
+                        <a:latin typeface="Calibri" charset="0"/>
+                        <a:ea typeface="Calibri" charset="0"/>
+                        <a:cs typeface="Calibri" charset="0"/>
+                      </a:endParaRPr>
+                    </a:p>
+                  </a:txBody>
+                  <a:tcPr marL="91440" marR="91440" marT="45720" marB="45720" anchor="ctr">
+                    <a:lnL w="12700" cap="flat" cmpd="sng" algn="ctr">
+                      <a:solidFill>
+                        <a:srgbClr val="E1E5E8"/>
+                      </a:solidFill>
+                      <a:prstDash val="solid"/>
+                      <a:round/>
+                      <a:headEnd type="none" w="med" len="med"/>
+                      <a:tailEnd type="none" w="med" len="med"/>
+                    </a:lnL>
+                    <a:lnR w="12700" cap="flat" cmpd="sng" algn="ctr">
+                      <a:solidFill>
+                        <a:srgbClr val="E1E5E8"/>
+                      </a:solidFill>
+                      <a:prstDash val="solid"/>
+                      <a:round/>
+                      <a:headEnd type="none" w="med" len="med"/>
+                      <a:tailEnd type="none" w="med" len="med"/>
+                    </a:lnR>
+                    <a:lnT w="12700" cap="flat" cmpd="sng" algn="ctr">
+                      <a:solidFill>
+                        <a:srgbClr val="E1E5E8"/>
+                      </a:solidFill>
+                      <a:prstDash val="solid"/>
+                      <a:round/>
+                      <a:headEnd type="none" w="med" len="med"/>
+                      <a:tailEnd type="none" w="med" len="med"/>
+                    </a:lnT>
+                    <a:lnB w="12700" cap="flat" cmpd="sng" algn="ctr">
+                      <a:solidFill>
+                        <a:srgbClr val="E1E5E8"/>
+                      </a:solidFill>
+                      <a:prstDash val="solid"/>
+                      <a:round/>
+                      <a:headEnd type="none" w="med" len="med"/>
+                      <a:tailEnd type="none" w="med" len="med"/>
+                    </a:lnB>
+                    <a:solidFill>
+                      <a:srgbClr val="FFFFFF"/>
+                    </a:solidFill>
+                  </a:tcPr>
+                </a:tc>
+              </a:tr>
+              <a:tr h="420624">
+                <a:tc>
+                  <a:txBody>
+                    <a:bodyPr/>
+                    <a:lstStyle/>
+                    <a:p>
+                      <a:pPr indent="0" marL="0">
+                        <a:buNone/>
+                      </a:pPr>
+                      <a:r>
+                        <a:rPr lang="en-US" sz="1300" dirty="0">
+                          <a:solidFill>
+                            <a:srgbClr val="1A1C1C"/>
+                          </a:solidFill>
+                          <a:latin typeface="Calibri" pitchFamily="34" charset="0"/>
+                          <a:ea typeface="Calibri" pitchFamily="34" charset="-122"/>
+                          <a:cs typeface="Calibri" pitchFamily="34" charset="-120"/>
+                        </a:rPr>
+                        <a:t>n_init</a:t>
+                      </a:r>
+                      <a:endParaRPr lang="en-US" sz="1300" dirty="0">
+                        <a:latin typeface="Calibri" charset="0"/>
+                        <a:ea typeface="Calibri" charset="0"/>
+                        <a:cs typeface="Calibri" charset="0"/>
+                      </a:endParaRPr>
+                    </a:p>
+                  </a:txBody>
+                  <a:tcPr marL="91440" marR="91440" marT="45720" marB="45720" anchor="ctr">
+                    <a:lnL w="12700" cap="flat" cmpd="sng" algn="ctr">
+                      <a:solidFill>
+                        <a:srgbClr val="E1E5E8"/>
+                      </a:solidFill>
+                      <a:prstDash val="solid"/>
+                      <a:round/>
+                      <a:headEnd type="none" w="med" len="med"/>
+                      <a:tailEnd type="none" w="med" len="med"/>
+                    </a:lnL>
+                    <a:lnR w="12700" cap="flat" cmpd="sng" algn="ctr">
+                      <a:solidFill>
+                        <a:srgbClr val="E1E5E8"/>
+                      </a:solidFill>
+                      <a:prstDash val="solid"/>
+                      <a:round/>
+                      <a:headEnd type="none" w="med" len="med"/>
+                      <a:tailEnd type="none" w="med" len="med"/>
+                    </a:lnR>
+                    <a:lnT w="12700" cap="flat" cmpd="sng" algn="ctr">
+                      <a:solidFill>
+                        <a:srgbClr val="E1E5E8"/>
+                      </a:solidFill>
+                      <a:prstDash val="solid"/>
+                      <a:round/>
+                      <a:headEnd type="none" w="med" len="med"/>
+                      <a:tailEnd type="none" w="med" len="med"/>
+                    </a:lnT>
+                    <a:lnB w="12700" cap="flat" cmpd="sng" algn="ctr">
+                      <a:solidFill>
+                        <a:srgbClr val="E1E5E8"/>
+                      </a:solidFill>
+                      <a:prstDash val="solid"/>
+                      <a:round/>
+                      <a:headEnd type="none" w="med" len="med"/>
+                      <a:tailEnd type="none" w="med" len="med"/>
+                    </a:lnB>
+                    <a:solidFill>
+                      <a:srgbClr val="FFFFFF"/>
+                    </a:solidFill>
+                  </a:tcPr>
+                </a:tc>
+                <a:tc>
+                  <a:txBody>
+                    <a:bodyPr/>
+                    <a:lstStyle/>
+                    <a:p>
+                      <a:pPr indent="0" marL="0">
+                        <a:buNone/>
+                      </a:pPr>
+                      <a:r>
+                        <a:rPr lang="en-US" sz="1300" dirty="0">
+                          <a:solidFill>
+                            <a:srgbClr val="1A1C1C"/>
+                          </a:solidFill>
+                          <a:latin typeface="Calibri" pitchFamily="34" charset="0"/>
+                          <a:ea typeface="Calibri" pitchFamily="34" charset="-122"/>
+                          <a:cs typeface="Calibri" pitchFamily="34" charset="-120"/>
+                        </a:rPr>
+                        <a:t>10, 25</a:t>
+                      </a:r>
+                      <a:endParaRPr lang="en-US" sz="1300" dirty="0">
+                        <a:latin typeface="Calibri" charset="0"/>
+                        <a:ea typeface="Calibri" charset="0"/>
+                        <a:cs typeface="Calibri" charset="0"/>
+                      </a:endParaRPr>
+                    </a:p>
+                  </a:txBody>
+                  <a:tcPr marL="91440" marR="91440" marT="45720" marB="45720" anchor="ctr">
+                    <a:lnL w="12700" cap="flat" cmpd="sng" algn="ctr">
+                      <a:solidFill>
+                        <a:srgbClr val="E1E5E8"/>
+                      </a:solidFill>
+                      <a:prstDash val="solid"/>
+                      <a:round/>
+                      <a:headEnd type="none" w="med" len="med"/>
+                      <a:tailEnd type="none" w="med" len="med"/>
+                    </a:lnL>
+                    <a:lnR w="12700" cap="flat" cmpd="sng" algn="ctr">
+                      <a:solidFill>
+                        <a:srgbClr val="E1E5E8"/>
+                      </a:solidFill>
+                      <a:prstDash val="solid"/>
+                      <a:round/>
+                      <a:headEnd type="none" w="med" len="med"/>
+                      <a:tailEnd type="none" w="med" len="med"/>
+                    </a:lnR>
+                    <a:lnT w="12700" cap="flat" cmpd="sng" algn="ctr">
+                      <a:solidFill>
+                        <a:srgbClr val="E1E5E8"/>
+                      </a:solidFill>
+                      <a:prstDash val="solid"/>
+                      <a:round/>
+                      <a:headEnd type="none" w="med" len="med"/>
+                      <a:tailEnd type="none" w="med" len="med"/>
+                    </a:lnT>
+                    <a:lnB w="12700" cap="flat" cmpd="sng" algn="ctr">
+                      <a:solidFill>
+                        <a:srgbClr val="E1E5E8"/>
+                      </a:solidFill>
+                      <a:prstDash val="solid"/>
+                      <a:round/>
+                      <a:headEnd type="none" w="med" len="med"/>
+                      <a:tailEnd type="none" w="med" len="med"/>
+                    </a:lnB>
+                    <a:solidFill>
+                      <a:srgbClr val="FFFFFF"/>
+                    </a:solidFill>
+                  </a:tcPr>
+                </a:tc>
+                <a:tc>
+                  <a:txBody>
+                    <a:bodyPr/>
+                    <a:lstStyle/>
+                    <a:p>
+                      <a:pPr indent="0" marL="0">
+                        <a:buNone/>
+                      </a:pPr>
+                      <a:r>
+                        <a:rPr lang="en-US" sz="1300" dirty="0">
+                          <a:solidFill>
+                            <a:srgbClr val="1A1C1C"/>
+                          </a:solidFill>
+                          <a:latin typeface="Calibri" pitchFamily="34" charset="0"/>
+                          <a:ea typeface="Calibri" pitchFamily="34" charset="-122"/>
+                          <a:cs typeface="Calibri" pitchFamily="34" charset="-120"/>
+                        </a:rPr>
+                        <a:t>10</a:t>
+                      </a:r>
+                      <a:endParaRPr lang="en-US" sz="1300" dirty="0">
+                        <a:latin typeface="Calibri" charset="0"/>
+                        <a:ea typeface="Calibri" charset="0"/>
+                        <a:cs typeface="Calibri" charset="0"/>
+                      </a:endParaRPr>
+                    </a:p>
+                  </a:txBody>
+                  <a:tcPr marL="91440" marR="91440" marT="45720" marB="45720" anchor="ctr">
+                    <a:lnL w="12700" cap="flat" cmpd="sng" algn="ctr">
+                      <a:solidFill>
+                        <a:srgbClr val="E1E5E8"/>
+                      </a:solidFill>
+                      <a:prstDash val="solid"/>
+                      <a:round/>
+                      <a:headEnd type="none" w="med" len="med"/>
+                      <a:tailEnd type="none" w="med" len="med"/>
+                    </a:lnL>
+                    <a:lnR w="12700" cap="flat" cmpd="sng" algn="ctr">
+                      <a:solidFill>
+                        <a:srgbClr val="E1E5E8"/>
+                      </a:solidFill>
+                      <a:prstDash val="solid"/>
+                      <a:round/>
+                      <a:headEnd type="none" w="med" len="med"/>
+                      <a:tailEnd type="none" w="med" len="med"/>
+                    </a:lnR>
+                    <a:lnT w="12700" cap="flat" cmpd="sng" algn="ctr">
+                      <a:solidFill>
+                        <a:srgbClr val="E1E5E8"/>
+                      </a:solidFill>
+                      <a:prstDash val="solid"/>
+                      <a:round/>
+                      <a:headEnd type="none" w="med" len="med"/>
+                      <a:tailEnd type="none" w="med" len="med"/>
+                    </a:lnT>
+                    <a:lnB w="12700" cap="flat" cmpd="sng" algn="ctr">
+                      <a:solidFill>
+                        <a:srgbClr val="E1E5E8"/>
+                      </a:solidFill>
+                      <a:prstDash val="solid"/>
+                      <a:round/>
+                      <a:headEnd type="none" w="med" len="med"/>
+                      <a:tailEnd type="none" w="med" len="med"/>
+                    </a:lnB>
+                    <a:solidFill>
+                      <a:srgbClr val="FFFFFF"/>
+                    </a:solidFill>
+                  </a:tcPr>
+                </a:tc>
+              </a:tr>
+              <a:tr h="420624">
+                <a:tc>
+                  <a:txBody>
+                    <a:bodyPr/>
+                    <a:lstStyle/>
+                    <a:p>
+                      <a:pPr indent="0" marL="0">
+                        <a:buNone/>
+                      </a:pPr>
+                      <a:r>
+                        <a:rPr lang="en-US" sz="1300" dirty="0">
+                          <a:solidFill>
+                            <a:srgbClr val="1A1C1C"/>
+                          </a:solidFill>
+                          <a:latin typeface="Calibri" pitchFamily="34" charset="0"/>
+                          <a:ea typeface="Calibri" pitchFamily="34" charset="-122"/>
+                          <a:cs typeface="Calibri" pitchFamily="34" charset="-120"/>
+                        </a:rPr>
+                        <a:t>escalado</a:t>
+                      </a:r>
+                      <a:endParaRPr lang="en-US" sz="1300" dirty="0">
+                        <a:latin typeface="Calibri" charset="0"/>
+                        <a:ea typeface="Calibri" charset="0"/>
+                        <a:cs typeface="Calibri" charset="0"/>
+                      </a:endParaRPr>
+                    </a:p>
+                  </a:txBody>
+                  <a:tcPr marL="91440" marR="91440" marT="45720" marB="45720" anchor="ctr">
+                    <a:lnL w="12700" cap="flat" cmpd="sng" algn="ctr">
+                      <a:solidFill>
+                        <a:srgbClr val="E1E5E8"/>
+                      </a:solidFill>
+                      <a:prstDash val="solid"/>
+                      <a:round/>
+                      <a:headEnd type="none" w="med" len="med"/>
+                      <a:tailEnd type="none" w="med" len="med"/>
+                    </a:lnL>
+                    <a:lnR w="12700" cap="flat" cmpd="sng" algn="ctr">
+                      <a:solidFill>
+                        <a:srgbClr val="E1E5E8"/>
+                      </a:solidFill>
+                      <a:prstDash val="solid"/>
+                      <a:round/>
+                      <a:headEnd type="none" w="med" len="med"/>
+                      <a:tailEnd type="none" w="med" len="med"/>
+                    </a:lnR>
+                    <a:lnT w="12700" cap="flat" cmpd="sng" algn="ctr">
+                      <a:solidFill>
+                        <a:srgbClr val="E1E5E8"/>
+                      </a:solidFill>
+                      <a:prstDash val="solid"/>
+                      <a:round/>
+                      <a:headEnd type="none" w="med" len="med"/>
+                      <a:tailEnd type="none" w="med" len="med"/>
+                    </a:lnT>
+                    <a:lnB w="12700" cap="flat" cmpd="sng" algn="ctr">
+                      <a:solidFill>
+                        <a:srgbClr val="E1E5E8"/>
+                      </a:solidFill>
+                      <a:prstDash val="solid"/>
+                      <a:round/>
+                      <a:headEnd type="none" w="med" len="med"/>
+                      <a:tailEnd type="none" w="med" len="med"/>
+                    </a:lnB>
+                    <a:solidFill>
+                      <a:srgbClr val="FFFFFF"/>
+                    </a:solidFill>
+                  </a:tcPr>
+                </a:tc>
+                <a:tc>
+                  <a:txBody>
+                    <a:bodyPr/>
+                    <a:lstStyle/>
+                    <a:p>
+                      <a:pPr indent="0" marL="0">
+                        <a:buNone/>
+                      </a:pPr>
+                      <a:r>
+                        <a:rPr lang="en-US" sz="1300" dirty="0">
+                          <a:solidFill>
+                            <a:srgbClr val="1A1C1C"/>
+                          </a:solidFill>
+                          <a:latin typeface="Calibri" pitchFamily="34" charset="0"/>
+                          <a:ea typeface="Calibri" pitchFamily="34" charset="-122"/>
+                          <a:cs typeface="Calibri" pitchFamily="34" charset="-120"/>
+                        </a:rPr>
+                        <a:t>StandardScaler</a:t>
+                      </a:r>
+                      <a:endParaRPr lang="en-US" sz="1300" dirty="0">
+                        <a:latin typeface="Calibri" charset="0"/>
+                        <a:ea typeface="Calibri" charset="0"/>
+                        <a:cs typeface="Calibri" charset="0"/>
+                      </a:endParaRPr>
+                    </a:p>
+                  </a:txBody>
+                  <a:tcPr marL="91440" marR="91440" marT="45720" marB="45720" anchor="ctr">
+                    <a:lnL w="12700" cap="flat" cmpd="sng" algn="ctr">
+                      <a:solidFill>
+                        <a:srgbClr val="E1E5E8"/>
+                      </a:solidFill>
+                      <a:prstDash val="solid"/>
+                      <a:round/>
+                      <a:headEnd type="none" w="med" len="med"/>
+                      <a:tailEnd type="none" w="med" len="med"/>
+                    </a:lnL>
+                    <a:lnR w="12700" cap="flat" cmpd="sng" algn="ctr">
+                      <a:solidFill>
+                        <a:srgbClr val="E1E5E8"/>
+                      </a:solidFill>
+                      <a:prstDash val="solid"/>
+                      <a:round/>
+                      <a:headEnd type="none" w="med" len="med"/>
+                      <a:tailEnd type="none" w="med" len="med"/>
+                    </a:lnR>
+                    <a:lnT w="12700" cap="flat" cmpd="sng" algn="ctr">
+                      <a:solidFill>
+                        <a:srgbClr val="E1E5E8"/>
+                      </a:solidFill>
+                      <a:prstDash val="solid"/>
+                      <a:round/>
+                      <a:headEnd type="none" w="med" len="med"/>
+                      <a:tailEnd type="none" w="med" len="med"/>
+                    </a:lnT>
+                    <a:lnB w="12700" cap="flat" cmpd="sng" algn="ctr">
+                      <a:solidFill>
+                        <a:srgbClr val="E1E5E8"/>
+                      </a:solidFill>
+                      <a:prstDash val="solid"/>
+                      <a:round/>
+                      <a:headEnd type="none" w="med" len="med"/>
+                      <a:tailEnd type="none" w="med" len="med"/>
+                    </a:lnB>
+                    <a:solidFill>
+                      <a:srgbClr val="FFFFFF"/>
+                    </a:solidFill>
+                  </a:tcPr>
+                </a:tc>
+                <a:tc>
+                  <a:txBody>
+                    <a:bodyPr/>
+                    <a:lstStyle/>
+                    <a:p>
+                      <a:pPr indent="0" marL="0">
+                        <a:buNone/>
+                      </a:pPr>
+                      <a:r>
+                        <a:rPr lang="en-US" sz="1300" dirty="0">
+                          <a:solidFill>
+                            <a:srgbClr val="1A1C1C"/>
+                          </a:solidFill>
+                          <a:latin typeface="Calibri" pitchFamily="34" charset="0"/>
+                          <a:ea typeface="Calibri" pitchFamily="34" charset="-122"/>
+                          <a:cs typeface="Calibri" pitchFamily="34" charset="-120"/>
+                        </a:rPr>
+                        <a:t>si</a:t>
+                      </a:r>
+                      <a:endParaRPr lang="en-US" sz="1300" dirty="0">
+                        <a:latin typeface="Calibri" charset="0"/>
+                        <a:ea typeface="Calibri" charset="0"/>
+                        <a:cs typeface="Calibri" charset="0"/>
+                      </a:endParaRPr>
+                    </a:p>
+                  </a:txBody>
+                  <a:tcPr marL="91440" marR="91440" marT="45720" marB="45720" anchor="ctr">
+                    <a:lnL w="12700" cap="flat" cmpd="sng" algn="ctr">
+                      <a:solidFill>
+                        <a:srgbClr val="E1E5E8"/>
+                      </a:solidFill>
+                      <a:prstDash val="solid"/>
+                      <a:round/>
+                      <a:headEnd type="none" w="med" len="med"/>
+                      <a:tailEnd type="none" w="med" len="med"/>
+                    </a:lnL>
+                    <a:lnR w="12700" cap="flat" cmpd="sng" algn="ctr">
+                      <a:solidFill>
+                        <a:srgbClr val="E1E5E8"/>
+                      </a:solidFill>
+                      <a:prstDash val="solid"/>
+                      <a:round/>
+                      <a:headEnd type="none" w="med" len="med"/>
+                      <a:tailEnd type="none" w="med" len="med"/>
+                    </a:lnR>
+                    <a:lnT w="12700" cap="flat" cmpd="sng" algn="ctr">
+                      <a:solidFill>
+                        <a:srgbClr val="E1E5E8"/>
+                      </a:solidFill>
+                      <a:prstDash val="solid"/>
+                      <a:round/>
+                      <a:headEnd type="none" w="med" len="med"/>
+                      <a:tailEnd type="none" w="med" len="med"/>
+                    </a:lnT>
+                    <a:lnB w="12700" cap="flat" cmpd="sng" algn="ctr">
+                      <a:solidFill>
+                        <a:srgbClr val="E1E5E8"/>
+                      </a:solidFill>
+                      <a:prstDash val="solid"/>
+                      <a:round/>
+                      <a:headEnd type="none" w="med" len="med"/>
+                      <a:tailEnd type="none" w="med" len="med"/>
+                    </a:lnB>
+                    <a:solidFill>
+                      <a:srgbClr val="FFFFFF"/>
+                    </a:solidFill>
+                  </a:tcPr>
+                </a:tc>
+              </a:tr>
+            </a:tbl>
+          </a:graphicData>
+        </a:graphic>
+      </p:graphicFrame>
+      <p:sp>
+        <p:nvSpPr>
+          <p:cNvPr id="7" name="Shape 4"/>
+          <p:cNvSpPr/>
+          <p:nvPr/>
+        </p:nvSpPr>
+        <p:spPr>
+          <a:xfrm>
+            <a:off x="7955280" y="1737360"/>
+            <a:ext cx="3108960" cy="960120"/>
           </a:xfrm>
           <a:prstGeom prst="roundRect">
             <a:avLst>
-              <a:gd name="adj" fmla="val 5000"/>
+              <a:gd name="adj" fmla="val 5714"/>
             </a:avLst>
           </a:prstGeom>
           <a:solidFill>
-            <a:srgbClr val="FFFFFF"/>
+            <a:srgbClr val="0D1B2A"/>
           </a:solidFill>
-          <a:ln w="12700">
-            <a:solidFill>
-              <a:srgbClr val="E1E5E8"/>
-            </a:solidFill>
-            <a:prstDash val="solid"/>
-          </a:ln>
-        </p:spPr>
-      </p:sp>
-      <p:sp>
-        <p:nvSpPr>
-          <p:cNvPr id="7" name="Shape 5"/>
-          <p:cNvSpPr/>
-          <p:nvPr/>
-        </p:nvSpPr>
-        <p:spPr>
-          <a:xfrm>
-            <a:off x="1417320" y="2185416"/>
-            <a:ext cx="566928" cy="566928"/>
-          </a:xfrm>
-          <a:prstGeom prst="ellipse">
-            <a:avLst/>
-          </a:prstGeom>
-          <a:solidFill>
-            <a:srgbClr val="EE6C4D"/>
-          </a:solidFill>
-          <a:ln/>
-        </p:spPr>
-      </p:sp>
-      <p:sp>
-        <p:nvSpPr>
-          <p:cNvPr id="8" name="Text 6"/>
-          <p:cNvSpPr/>
-          <p:nvPr/>
-        </p:nvSpPr>
-        <p:spPr>
-          <a:xfrm>
-            <a:off x="1417320" y="2185416"/>
-            <a:ext cx="566928" cy="566928"/>
+          <a:ln/>
+        </p:spPr>
+      </p:sp>
+      <p:sp>
+        <p:nvSpPr>
+          <p:cNvPr id="8" name="Text 5"/>
+          <p:cNvSpPr/>
+          <p:nvPr/>
+        </p:nvSpPr>
+        <p:spPr>
+          <a:xfrm>
+            <a:off x="8092440" y="1847088"/>
+            <a:ext cx="1234440" cy="731520"/>
           </a:xfrm>
           <a:prstGeom prst="rect">
             <a:avLst/>
@@ -4935,7 +6060,46 @@
               <a:buNone/>
             </a:pPr>
             <a:r>
-              <a:rPr lang="en-US" sz="1600" b="1" dirty="0">
+              <a:rPr lang="en-US" sz="2400" b="1" dirty="0">
+                <a:solidFill>
+                  <a:srgbClr val="E0FBFC"/>
+                </a:solidFill>
+                <a:latin typeface="Georgia" pitchFamily="34" charset="0"/>
+                <a:ea typeface="Georgia" pitchFamily="34" charset="-122"/>
+                <a:cs typeface="Georgia" pitchFamily="34" charset="-120"/>
+              </a:rPr>
+              <a:t>0.419</a:t>
+            </a:r>
+            <a:endParaRPr lang="en-US" sz="2400" dirty="0"/>
+          </a:p>
+        </p:txBody>
+      </p:sp>
+      <p:sp>
+        <p:nvSpPr>
+          <p:cNvPr id="9" name="Text 6"/>
+          <p:cNvSpPr/>
+          <p:nvPr/>
+        </p:nvSpPr>
+        <p:spPr>
+          <a:xfrm>
+            <a:off x="9326880" y="1874520"/>
+            <a:ext cx="1600200" cy="320040"/>
+          </a:xfrm>
+          <a:prstGeom prst="rect">
+            <a:avLst/>
+          </a:prstGeom>
+          <a:noFill/>
+          <a:ln/>
+        </p:spPr>
+        <p:txBody>
+          <a:bodyPr wrap="square" rtlCol="0" anchor="ctr"/>
+          <a:lstStyle/>
+          <a:p>
+            <a:pPr indent="0" marL="0">
+              <a:buNone/>
+            </a:pPr>
+            <a:r>
+              <a:rPr lang="en-US" sz="1300" b="1" dirty="0">
                 <a:solidFill>
                   <a:srgbClr val="FFFFFF"/>
                 </a:solidFill>
@@ -4943,22 +6107,22 @@
                 <a:ea typeface="Calibri" pitchFamily="34" charset="-122"/>
                 <a:cs typeface="Calibri" pitchFamily="34" charset="-120"/>
               </a:rPr>
-              <a:t>1</a:t>
-            </a:r>
-            <a:endParaRPr lang="en-US" sz="1600" dirty="0"/>
-          </a:p>
-        </p:txBody>
-      </p:sp>
-      <p:sp>
-        <p:nvSpPr>
-          <p:cNvPr id="9" name="Text 7"/>
-          <p:cNvSpPr/>
-          <p:nvPr/>
-        </p:nvSpPr>
-        <p:spPr>
-          <a:xfrm>
-            <a:off x="2194560" y="2121408"/>
-            <a:ext cx="8549640" cy="384048"/>
+              <a:t>Silhouette</a:t>
+            </a:r>
+            <a:endParaRPr lang="en-US" sz="1300" dirty="0"/>
+          </a:p>
+        </p:txBody>
+      </p:sp>
+      <p:sp>
+        <p:nvSpPr>
+          <p:cNvPr id="10" name="Text 7"/>
+          <p:cNvSpPr/>
+          <p:nvPr/>
+        </p:nvSpPr>
+        <p:spPr>
+          <a:xfrm>
+            <a:off x="9326880" y="2194560"/>
+            <a:ext cx="1645920" cy="411480"/>
           </a:xfrm>
           <a:prstGeom prst="rect">
             <a:avLst/>
@@ -4974,116 +6138,52 @@
               <a:buNone/>
             </a:pPr>
             <a:r>
-              <a:rPr lang="en-US" sz="1800" b="1" dirty="0">
-                <a:solidFill>
-                  <a:srgbClr val="0D1B2A"/>
-                </a:solidFill>
-                <a:latin typeface="Calibri" pitchFamily="34" charset="0"/>
-                <a:ea typeface="Calibri" pitchFamily="34" charset="-122"/>
-                <a:cs typeface="Calibri" pitchFamily="34" charset="-120"/>
-              </a:rPr>
-              <a:t>Riesgo derivado del perfil termico</a:t>
-            </a:r>
-            <a:endParaRPr lang="en-US" sz="1800" dirty="0"/>
-          </a:p>
-        </p:txBody>
-      </p:sp>
-      <p:sp>
-        <p:nvSpPr>
-          <p:cNvPr id="10" name="Text 8"/>
-          <p:cNvSpPr/>
-          <p:nvPr/>
-        </p:nvSpPr>
-        <p:spPr>
-          <a:xfrm>
-            <a:off x="2194560" y="2542032"/>
-            <a:ext cx="8549640" cy="365760"/>
-          </a:xfrm>
-          <a:prstGeom prst="rect">
-            <a:avLst/>
-          </a:prstGeom>
-          <a:noFill/>
-          <a:ln/>
-        </p:spPr>
-        <p:txBody>
-          <a:bodyPr wrap="square" rtlCol="0" anchor="ctr"/>
-          <a:lstStyle/>
-          <a:p>
-            <a:pPr indent="0" marL="0">
-              <a:buNone/>
-            </a:pPr>
-            <a:r>
-              <a:rPr lang="en-US" sz="1400" dirty="0">
-                <a:solidFill>
-                  <a:srgbClr val="44474C"/>
-                </a:solidFill>
-                <a:latin typeface="Calibri" pitchFamily="34" charset="0"/>
-                <a:ea typeface="Calibri" pitchFamily="34" charset="-122"/>
-                <a:cs typeface="Calibri" pitchFamily="34" charset="-120"/>
-              </a:rPr>
-              <a:t>No existe un registro oficial de heladas observadas por distrito con el que validar.</a:t>
-            </a:r>
-            <a:endParaRPr lang="en-US" sz="1400" dirty="0"/>
-          </a:p>
-        </p:txBody>
-      </p:sp>
-      <p:sp>
-        <p:nvSpPr>
-          <p:cNvPr id="11" name="Shape 9"/>
-          <p:cNvSpPr/>
-          <p:nvPr/>
-        </p:nvSpPr>
-        <p:spPr>
-          <a:xfrm>
-            <a:off x="1143000" y="3218688"/>
-            <a:ext cx="9921240" cy="1097280"/>
+              <a:rPr lang="en-US" sz="900" dirty="0">
+                <a:solidFill>
+                  <a:srgbClr val="A9BCC6"/>
+                </a:solidFill>
+                <a:latin typeface="Calibri" pitchFamily="34" charset="0"/>
+                <a:ea typeface="Calibri" pitchFamily="34" charset="-122"/>
+                <a:cs typeface="Calibri" pitchFamily="34" charset="-120"/>
+              </a:rPr>
+              <a:t>cohesion y separacion (mas alto, mejor)</a:t>
+            </a:r>
+            <a:endParaRPr lang="en-US" sz="900" dirty="0"/>
+          </a:p>
+        </p:txBody>
+      </p:sp>
+      <p:sp>
+        <p:nvSpPr>
+          <p:cNvPr id="11" name="Shape 8"/>
+          <p:cNvSpPr/>
+          <p:nvPr/>
+        </p:nvSpPr>
+        <p:spPr>
+          <a:xfrm>
+            <a:off x="7955280" y="2834640"/>
+            <a:ext cx="3108960" cy="960120"/>
           </a:xfrm>
           <a:prstGeom prst="roundRect">
             <a:avLst>
-              <a:gd name="adj" fmla="val 5000"/>
+              <a:gd name="adj" fmla="val 5714"/>
             </a:avLst>
           </a:prstGeom>
           <a:solidFill>
-            <a:srgbClr val="FFFFFF"/>
+            <a:srgbClr val="0D1B2A"/>
           </a:solidFill>
-          <a:ln w="12700">
-            <a:solidFill>
-              <a:srgbClr val="E1E5E8"/>
-            </a:solidFill>
-            <a:prstDash val="solid"/>
-          </a:ln>
-        </p:spPr>
-      </p:sp>
-      <p:sp>
-        <p:nvSpPr>
-          <p:cNvPr id="12" name="Shape 10"/>
-          <p:cNvSpPr/>
-          <p:nvPr/>
-        </p:nvSpPr>
-        <p:spPr>
-          <a:xfrm>
-            <a:off x="1417320" y="3483864"/>
-            <a:ext cx="566928" cy="566928"/>
-          </a:xfrm>
-          <a:prstGeom prst="ellipse">
-            <a:avLst/>
-          </a:prstGeom>
-          <a:solidFill>
-            <a:srgbClr val="EE6C4D"/>
-          </a:solidFill>
-          <a:ln/>
-        </p:spPr>
-      </p:sp>
-      <p:sp>
-        <p:nvSpPr>
-          <p:cNvPr id="13" name="Text 11"/>
-          <p:cNvSpPr/>
-          <p:nvPr/>
-        </p:nvSpPr>
-        <p:spPr>
-          <a:xfrm>
-            <a:off x="1417320" y="3483864"/>
-            <a:ext cx="566928" cy="566928"/>
+          <a:ln/>
+        </p:spPr>
+      </p:sp>
+      <p:sp>
+        <p:nvSpPr>
+          <p:cNvPr id="12" name="Text 9"/>
+          <p:cNvSpPr/>
+          <p:nvPr/>
+        </p:nvSpPr>
+        <p:spPr>
+          <a:xfrm>
+            <a:off x="8092440" y="2944368"/>
+            <a:ext cx="1234440" cy="731520"/>
           </a:xfrm>
           <a:prstGeom prst="rect">
             <a:avLst/>
@@ -5099,7 +6199,46 @@
               <a:buNone/>
             </a:pPr>
             <a:r>
-              <a:rPr lang="en-US" sz="1600" b="1" dirty="0">
+              <a:rPr lang="en-US" sz="2400" b="1" dirty="0">
+                <a:solidFill>
+                  <a:srgbClr val="E0FBFC"/>
+                </a:solidFill>
+                <a:latin typeface="Georgia" pitchFamily="34" charset="0"/>
+                <a:ea typeface="Georgia" pitchFamily="34" charset="-122"/>
+                <a:cs typeface="Georgia" pitchFamily="34" charset="-120"/>
+              </a:rPr>
+              <a:t>0.813</a:t>
+            </a:r>
+            <a:endParaRPr lang="en-US" sz="2400" dirty="0"/>
+          </a:p>
+        </p:txBody>
+      </p:sp>
+      <p:sp>
+        <p:nvSpPr>
+          <p:cNvPr id="13" name="Text 10"/>
+          <p:cNvSpPr/>
+          <p:nvPr/>
+        </p:nvSpPr>
+        <p:spPr>
+          <a:xfrm>
+            <a:off x="9326880" y="2971800"/>
+            <a:ext cx="1600200" cy="320040"/>
+          </a:xfrm>
+          <a:prstGeom prst="rect">
+            <a:avLst/>
+          </a:prstGeom>
+          <a:noFill/>
+          <a:ln/>
+        </p:spPr>
+        <p:txBody>
+          <a:bodyPr wrap="square" rtlCol="0" anchor="ctr"/>
+          <a:lstStyle/>
+          <a:p>
+            <a:pPr indent="0" marL="0">
+              <a:buNone/>
+            </a:pPr>
+            <a:r>
+              <a:rPr lang="en-US" sz="1300" b="1" dirty="0">
                 <a:solidFill>
                   <a:srgbClr val="FFFFFF"/>
                 </a:solidFill>
@@ -5107,22 +6246,22 @@
                 <a:ea typeface="Calibri" pitchFamily="34" charset="-122"/>
                 <a:cs typeface="Calibri" pitchFamily="34" charset="-120"/>
               </a:rPr>
-              <a:t>2</a:t>
-            </a:r>
-            <a:endParaRPr lang="en-US" sz="1600" dirty="0"/>
-          </a:p>
-        </p:txBody>
-      </p:sp>
-      <p:sp>
-        <p:nvSpPr>
-          <p:cNvPr id="14" name="Text 12"/>
-          <p:cNvSpPr/>
-          <p:nvPr/>
-        </p:nvSpPr>
-        <p:spPr>
-          <a:xfrm>
-            <a:off x="2194560" y="3419856"/>
-            <a:ext cx="8549640" cy="384048"/>
+              <a:t>Davies-Bouldin</a:t>
+            </a:r>
+            <a:endParaRPr lang="en-US" sz="1300" dirty="0"/>
+          </a:p>
+        </p:txBody>
+      </p:sp>
+      <p:sp>
+        <p:nvSpPr>
+          <p:cNvPr id="14" name="Text 11"/>
+          <p:cNvSpPr/>
+          <p:nvPr/>
+        </p:nvSpPr>
+        <p:spPr>
+          <a:xfrm>
+            <a:off x="9326880" y="3291840"/>
+            <a:ext cx="1645920" cy="411480"/>
           </a:xfrm>
           <a:prstGeom prst="rect">
             <a:avLst/>
@@ -5138,155 +6277,52 @@
               <a:buNone/>
             </a:pPr>
             <a:r>
-              <a:rPr lang="en-US" sz="1800" b="1" dirty="0">
-                <a:solidFill>
-                  <a:srgbClr val="0D1B2A"/>
-                </a:solidFill>
-                <a:latin typeface="Calibri" pitchFamily="34" charset="0"/>
-                <a:ea typeface="Calibri" pitchFamily="34" charset="-122"/>
-                <a:cs typeface="Calibri" pitchFamily="34" charset="-120"/>
-              </a:rPr>
-              <a:t>SENAMHI sin API publica estable</a:t>
-            </a:r>
-            <a:endParaRPr lang="en-US" sz="1800" dirty="0"/>
-          </a:p>
-        </p:txBody>
-      </p:sp>
-      <p:sp>
-        <p:nvSpPr>
-          <p:cNvPr id="15" name="Text 13"/>
-          <p:cNvSpPr/>
-          <p:nvPr/>
-        </p:nvSpPr>
-        <p:spPr>
-          <a:xfrm>
-            <a:off x="2194560" y="3840480"/>
-            <a:ext cx="8549640" cy="365760"/>
-          </a:xfrm>
-          <a:prstGeom prst="rect">
-            <a:avLst/>
-          </a:prstGeom>
-          <a:noFill/>
-          <a:ln/>
-        </p:spPr>
-        <p:txBody>
-          <a:bodyPr wrap="square" rtlCol="0" anchor="ctr"/>
-          <a:lstStyle/>
-          <a:p>
-            <a:pPr indent="0" marL="0">
-              <a:buNone/>
-            </a:pPr>
-            <a:r>
-              <a:rPr lang="en-US" sz="1400" dirty="0">
-                <a:solidFill>
-                  <a:srgbClr val="44474C"/>
-                </a:solidFill>
-                <a:latin typeface="Calibri" pitchFamily="34" charset="0"/>
-                <a:ea typeface="Calibri" pitchFamily="34" charset="-122"/>
-                <a:cs typeface="Calibri" pitchFamily="34" charset="-120"/>
-              </a:rPr>
-              <a:t>Es la fuente oficial prioritaria, pero Open-Meteo es la fuente operativa real.</a:t>
-            </a:r>
-            <a:endParaRPr lang="en-US" sz="1400" dirty="0"/>
-          </a:p>
-        </p:txBody>
-      </p:sp>
-      <p:sp>
-        <p:nvSpPr>
-          <p:cNvPr id="16" name="Shape 14"/>
-          <p:cNvSpPr/>
-          <p:nvPr/>
-        </p:nvSpPr>
-        <p:spPr>
-          <a:xfrm>
-            <a:off x="1143000" y="4517136"/>
-            <a:ext cx="9921240" cy="1097280"/>
+              <a:rPr lang="en-US" sz="900" dirty="0">
+                <a:solidFill>
+                  <a:srgbClr val="A9BCC6"/>
+                </a:solidFill>
+                <a:latin typeface="Calibri" pitchFamily="34" charset="0"/>
+                <a:ea typeface="Calibri" pitchFamily="34" charset="-122"/>
+                <a:cs typeface="Calibri" pitchFamily="34" charset="-120"/>
+              </a:rPr>
+              <a:t>dispersion entre grupos (mas bajo, mejor)</a:t>
+            </a:r>
+            <a:endParaRPr lang="en-US" sz="900" dirty="0"/>
+          </a:p>
+        </p:txBody>
+      </p:sp>
+      <p:sp>
+        <p:nvSpPr>
+          <p:cNvPr id="15" name="Shape 12"/>
+          <p:cNvSpPr/>
+          <p:nvPr/>
+        </p:nvSpPr>
+        <p:spPr>
+          <a:xfrm>
+            <a:off x="1143000" y="4114800"/>
+            <a:ext cx="9921240" cy="1600200"/>
           </a:xfrm>
           <a:prstGeom prst="roundRect">
             <a:avLst>
-              <a:gd name="adj" fmla="val 5000"/>
+              <a:gd name="adj" fmla="val 3429"/>
             </a:avLst>
           </a:prstGeom>
           <a:solidFill>
-            <a:srgbClr val="FFFFFF"/>
+            <a:srgbClr val="EDF3F5"/>
           </a:solidFill>
-          <a:ln w="12700">
-            <a:solidFill>
-              <a:srgbClr val="E1E5E8"/>
-            </a:solidFill>
-            <a:prstDash val="solid"/>
-          </a:ln>
-        </p:spPr>
-      </p:sp>
-      <p:sp>
-        <p:nvSpPr>
-          <p:cNvPr id="17" name="Shape 15"/>
-          <p:cNvSpPr/>
-          <p:nvPr/>
-        </p:nvSpPr>
-        <p:spPr>
-          <a:xfrm>
-            <a:off x="1417320" y="4782312"/>
-            <a:ext cx="566928" cy="566928"/>
-          </a:xfrm>
-          <a:prstGeom prst="ellipse">
-            <a:avLst/>
-          </a:prstGeom>
-          <a:solidFill>
-            <a:srgbClr val="EE6C4D"/>
-          </a:solidFill>
-          <a:ln/>
-        </p:spPr>
-      </p:sp>
-      <p:sp>
-        <p:nvSpPr>
-          <p:cNvPr id="18" name="Text 16"/>
-          <p:cNvSpPr/>
-          <p:nvPr/>
-        </p:nvSpPr>
-        <p:spPr>
-          <a:xfrm>
-            <a:off x="1417320" y="4782312"/>
-            <a:ext cx="566928" cy="566928"/>
-          </a:xfrm>
-          <a:prstGeom prst="rect">
-            <a:avLst/>
-          </a:prstGeom>
-          <a:noFill/>
-          <a:ln/>
-        </p:spPr>
-        <p:txBody>
-          <a:bodyPr wrap="square" rtlCol="0" anchor="ctr"/>
-          <a:lstStyle/>
-          <a:p>
-            <a:pPr algn="ctr" indent="0" marL="0">
-              <a:buNone/>
-            </a:pPr>
-            <a:r>
-              <a:rPr lang="en-US" sz="1600" b="1" dirty="0">
-                <a:solidFill>
-                  <a:srgbClr val="FFFFFF"/>
-                </a:solidFill>
-                <a:latin typeface="Calibri" pitchFamily="34" charset="0"/>
-                <a:ea typeface="Calibri" pitchFamily="34" charset="-122"/>
-                <a:cs typeface="Calibri" pitchFamily="34" charset="-120"/>
-              </a:rPr>
-              <a:t>3</a:t>
-            </a:r>
-            <a:endParaRPr lang="en-US" sz="1600" dirty="0"/>
-          </a:p>
-        </p:txBody>
-      </p:sp>
-      <p:sp>
-        <p:nvSpPr>
-          <p:cNvPr id="19" name="Text 17"/>
-          <p:cNvSpPr/>
-          <p:nvPr/>
-        </p:nvSpPr>
-        <p:spPr>
-          <a:xfrm>
-            <a:off x="2194560" y="4718304"/>
-            <a:ext cx="8549640" cy="384048"/>
+          <a:ln/>
+        </p:spPr>
+      </p:sp>
+      <p:sp>
+        <p:nvSpPr>
+          <p:cNvPr id="16" name="Text 13"/>
+          <p:cNvSpPr/>
+          <p:nvPr/>
+        </p:nvSpPr>
+        <p:spPr>
+          <a:xfrm>
+            <a:off x="1508760" y="4297680"/>
+            <a:ext cx="9189720" cy="1234440"/>
           </a:xfrm>
           <a:prstGeom prst="rect">
             <a:avLst/>
@@ -5299,10 +6335,13 @@
           <a:lstStyle/>
           <a:p>
             <a:pPr indent="0" marL="0">
-              <a:buNone/>
-            </a:pPr>
-            <a:r>
-              <a:rPr lang="en-US" sz="1800" b="1" dirty="0">
+              <a:lnSpc>
+                <a:spcPts val="2600"/>
+              </a:lnSpc>
+              <a:buNone/>
+            </a:pPr>
+            <a:r>
+              <a:rPr lang="en-US" sz="1500" b="1" dirty="0">
                 <a:solidFill>
                   <a:srgbClr val="0D1B2A"/>
                 </a:solidFill>
@@ -5310,54 +6349,32 @@
                 <a:ea typeface="Calibri" pitchFamily="34" charset="-122"/>
                 <a:cs typeface="Calibri" pitchFamily="34" charset="-120"/>
               </a:rPr>
-              <a:t>Umbrales de chuño y ganado del MVP</a:t>
-            </a:r>
-            <a:endParaRPr lang="en-US" sz="1800" dirty="0"/>
-          </a:p>
-        </p:txBody>
-      </p:sp>
-      <p:sp>
-        <p:nvSpPr>
-          <p:cNvPr id="20" name="Text 18"/>
-          <p:cNvSpPr/>
-          <p:nvPr/>
-        </p:nvSpPr>
-        <p:spPr>
-          <a:xfrm>
-            <a:off x="2194560" y="5138928"/>
-            <a:ext cx="8549640" cy="365760"/>
-          </a:xfrm>
-          <a:prstGeom prst="rect">
-            <a:avLst/>
-          </a:prstGeom>
-          <a:noFill/>
-          <a:ln/>
-        </p:spPr>
-        <p:txBody>
-          <a:bodyPr wrap="square" rtlCol="0" anchor="ctr"/>
-          <a:lstStyle/>
-          <a:p>
+              <a:t>Por que no accuracy ni F1:  </a:t>
+            </a:r>
             <a:pPr indent="0" marL="0">
-              <a:buNone/>
-            </a:pPr>
-            <a:r>
-              <a:rPr lang="en-US" sz="1400" dirty="0">
-                <a:solidFill>
-                  <a:srgbClr val="44474C"/>
-                </a:solidFill>
-                <a:latin typeface="Calibri" pitchFamily="34" charset="0"/>
-                <a:ea typeface="Calibri" pitchFamily="34" charset="-122"/>
-                <a:cs typeface="Calibri" pitchFamily="34" charset="-120"/>
-              </a:rPr>
-              <a:t>Documentados con fuentes, pero no son cifras oficiales.</a:t>
-            </a:r>
-            <a:endParaRPr lang="en-US" sz="1400" dirty="0"/>
-          </a:p>
-        </p:txBody>
-      </p:sp>
-      <p:sp>
-        <p:nvSpPr>
-          <p:cNvPr id="21" name="Text 19"/>
+              <a:lnSpc>
+                <a:spcPts val="2600"/>
+              </a:lnSpc>
+              <a:buNone/>
+            </a:pPr>
+            <a:r>
+              <a:rPr lang="en-US" sz="1500" dirty="0">
+                <a:solidFill>
+                  <a:srgbClr val="1A1C1C"/>
+                </a:solidFill>
+                <a:latin typeface="Calibri" pitchFamily="34" charset="0"/>
+                <a:ea typeface="Calibri" pitchFamily="34" charset="-122"/>
+                <a:cs typeface="Calibri" pitchFamily="34" charset="-120"/>
+              </a:rPr>
+              <a:t>no existe una verdad de terreno de "aqui hubo helada" para estos distritos. Al ser no supervisado, se mide la calidad de la estructura descubierta, no el acierto contra una etiqueta.</a:t>
+            </a:r>
+            <a:endParaRPr lang="en-US" sz="1500" dirty="0"/>
+          </a:p>
+        </p:txBody>
+      </p:sp>
+      <p:sp>
+        <p:nvSpPr>
+          <p:cNvPr id="17" name="Text 14"/>
           <p:cNvSpPr/>
           <p:nvPr/>
         </p:nvSpPr>
@@ -5380,17 +6397,17 @@
               <a:buNone/>
             </a:pPr>
             <a:r>
-              <a:rPr lang="en-US" sz="1400" b="1" dirty="0">
-                <a:solidFill>
-                  <a:srgbClr val="1F6F78"/>
-                </a:solidFill>
-                <a:latin typeface="Calibri" pitchFamily="34" charset="0"/>
-                <a:ea typeface="Calibri" pitchFamily="34" charset="-122"/>
-                <a:cs typeface="Calibri" pitchFamily="34" charset="-120"/>
-              </a:rPr>
-              <a:t>Ninguna invalida la arquitectura ni el ciclo de vida que mostramos.</a:t>
-            </a:r>
-            <a:endParaRPr lang="en-US" sz="1400" dirty="0"/>
+              <a:rPr lang="en-US" sz="1300" dirty="0">
+                <a:solidFill>
+                  <a:srgbClr val="44474C"/>
+                </a:solidFill>
+                <a:latin typeface="Calibri" pitchFamily="34" charset="0"/>
+                <a:ea typeface="Calibri" pitchFamily="34" charset="-122"/>
+                <a:cs typeface="Calibri" pitchFamily="34" charset="-120"/>
+              </a:rPr>
+              <a:t>El grid completo queda registrado en cluster_metadata.json</a:t>
+            </a:r>
+            <a:endParaRPr lang="en-US" sz="1300" dirty="0"/>
           </a:p>
         </p:txBody>
       </p:sp>
@@ -5405,6 +6422,706 @@
 <file path=ppt/slides/slide7.xml><?xml version="1.0" encoding="utf-8"?>
 <p:sld xmlns:a="http://schemas.openxmlformats.org/drawingml/2006/main" xmlns:r="http://schemas.openxmlformats.org/officeDocument/2006/relationships" xmlns:p="http://schemas.openxmlformats.org/presentationml/2006/main">
   <p:cSld name="Slide 7">
+    <p:bg>
+      <p:bgPr>
+        <a:solidFill>
+          <a:srgbClr val="F9F9F9"/>
+        </a:solidFill>
+      </p:bgPr>
+    </p:bg>
+    <p:spTree>
+      <p:nvGrpSpPr>
+        <p:cNvPr id="1" name=""/>
+        <p:cNvGrpSpPr/>
+        <p:nvPr/>
+      </p:nvGrpSpPr>
+      <p:grpSpPr>
+        <a:xfrm>
+          <a:off x="0" y="0"/>
+          <a:ext cx="0" cy="0"/>
+          <a:chOff x="0" y="0"/>
+          <a:chExt cx="0" cy="0"/>
+        </a:xfrm>
+      </p:grpSpPr>
+      <p:sp>
+        <p:nvSpPr>
+          <p:cNvPr id="2" name="Shape 0"/>
+          <p:cNvSpPr/>
+          <p:nvPr/>
+        </p:nvSpPr>
+        <p:spPr>
+          <a:xfrm>
+            <a:off x="0" y="0"/>
+            <a:ext cx="566928" cy="6858000"/>
+          </a:xfrm>
+          <a:prstGeom prst="rect">
+            <a:avLst/>
+          </a:prstGeom>
+          <a:solidFill>
+            <a:srgbClr val="0D1B2A"/>
+          </a:solidFill>
+          <a:ln/>
+        </p:spPr>
+      </p:sp>
+      <p:sp>
+        <p:nvSpPr>
+          <p:cNvPr id="3" name="Text 1"/>
+          <p:cNvSpPr/>
+          <p:nvPr/>
+        </p:nvSpPr>
+        <p:spPr>
+          <a:xfrm rot="16200000">
+            <a:off x="-658368" y="3108960"/>
+            <a:ext cx="1920240" cy="640080"/>
+          </a:xfrm>
+          <a:prstGeom prst="rect">
+            <a:avLst/>
+          </a:prstGeom>
+          <a:noFill/>
+          <a:ln/>
+        </p:spPr>
+        <p:txBody>
+          <a:bodyPr wrap="square" rtlCol="0" anchor="ctr"/>
+          <a:lstStyle/>
+          <a:p>
+            <a:pPr algn="ctr" indent="0" marL="0">
+              <a:buNone/>
+            </a:pPr>
+            <a:r>
+              <a:rPr lang="en-US" sz="1200" b="1" spc="200" kern="0" dirty="0">
+                <a:solidFill>
+                  <a:srgbClr val="E0FBFC"/>
+                </a:solidFill>
+                <a:latin typeface="Calibri" pitchFamily="34" charset="0"/>
+                <a:ea typeface="Calibri" pitchFamily="34" charset="-122"/>
+                <a:cs typeface="Calibri" pitchFamily="34" charset="-120"/>
+              </a:rPr>
+              <a:t>LIMITACIONES</a:t>
+            </a:r>
+            <a:endParaRPr lang="en-US" sz="1200" dirty="0"/>
+          </a:p>
+        </p:txBody>
+      </p:sp>
+      <p:sp>
+        <p:nvSpPr>
+          <p:cNvPr id="4" name="Text 2"/>
+          <p:cNvSpPr/>
+          <p:nvPr/>
+        </p:nvSpPr>
+        <p:spPr>
+          <a:xfrm>
+            <a:off x="1143000" y="457200"/>
+            <a:ext cx="9921240" cy="731520"/>
+          </a:xfrm>
+          <a:prstGeom prst="rect">
+            <a:avLst/>
+          </a:prstGeom>
+          <a:noFill/>
+          <a:ln/>
+        </p:spPr>
+        <p:txBody>
+          <a:bodyPr wrap="square" rtlCol="0" anchor="ctr"/>
+          <a:lstStyle/>
+          <a:p>
+            <a:pPr indent="0" marL="0">
+              <a:buNone/>
+            </a:pPr>
+            <a:r>
+              <a:rPr lang="en-US" sz="3600" b="1" dirty="0">
+                <a:solidFill>
+                  <a:srgbClr val="0D1B2A"/>
+                </a:solidFill>
+                <a:latin typeface="Georgia" pitchFamily="34" charset="0"/>
+                <a:ea typeface="Georgia" pitchFamily="34" charset="-122"/>
+                <a:cs typeface="Georgia" pitchFamily="34" charset="-120"/>
+              </a:rPr>
+              <a:t>Lo que el sistema todavia no hace</a:t>
+            </a:r>
+            <a:endParaRPr lang="en-US" sz="3600" dirty="0"/>
+          </a:p>
+        </p:txBody>
+      </p:sp>
+      <p:sp>
+        <p:nvSpPr>
+          <p:cNvPr id="5" name="Text 3"/>
+          <p:cNvSpPr/>
+          <p:nvPr/>
+        </p:nvSpPr>
+        <p:spPr>
+          <a:xfrm>
+            <a:off x="1143000" y="1170432"/>
+            <a:ext cx="9921240" cy="411480"/>
+          </a:xfrm>
+          <a:prstGeom prst="rect">
+            <a:avLst/>
+          </a:prstGeom>
+          <a:noFill/>
+          <a:ln/>
+        </p:spPr>
+        <p:txBody>
+          <a:bodyPr wrap="square" rtlCol="0" anchor="ctr"/>
+          <a:lstStyle/>
+          <a:p>
+            <a:pPr indent="0" marL="0">
+              <a:buNone/>
+            </a:pPr>
+            <a:r>
+              <a:rPr lang="en-US" sz="1600" i="1" dirty="0">
+                <a:solidFill>
+                  <a:srgbClr val="3D5A80"/>
+                </a:solidFill>
+                <a:latin typeface="Calibri" pitchFamily="34" charset="0"/>
+                <a:ea typeface="Calibri" pitchFamily="34" charset="-122"/>
+                <a:cs typeface="Calibri" pitchFamily="34" charset="-120"/>
+              </a:rPr>
+              <a:t>Un informe honesto vale mas que uno perfecto.</a:t>
+            </a:r>
+            <a:endParaRPr lang="en-US" sz="1600" dirty="0"/>
+          </a:p>
+        </p:txBody>
+      </p:sp>
+      <p:sp>
+        <p:nvSpPr>
+          <p:cNvPr id="6" name="Shape 4"/>
+          <p:cNvSpPr/>
+          <p:nvPr/>
+        </p:nvSpPr>
+        <p:spPr>
+          <a:xfrm>
+            <a:off x="1143000" y="1920240"/>
+            <a:ext cx="9921240" cy="1097280"/>
+          </a:xfrm>
+          <a:prstGeom prst="roundRect">
+            <a:avLst>
+              <a:gd name="adj" fmla="val 5000"/>
+            </a:avLst>
+          </a:prstGeom>
+          <a:solidFill>
+            <a:srgbClr val="FFFFFF"/>
+          </a:solidFill>
+          <a:ln w="12700">
+            <a:solidFill>
+              <a:srgbClr val="E1E5E8"/>
+            </a:solidFill>
+            <a:prstDash val="solid"/>
+          </a:ln>
+        </p:spPr>
+      </p:sp>
+      <p:sp>
+        <p:nvSpPr>
+          <p:cNvPr id="7" name="Shape 5"/>
+          <p:cNvSpPr/>
+          <p:nvPr/>
+        </p:nvSpPr>
+        <p:spPr>
+          <a:xfrm>
+            <a:off x="1417320" y="2185416"/>
+            <a:ext cx="566928" cy="566928"/>
+          </a:xfrm>
+          <a:prstGeom prst="ellipse">
+            <a:avLst/>
+          </a:prstGeom>
+          <a:solidFill>
+            <a:srgbClr val="EE6C4D"/>
+          </a:solidFill>
+          <a:ln/>
+        </p:spPr>
+      </p:sp>
+      <p:sp>
+        <p:nvSpPr>
+          <p:cNvPr id="8" name="Text 6"/>
+          <p:cNvSpPr/>
+          <p:nvPr/>
+        </p:nvSpPr>
+        <p:spPr>
+          <a:xfrm>
+            <a:off x="1417320" y="2185416"/>
+            <a:ext cx="566928" cy="566928"/>
+          </a:xfrm>
+          <a:prstGeom prst="rect">
+            <a:avLst/>
+          </a:prstGeom>
+          <a:noFill/>
+          <a:ln/>
+        </p:spPr>
+        <p:txBody>
+          <a:bodyPr wrap="square" rtlCol="0" anchor="ctr"/>
+          <a:lstStyle/>
+          <a:p>
+            <a:pPr algn="ctr" indent="0" marL="0">
+              <a:buNone/>
+            </a:pPr>
+            <a:r>
+              <a:rPr lang="en-US" sz="1600" b="1" dirty="0">
+                <a:solidFill>
+                  <a:srgbClr val="FFFFFF"/>
+                </a:solidFill>
+                <a:latin typeface="Calibri" pitchFamily="34" charset="0"/>
+                <a:ea typeface="Calibri" pitchFamily="34" charset="-122"/>
+                <a:cs typeface="Calibri" pitchFamily="34" charset="-120"/>
+              </a:rPr>
+              <a:t>1</a:t>
+            </a:r>
+            <a:endParaRPr lang="en-US" sz="1600" dirty="0"/>
+          </a:p>
+        </p:txBody>
+      </p:sp>
+      <p:sp>
+        <p:nvSpPr>
+          <p:cNvPr id="9" name="Text 7"/>
+          <p:cNvSpPr/>
+          <p:nvPr/>
+        </p:nvSpPr>
+        <p:spPr>
+          <a:xfrm>
+            <a:off x="2194560" y="2121408"/>
+            <a:ext cx="8549640" cy="384048"/>
+          </a:xfrm>
+          <a:prstGeom prst="rect">
+            <a:avLst/>
+          </a:prstGeom>
+          <a:noFill/>
+          <a:ln/>
+        </p:spPr>
+        <p:txBody>
+          <a:bodyPr wrap="square" rtlCol="0" anchor="ctr"/>
+          <a:lstStyle/>
+          <a:p>
+            <a:pPr indent="0" marL="0">
+              <a:buNone/>
+            </a:pPr>
+            <a:r>
+              <a:rPr lang="en-US" sz="1800" b="1" dirty="0">
+                <a:solidFill>
+                  <a:srgbClr val="0D1B2A"/>
+                </a:solidFill>
+                <a:latin typeface="Calibri" pitchFamily="34" charset="0"/>
+                <a:ea typeface="Calibri" pitchFamily="34" charset="-122"/>
+                <a:cs typeface="Calibri" pitchFamily="34" charset="-120"/>
+              </a:rPr>
+              <a:t>Riesgo derivado del perfil termico</a:t>
+            </a:r>
+            <a:endParaRPr lang="en-US" sz="1800" dirty="0"/>
+          </a:p>
+        </p:txBody>
+      </p:sp>
+      <p:sp>
+        <p:nvSpPr>
+          <p:cNvPr id="10" name="Text 8"/>
+          <p:cNvSpPr/>
+          <p:nvPr/>
+        </p:nvSpPr>
+        <p:spPr>
+          <a:xfrm>
+            <a:off x="2194560" y="2542032"/>
+            <a:ext cx="8549640" cy="365760"/>
+          </a:xfrm>
+          <a:prstGeom prst="rect">
+            <a:avLst/>
+          </a:prstGeom>
+          <a:noFill/>
+          <a:ln/>
+        </p:spPr>
+        <p:txBody>
+          <a:bodyPr wrap="square" rtlCol="0" anchor="ctr"/>
+          <a:lstStyle/>
+          <a:p>
+            <a:pPr indent="0" marL="0">
+              <a:buNone/>
+            </a:pPr>
+            <a:r>
+              <a:rPr lang="en-US" sz="1400" dirty="0">
+                <a:solidFill>
+                  <a:srgbClr val="44474C"/>
+                </a:solidFill>
+                <a:latin typeface="Calibri" pitchFamily="34" charset="0"/>
+                <a:ea typeface="Calibri" pitchFamily="34" charset="-122"/>
+                <a:cs typeface="Calibri" pitchFamily="34" charset="-120"/>
+              </a:rPr>
+              <a:t>No existe un registro oficial de heladas observadas por distrito con el que validar.</a:t>
+            </a:r>
+            <a:endParaRPr lang="en-US" sz="1400" dirty="0"/>
+          </a:p>
+        </p:txBody>
+      </p:sp>
+      <p:sp>
+        <p:nvSpPr>
+          <p:cNvPr id="11" name="Shape 9"/>
+          <p:cNvSpPr/>
+          <p:nvPr/>
+        </p:nvSpPr>
+        <p:spPr>
+          <a:xfrm>
+            <a:off x="1143000" y="3218688"/>
+            <a:ext cx="9921240" cy="1097280"/>
+          </a:xfrm>
+          <a:prstGeom prst="roundRect">
+            <a:avLst>
+              <a:gd name="adj" fmla="val 5000"/>
+            </a:avLst>
+          </a:prstGeom>
+          <a:solidFill>
+            <a:srgbClr val="FFFFFF"/>
+          </a:solidFill>
+          <a:ln w="12700">
+            <a:solidFill>
+              <a:srgbClr val="E1E5E8"/>
+            </a:solidFill>
+            <a:prstDash val="solid"/>
+          </a:ln>
+        </p:spPr>
+      </p:sp>
+      <p:sp>
+        <p:nvSpPr>
+          <p:cNvPr id="12" name="Shape 10"/>
+          <p:cNvSpPr/>
+          <p:nvPr/>
+        </p:nvSpPr>
+        <p:spPr>
+          <a:xfrm>
+            <a:off x="1417320" y="3483864"/>
+            <a:ext cx="566928" cy="566928"/>
+          </a:xfrm>
+          <a:prstGeom prst="ellipse">
+            <a:avLst/>
+          </a:prstGeom>
+          <a:solidFill>
+            <a:srgbClr val="EE6C4D"/>
+          </a:solidFill>
+          <a:ln/>
+        </p:spPr>
+      </p:sp>
+      <p:sp>
+        <p:nvSpPr>
+          <p:cNvPr id="13" name="Text 11"/>
+          <p:cNvSpPr/>
+          <p:nvPr/>
+        </p:nvSpPr>
+        <p:spPr>
+          <a:xfrm>
+            <a:off x="1417320" y="3483864"/>
+            <a:ext cx="566928" cy="566928"/>
+          </a:xfrm>
+          <a:prstGeom prst="rect">
+            <a:avLst/>
+          </a:prstGeom>
+          <a:noFill/>
+          <a:ln/>
+        </p:spPr>
+        <p:txBody>
+          <a:bodyPr wrap="square" rtlCol="0" anchor="ctr"/>
+          <a:lstStyle/>
+          <a:p>
+            <a:pPr algn="ctr" indent="0" marL="0">
+              <a:buNone/>
+            </a:pPr>
+            <a:r>
+              <a:rPr lang="en-US" sz="1600" b="1" dirty="0">
+                <a:solidFill>
+                  <a:srgbClr val="FFFFFF"/>
+                </a:solidFill>
+                <a:latin typeface="Calibri" pitchFamily="34" charset="0"/>
+                <a:ea typeface="Calibri" pitchFamily="34" charset="-122"/>
+                <a:cs typeface="Calibri" pitchFamily="34" charset="-120"/>
+              </a:rPr>
+              <a:t>2</a:t>
+            </a:r>
+            <a:endParaRPr lang="en-US" sz="1600" dirty="0"/>
+          </a:p>
+        </p:txBody>
+      </p:sp>
+      <p:sp>
+        <p:nvSpPr>
+          <p:cNvPr id="14" name="Text 12"/>
+          <p:cNvSpPr/>
+          <p:nvPr/>
+        </p:nvSpPr>
+        <p:spPr>
+          <a:xfrm>
+            <a:off x="2194560" y="3419856"/>
+            <a:ext cx="8549640" cy="384048"/>
+          </a:xfrm>
+          <a:prstGeom prst="rect">
+            <a:avLst/>
+          </a:prstGeom>
+          <a:noFill/>
+          <a:ln/>
+        </p:spPr>
+        <p:txBody>
+          <a:bodyPr wrap="square" rtlCol="0" anchor="ctr"/>
+          <a:lstStyle/>
+          <a:p>
+            <a:pPr indent="0" marL="0">
+              <a:buNone/>
+            </a:pPr>
+            <a:r>
+              <a:rPr lang="en-US" sz="1800" b="1" dirty="0">
+                <a:solidFill>
+                  <a:srgbClr val="0D1B2A"/>
+                </a:solidFill>
+                <a:latin typeface="Calibri" pitchFamily="34" charset="0"/>
+                <a:ea typeface="Calibri" pitchFamily="34" charset="-122"/>
+                <a:cs typeface="Calibri" pitchFamily="34" charset="-120"/>
+              </a:rPr>
+              <a:t>SENAMHI sin API publica estable</a:t>
+            </a:r>
+            <a:endParaRPr lang="en-US" sz="1800" dirty="0"/>
+          </a:p>
+        </p:txBody>
+      </p:sp>
+      <p:sp>
+        <p:nvSpPr>
+          <p:cNvPr id="15" name="Text 13"/>
+          <p:cNvSpPr/>
+          <p:nvPr/>
+        </p:nvSpPr>
+        <p:spPr>
+          <a:xfrm>
+            <a:off x="2194560" y="3840480"/>
+            <a:ext cx="8549640" cy="365760"/>
+          </a:xfrm>
+          <a:prstGeom prst="rect">
+            <a:avLst/>
+          </a:prstGeom>
+          <a:noFill/>
+          <a:ln/>
+        </p:spPr>
+        <p:txBody>
+          <a:bodyPr wrap="square" rtlCol="0" anchor="ctr"/>
+          <a:lstStyle/>
+          <a:p>
+            <a:pPr indent="0" marL="0">
+              <a:buNone/>
+            </a:pPr>
+            <a:r>
+              <a:rPr lang="en-US" sz="1400" dirty="0">
+                <a:solidFill>
+                  <a:srgbClr val="44474C"/>
+                </a:solidFill>
+                <a:latin typeface="Calibri" pitchFamily="34" charset="0"/>
+                <a:ea typeface="Calibri" pitchFamily="34" charset="-122"/>
+                <a:cs typeface="Calibri" pitchFamily="34" charset="-120"/>
+              </a:rPr>
+              <a:t>Es la fuente oficial prioritaria, pero Open-Meteo es la fuente operativa real.</a:t>
+            </a:r>
+            <a:endParaRPr lang="en-US" sz="1400" dirty="0"/>
+          </a:p>
+        </p:txBody>
+      </p:sp>
+      <p:sp>
+        <p:nvSpPr>
+          <p:cNvPr id="16" name="Shape 14"/>
+          <p:cNvSpPr/>
+          <p:nvPr/>
+        </p:nvSpPr>
+        <p:spPr>
+          <a:xfrm>
+            <a:off x="1143000" y="4517136"/>
+            <a:ext cx="9921240" cy="1097280"/>
+          </a:xfrm>
+          <a:prstGeom prst="roundRect">
+            <a:avLst>
+              <a:gd name="adj" fmla="val 5000"/>
+            </a:avLst>
+          </a:prstGeom>
+          <a:solidFill>
+            <a:srgbClr val="FFFFFF"/>
+          </a:solidFill>
+          <a:ln w="12700">
+            <a:solidFill>
+              <a:srgbClr val="E1E5E8"/>
+            </a:solidFill>
+            <a:prstDash val="solid"/>
+          </a:ln>
+        </p:spPr>
+      </p:sp>
+      <p:sp>
+        <p:nvSpPr>
+          <p:cNvPr id="17" name="Shape 15"/>
+          <p:cNvSpPr/>
+          <p:nvPr/>
+        </p:nvSpPr>
+        <p:spPr>
+          <a:xfrm>
+            <a:off x="1417320" y="4782312"/>
+            <a:ext cx="566928" cy="566928"/>
+          </a:xfrm>
+          <a:prstGeom prst="ellipse">
+            <a:avLst/>
+          </a:prstGeom>
+          <a:solidFill>
+            <a:srgbClr val="EE6C4D"/>
+          </a:solidFill>
+          <a:ln/>
+        </p:spPr>
+      </p:sp>
+      <p:sp>
+        <p:nvSpPr>
+          <p:cNvPr id="18" name="Text 16"/>
+          <p:cNvSpPr/>
+          <p:nvPr/>
+        </p:nvSpPr>
+        <p:spPr>
+          <a:xfrm>
+            <a:off x="1417320" y="4782312"/>
+            <a:ext cx="566928" cy="566928"/>
+          </a:xfrm>
+          <a:prstGeom prst="rect">
+            <a:avLst/>
+          </a:prstGeom>
+          <a:noFill/>
+          <a:ln/>
+        </p:spPr>
+        <p:txBody>
+          <a:bodyPr wrap="square" rtlCol="0" anchor="ctr"/>
+          <a:lstStyle/>
+          <a:p>
+            <a:pPr algn="ctr" indent="0" marL="0">
+              <a:buNone/>
+            </a:pPr>
+            <a:r>
+              <a:rPr lang="en-US" sz="1600" b="1" dirty="0">
+                <a:solidFill>
+                  <a:srgbClr val="FFFFFF"/>
+                </a:solidFill>
+                <a:latin typeface="Calibri" pitchFamily="34" charset="0"/>
+                <a:ea typeface="Calibri" pitchFamily="34" charset="-122"/>
+                <a:cs typeface="Calibri" pitchFamily="34" charset="-120"/>
+              </a:rPr>
+              <a:t>3</a:t>
+            </a:r>
+            <a:endParaRPr lang="en-US" sz="1600" dirty="0"/>
+          </a:p>
+        </p:txBody>
+      </p:sp>
+      <p:sp>
+        <p:nvSpPr>
+          <p:cNvPr id="19" name="Text 17"/>
+          <p:cNvSpPr/>
+          <p:nvPr/>
+        </p:nvSpPr>
+        <p:spPr>
+          <a:xfrm>
+            <a:off x="2194560" y="4718304"/>
+            <a:ext cx="8549640" cy="384048"/>
+          </a:xfrm>
+          <a:prstGeom prst="rect">
+            <a:avLst/>
+          </a:prstGeom>
+          <a:noFill/>
+          <a:ln/>
+        </p:spPr>
+        <p:txBody>
+          <a:bodyPr wrap="square" rtlCol="0" anchor="ctr"/>
+          <a:lstStyle/>
+          <a:p>
+            <a:pPr indent="0" marL="0">
+              <a:buNone/>
+            </a:pPr>
+            <a:r>
+              <a:rPr lang="en-US" sz="1800" b="1" dirty="0">
+                <a:solidFill>
+                  <a:srgbClr val="0D1B2A"/>
+                </a:solidFill>
+                <a:latin typeface="Calibri" pitchFamily="34" charset="0"/>
+                <a:ea typeface="Calibri" pitchFamily="34" charset="-122"/>
+                <a:cs typeface="Calibri" pitchFamily="34" charset="-120"/>
+              </a:rPr>
+              <a:t>Umbrales de chuño y ganado del MVP</a:t>
+            </a:r>
+            <a:endParaRPr lang="en-US" sz="1800" dirty="0"/>
+          </a:p>
+        </p:txBody>
+      </p:sp>
+      <p:sp>
+        <p:nvSpPr>
+          <p:cNvPr id="20" name="Text 18"/>
+          <p:cNvSpPr/>
+          <p:nvPr/>
+        </p:nvSpPr>
+        <p:spPr>
+          <a:xfrm>
+            <a:off x="2194560" y="5138928"/>
+            <a:ext cx="8549640" cy="365760"/>
+          </a:xfrm>
+          <a:prstGeom prst="rect">
+            <a:avLst/>
+          </a:prstGeom>
+          <a:noFill/>
+          <a:ln/>
+        </p:spPr>
+        <p:txBody>
+          <a:bodyPr wrap="square" rtlCol="0" anchor="ctr"/>
+          <a:lstStyle/>
+          <a:p>
+            <a:pPr indent="0" marL="0">
+              <a:buNone/>
+            </a:pPr>
+            <a:r>
+              <a:rPr lang="en-US" sz="1400" dirty="0">
+                <a:solidFill>
+                  <a:srgbClr val="44474C"/>
+                </a:solidFill>
+                <a:latin typeface="Calibri" pitchFamily="34" charset="0"/>
+                <a:ea typeface="Calibri" pitchFamily="34" charset="-122"/>
+                <a:cs typeface="Calibri" pitchFamily="34" charset="-120"/>
+              </a:rPr>
+              <a:t>Documentados con fuentes, pero no son cifras oficiales.</a:t>
+            </a:r>
+            <a:endParaRPr lang="en-US" sz="1400" dirty="0"/>
+          </a:p>
+        </p:txBody>
+      </p:sp>
+      <p:sp>
+        <p:nvSpPr>
+          <p:cNvPr id="21" name="Text 19"/>
+          <p:cNvSpPr/>
+          <p:nvPr/>
+        </p:nvSpPr>
+        <p:spPr>
+          <a:xfrm>
+            <a:off x="1143000" y="5897880"/>
+            <a:ext cx="9921240" cy="365760"/>
+          </a:xfrm>
+          <a:prstGeom prst="rect">
+            <a:avLst/>
+          </a:prstGeom>
+          <a:noFill/>
+          <a:ln/>
+        </p:spPr>
+        <p:txBody>
+          <a:bodyPr wrap="square" rtlCol="0" anchor="ctr"/>
+          <a:lstStyle/>
+          <a:p>
+            <a:pPr indent="0" marL="0">
+              <a:buNone/>
+            </a:pPr>
+            <a:r>
+              <a:rPr lang="en-US" sz="1400" b="1" dirty="0">
+                <a:solidFill>
+                  <a:srgbClr val="1F6F78"/>
+                </a:solidFill>
+                <a:latin typeface="Calibri" pitchFamily="34" charset="0"/>
+                <a:ea typeface="Calibri" pitchFamily="34" charset="-122"/>
+                <a:cs typeface="Calibri" pitchFamily="34" charset="-120"/>
+              </a:rPr>
+              <a:t>Ninguna invalida la arquitectura ni el ciclo de vida que mostramos.</a:t>
+            </a:r>
+            <a:endParaRPr lang="en-US" sz="1400" dirty="0"/>
+          </a:p>
+        </p:txBody>
+      </p:sp>
+    </p:spTree>
+  </p:cSld>
+  <p:clrMapOvr>
+    <a:masterClrMapping/>
+  </p:clrMapOvr>
+</p:sld>
+</file>
+
+<file path=ppt/slides/slide8.xml><?xml version="1.0" encoding="utf-8"?>
+<p:sld xmlns:a="http://schemas.openxmlformats.org/drawingml/2006/main" xmlns:r="http://schemas.openxmlformats.org/officeDocument/2006/relationships" xmlns:p="http://schemas.openxmlformats.org/presentationml/2006/main">
+  <p:cSld name="Slide 8">
     <p:bg>
       <p:bgPr>
         <a:solidFill>

</xml_diff>

<commit_message>
docs: informe tecnico final del curso en Word
Informe alineado a los criterios de evaluacion (8 puntos):
herramientas y plataformas, organizacion del codigo fuente, consideraciones de
despliegue inicial, flujos de mantenimiento e integracion continua, y el enlace
del video de la exposicion.

- Portada con el escudo institucional y la docente Ing. Fernandez Chambi Mayenka.
- Tabla de enlaces verificables: video, repositorio, aplicacion web, API y APK.
- Documenta la consideracion critica detectada en produccion (las variables del
  panel de Render prevalecen sobre render.yaml).
- Incluye las pruebas de funcionamiento del mantenimiento, entre ellas la que
  verifica que el quality gate bloquea un modelo degradado.
- Capturas actualizadas extraidas del informe del equipo; sin cursivas ni
  marcadores pendientes.
- Se versiona el generador en docs/build_informe_tecnico.py.

Co-Authored-By: Claude Opus 4.8 <noreply@anthropic.com>
</commit_message>
<xml_diff>
--- a/docs/presentacion/FrostPuno_Joseph.pptx
+++ b/docs/presentacion/FrostPuno_Joseph.pptx
@@ -4,6 +4,9 @@
   <p:sldMasterIdLst>
     <p:sldMasterId id="2147483648" r:id="rId1"/>
   </p:sldMasterIdLst>
+  <p:notesMasterIdLst>
+    <p:notesMasterId r:id="rId10"/>
+  </p:notesMasterIdLst>
   <p:sldIdLst>
     <p:sldId id="256" r:id="rId2"/>
     <p:sldId id="257" r:id="rId3"/>
@@ -14,11 +17,8 @@
     <p:sldId id="262" r:id="rId8"/>
     <p:sldId id="263" r:id="rId9"/>
   </p:sldIdLst>
-  <p:notesMasterIdLst>
-    <p:notesMasterId r:id="rId10"/>
-  </p:notesMasterIdLst>
-  <p:sldSz cx="12191695" cy="6858000"/>
-  <p:notesSz cx="6858000" cy="12191695"/>
+  <p:sldSz cx="12192000" cy="6858000"/>
+  <p:notesSz cx="6858000" cy="12192000"/>
   <p:defaultTextStyle>
     <a:lvl1pPr marL="0" algn="l" defTabSz="914400" rtl="0" eaLnBrk="1" latinLnBrk="0" hangingPunct="1">
       <a:defRPr sz="1800" kern="1200">
@@ -111,6 +111,11 @@
       </a:defRPr>
     </a:lvl9pPr>
   </p:defaultTextStyle>
+  <p:extLst>
+    <p:ext uri="{EFAFB233-063F-42B5-8137-9DF3F51BA10A}">
+      <p15:sldGuideLst xmlns:p15="http://schemas.microsoft.com/office/powerpoint/2012/main"/>
+    </p:ext>
+  </p:extLst>
 </p:presentation>
 </file>
 
@@ -136,234 +141,10 @@
           <a:chExt cx="0" cy="0"/>
         </a:xfrm>
       </p:grpSpPr>
-      <p:sp>
-        <p:nvSpPr>
-          <p:cNvPr id="2" name="Header Placeholder 1"/>
-          <p:cNvSpPr>
-            <a:spLocks noGrp="1"/>
-          </p:cNvSpPr>
-          <p:nvPr>
-            <p:ph type="hdr" sz="quarter"/>
-          </p:nvPr>
-        </p:nvSpPr>
-        <p:spPr>
-          <a:xfrm>
-            <a:off x="0" y="0"/>
-            <a:ext cx="2971800" cy="458788"/>
-          </a:xfrm>
-          <a:prstGeom prst="rect">
-            <a:avLst/>
-          </a:prstGeom>
-        </p:spPr>
-        <p:txBody>
-          <a:bodyPr vert="horz" lIns="91440" tIns="45720" rIns="91440" bIns="45720" rtlCol="0"/>
-          <a:lstStyle>
-            <a:lvl1pPr algn="l">
-              <a:defRPr sz="1200"/>
-            </a:lvl1pPr>
-          </a:lstStyle>
-          <a:p>
-            <a:endParaRPr lang="en-US"/>
-          </a:p>
-        </p:txBody>
-      </p:sp>
-      <p:sp>
-        <p:nvSpPr>
-          <p:cNvPr id="3" name="Date Placeholder 2"/>
-          <p:cNvSpPr>
-            <a:spLocks noGrp="1"/>
-          </p:cNvSpPr>
-          <p:nvPr>
-            <p:ph type="dt" idx="1"/>
-          </p:nvPr>
-        </p:nvSpPr>
-        <p:spPr>
-          <a:xfrm>
-            <a:off x="3884613" y="0"/>
-            <a:ext cx="2971800" cy="458788"/>
-          </a:xfrm>
-          <a:prstGeom prst="rect">
-            <a:avLst/>
-          </a:prstGeom>
-        </p:spPr>
-        <p:txBody>
-          <a:bodyPr vert="horz" lIns="91440" tIns="45720" rIns="91440" bIns="45720" rtlCol="0"/>
-          <a:lstStyle>
-            <a:lvl1pPr algn="r">
-              <a:defRPr sz="1200"/>
-            </a:lvl1pPr>
-          </a:lstStyle>
-          <a:p>
-            <a:fld id="{5282F153-3F37-0F45-9E97-73ACFA13230C}" type="datetimeFigureOut">
-              <a:rPr lang="en-US"/>
-              <a:t>7/23/19</a:t>
-            </a:fld>
-            <a:endParaRPr lang="en-US"/>
-          </a:p>
-        </p:txBody>
-      </p:sp>
-      <p:sp>
-        <p:nvSpPr>
-          <p:cNvPr id="4" name="Slide Image Placeholder 3"/>
-          <p:cNvSpPr>
-            <a:spLocks noGrp="1" noRot="1" noChangeAspect="1"/>
-          </p:cNvSpPr>
-          <p:nvPr>
-            <p:ph type="sldImg" idx="2"/>
-          </p:nvPr>
-        </p:nvSpPr>
-        <p:spPr>
-          <a:xfrm>
-            <a:off x="685800" y="1143000"/>
-            <a:ext cx="5486400" cy="3086100"/>
-          </a:xfrm>
-          <a:prstGeom prst="rect">
-            <a:avLst/>
-          </a:prstGeom>
-          <a:noFill/>
-          <a:ln w="12700">
-            <a:solidFill>
-              <a:prstClr val="black"/>
-            </a:solidFill>
-          </a:ln>
-        </p:spPr>
-        <p:txBody>
-          <a:bodyPr vert="horz" lIns="91440" tIns="45720" rIns="91440" bIns="45720" rtlCol="0" anchor="ctr"/>
-          <a:lstStyle/>
-          <a:p>
-            <a:endParaRPr lang="en-US"/>
-          </a:p>
-        </p:txBody>
-      </p:sp>
-      <p:sp>
-        <p:nvSpPr>
-          <p:cNvPr id="5" name="Notes Placeholder 4"/>
-          <p:cNvSpPr>
-            <a:spLocks noGrp="1"/>
-          </p:cNvSpPr>
-          <p:nvPr>
-            <p:ph type="body" sz="quarter" idx="3"/>
-          </p:nvPr>
-        </p:nvSpPr>
-        <p:spPr>
-          <a:xfrm>
-            <a:off x="685800" y="4400550"/>
-            <a:ext cx="5486400" cy="3600450"/>
-          </a:xfrm>
-          <a:prstGeom prst="rect">
-            <a:avLst/>
-          </a:prstGeom>
-        </p:spPr>
-        <p:txBody>
-          <a:bodyPr vert="horz" lIns="91440" tIns="45720" rIns="91440" bIns="45720" rtlCol="0"/>
-          <a:lstStyle/>
-          <a:p>
-            <a:pPr lvl="0"/>
-            <a:r>
-              <a:rPr lang="en-US"/>
-              <a:t>Click to edit Master text styles</a:t>
-            </a:r>
-          </a:p>
-          <a:p>
-            <a:pPr lvl="1"/>
-            <a:r>
-              <a:rPr lang="en-US"/>
-              <a:t>Second level</a:t>
-            </a:r>
-          </a:p>
-          <a:p>
-            <a:pPr lvl="2"/>
-            <a:r>
-              <a:rPr lang="en-US"/>
-              <a:t>Third level</a:t>
-            </a:r>
-          </a:p>
-          <a:p>
-            <a:pPr lvl="3"/>
-            <a:r>
-              <a:rPr lang="en-US"/>
-              <a:t>Fourth level</a:t>
-            </a:r>
-          </a:p>
-          <a:p>
-            <a:pPr lvl="4"/>
-            <a:r>
-              <a:rPr lang="en-US"/>
-              <a:t>Fifth level</a:t>
-            </a:r>
-          </a:p>
-        </p:txBody>
-      </p:sp>
-      <p:sp>
-        <p:nvSpPr>
-          <p:cNvPr id="6" name="Footer Placeholder 5"/>
-          <p:cNvSpPr>
-            <a:spLocks noGrp="1"/>
-          </p:cNvSpPr>
-          <p:nvPr>
-            <p:ph type="ftr" sz="quarter" idx="4"/>
-          </p:nvPr>
-        </p:nvSpPr>
-        <p:spPr>
-          <a:xfrm>
-            <a:off x="0" y="8685213"/>
-            <a:ext cx="2971800" cy="458787"/>
-          </a:xfrm>
-          <a:prstGeom prst="rect">
-            <a:avLst/>
-          </a:prstGeom>
-        </p:spPr>
-        <p:txBody>
-          <a:bodyPr vert="horz" lIns="91440" tIns="45720" rIns="91440" bIns="45720" rtlCol="0" anchor="b"/>
-          <a:lstStyle>
-            <a:lvl1pPr algn="l">
-              <a:defRPr sz="1200"/>
-            </a:lvl1pPr>
-          </a:lstStyle>
-          <a:p>
-            <a:endParaRPr lang="en-US"/>
-          </a:p>
-        </p:txBody>
-      </p:sp>
-      <p:sp>
-        <p:nvSpPr>
-          <p:cNvPr id="7" name="Slide Number Placeholder 6"/>
-          <p:cNvSpPr>
-            <a:spLocks noGrp="1"/>
-          </p:cNvSpPr>
-          <p:nvPr>
-            <p:ph type="sldNum" sz="quarter" idx="5"/>
-          </p:nvPr>
-        </p:nvSpPr>
-        <p:spPr>
-          <a:xfrm>
-            <a:off x="3884613" y="8685213"/>
-            <a:ext cx="2971800" cy="458787"/>
-          </a:xfrm>
-          <a:prstGeom prst="rect">
-            <a:avLst/>
-          </a:prstGeom>
-        </p:spPr>
-        <p:txBody>
-          <a:bodyPr vert="horz" lIns="91440" tIns="45720" rIns="91440" bIns="45720" rtlCol="0" anchor="b"/>
-          <a:lstStyle>
-            <a:lvl1pPr algn="r">
-              <a:defRPr sz="1200"/>
-            </a:lvl1pPr>
-          </a:lstStyle>
-          <a:p>
-            <a:fld id="{CE5E9CC1-C706-0F49-92D6-E571CC5EEA8F}" type="slidenum">
-              <a:rPr lang="en-US"/>
-              <a:t>‹#›</a:t>
-            </a:fld>
-            <a:endParaRPr lang="en-US"/>
-          </a:p>
-        </p:txBody>
-      </p:sp>
     </p:spTree>
     <p:extLst>
       <p:ext uri="{BB962C8B-B14F-4D97-AF65-F5344CB8AC3E}">
-        <p14:creationId xmlns:p14="http://schemas.microsoft.com/office/powerpoint/2010/main" val="1024086991"/>
+        <p14:creationId xmlns:p14="http://schemas.microsoft.com/office/powerpoint/2010/main" val="422320485"/>
       </p:ext>
     </p:extLst>
   </p:cSld>
@@ -507,10 +288,6 @@
           <a:bodyPr/>
           <a:lstStyle/>
           <a:p>
-            <a:r>
-              <a:rPr lang="en-US" dirty="0"/>
-              <a:t/>
-            </a:r>
             <a:endParaRPr lang="en-US" dirty="0"/>
           </a:p>
         </p:txBody>
@@ -595,10 +372,6 @@
           <a:bodyPr/>
           <a:lstStyle/>
           <a:p>
-            <a:r>
-              <a:rPr lang="en-US" dirty="0"/>
-              <a:t/>
-            </a:r>
             <a:endParaRPr lang="en-US" dirty="0"/>
           </a:p>
         </p:txBody>
@@ -683,10 +456,6 @@
           <a:bodyPr/>
           <a:lstStyle/>
           <a:p>
-            <a:r>
-              <a:rPr lang="en-US" dirty="0"/>
-              <a:t/>
-            </a:r>
             <a:endParaRPr lang="en-US" dirty="0"/>
           </a:p>
         </p:txBody>
@@ -771,10 +540,6 @@
           <a:bodyPr/>
           <a:lstStyle/>
           <a:p>
-            <a:r>
-              <a:rPr lang="en-US" dirty="0"/>
-              <a:t/>
-            </a:r>
             <a:endParaRPr lang="en-US" dirty="0"/>
           </a:p>
         </p:txBody>
@@ -859,10 +624,6 @@
           <a:bodyPr/>
           <a:lstStyle/>
           <a:p>
-            <a:r>
-              <a:rPr lang="en-US" dirty="0"/>
-              <a:t/>
-            </a:r>
             <a:endParaRPr lang="en-US" dirty="0"/>
           </a:p>
         </p:txBody>
@@ -947,10 +708,6 @@
           <a:bodyPr/>
           <a:lstStyle/>
           <a:p>
-            <a:r>
-              <a:rPr lang="en-US" dirty="0"/>
-              <a:t/>
-            </a:r>
             <a:endParaRPr lang="en-US" dirty="0"/>
           </a:p>
         </p:txBody>
@@ -1035,10 +792,6 @@
           <a:bodyPr/>
           <a:lstStyle/>
           <a:p>
-            <a:r>
-              <a:rPr lang="en-US" dirty="0"/>
-              <a:t/>
-            </a:r>
             <a:endParaRPr lang="en-US" dirty="0"/>
           </a:p>
         </p:txBody>
@@ -1123,10 +876,6 @@
           <a:bodyPr/>
           <a:lstStyle/>
           <a:p>
-            <a:r>
-              <a:rPr lang="en-US" dirty="0"/>
-              <a:t/>
-            </a:r>
             <a:endParaRPr lang="en-US" dirty="0"/>
           </a:p>
         </p:txBody>
@@ -1200,6 +949,11 @@
 <file path=ppt/slideMasters/slideMaster1.xml><?xml version="1.0" encoding="utf-8"?>
 <p:sldMaster xmlns:a="http://schemas.openxmlformats.org/drawingml/2006/main" xmlns:r="http://schemas.openxmlformats.org/officeDocument/2006/relationships" xmlns:p="http://schemas.openxmlformats.org/presentationml/2006/main">
   <p:cSld>
+    <p:bg>
+      <p:bgRef idx="1001">
+        <a:schemeClr val="bg1"/>
+      </p:bgRef>
+    </p:bg>
     <p:spTree>
       <p:nvGrpSpPr>
         <p:cNvPr id="1" name=""/>
@@ -1482,6 +1236,7 @@
         <a:solidFill>
           <a:srgbClr val="0D1B2A"/>
         </a:solidFill>
+        <a:effectLst/>
       </p:bgPr>
     </p:bg>
     <p:spTree>
@@ -1520,14 +1275,14 @@
       </p:sp>
       <p:pic>
         <p:nvPicPr>
-          <p:cNvPr id="3" name="Image 0" descr="D:\Dev\02_UNIVERSIDAD\FrostPuno\.claude\worktrees\flutter-frost-prediction-puno-d1a1d7\docs\presentacion\img\escudo_una.png">    </p:cNvPr>
+          <p:cNvPr id="3" name="Image 0" descr="D:\Dev\02_UNIVERSIDAD\FrostPuno\.claude\worktrees\flutter-frost-prediction-puno-d1a1d7\docs\presentacion\img\escudo_una.png"/>
           <p:cNvPicPr>
             <a:picLocks noChangeAspect="1"/>
           </p:cNvPicPr>
           <p:nvPr/>
         </p:nvPicPr>
         <p:blipFill>
-          <a:blip r:embed="rId1"/>
+          <a:blip r:embed="rId3"/>
           <a:stretch>
             <a:fillRect/>
           </a:stretch>
@@ -1563,7 +1318,7 @@
           <a:bodyPr wrap="square" rtlCol="0" anchor="ctr"/>
           <a:lstStyle/>
           <a:p>
-            <a:pPr algn="ctr" indent="0" marL="0">
+            <a:pPr marL="0" indent="0" algn="ctr">
               <a:lnSpc>
                 <a:spcPts val="1800"/>
               </a:lnSpc>
@@ -1583,7 +1338,7 @@
             <a:endParaRPr lang="en-US" sz="1200" dirty="0"/>
           </a:p>
           <a:p>
-            <a:pPr algn="ctr" indent="0" marL="0">
+            <a:pPr marL="0" indent="0" algn="ctr">
               <a:lnSpc>
                 <a:spcPts val="1800"/>
               </a:lnSpc>
@@ -1625,7 +1380,7 @@
           <a:bodyPr wrap="square" rtlCol="0" anchor="ctr"/>
           <a:lstStyle/>
           <a:p>
-            <a:pPr indent="0" marL="0">
+            <a:pPr marL="0" indent="0">
               <a:buNone/>
             </a:pPr>
             <a:r>
@@ -1664,7 +1419,7 @@
           <a:bodyPr wrap="square" rtlCol="0" anchor="ctr"/>
           <a:lstStyle/>
           <a:p>
-            <a:pPr indent="0" marL="0">
+            <a:pPr marL="0" indent="0">
               <a:lnSpc>
                 <a:spcPts val="2800"/>
               </a:lnSpc>
@@ -1684,7 +1439,7 @@
             <a:endParaRPr lang="en-US" sz="1800" dirty="0"/>
           </a:p>
           <a:p>
-            <a:pPr indent="0" marL="0">
+            <a:pPr marL="0" indent="0">
               <a:lnSpc>
                 <a:spcPts val="2800"/>
               </a:lnSpc>
@@ -1746,7 +1501,7 @@
           <a:bodyPr wrap="square" rtlCol="0" anchor="ctr"/>
           <a:lstStyle/>
           <a:p>
-            <a:pPr indent="0" marL="0">
+            <a:pPr marL="0" indent="0">
               <a:lnSpc>
                 <a:spcPts val="2800"/>
               </a:lnSpc>
@@ -1766,7 +1521,7 @@
             <a:endParaRPr lang="en-US" sz="1500" dirty="0"/>
           </a:p>
           <a:p>
-            <a:pPr indent="0" marL="0">
+            <a:pPr marL="0" indent="0">
               <a:lnSpc>
                 <a:spcPts val="2800"/>
               </a:lnSpc>
@@ -1830,7 +1585,7 @@
           <a:bodyPr wrap="square" rtlCol="0" anchor="ctr"/>
           <a:lstStyle/>
           <a:p>
-            <a:pPr indent="0" marL="0">
+            <a:pPr marL="0" indent="0">
               <a:buNone/>
             </a:pPr>
             <a:r>
@@ -1864,6 +1619,7 @@
         <a:solidFill>
           <a:srgbClr val="F9F9F9"/>
         </a:solidFill>
+        <a:effectLst/>
       </p:bgPr>
     </p:bg>
     <p:spTree>
@@ -1921,11 +1677,11 @@
           <a:bodyPr wrap="square" rtlCol="0" anchor="ctr"/>
           <a:lstStyle/>
           <a:p>
-            <a:pPr algn="ctr" indent="0" marL="0">
-              <a:buNone/>
-            </a:pPr>
-            <a:r>
-              <a:rPr lang="en-US" sz="1200" b="1" spc="200" kern="0" dirty="0">
+            <a:pPr marL="0" indent="0" algn="ctr">
+              <a:buNone/>
+            </a:pPr>
+            <a:r>
+              <a:rPr lang="en-US" sz="1200" b="1" kern="0" spc="200" dirty="0">
                 <a:solidFill>
                   <a:srgbClr val="E0FBFC"/>
                 </a:solidFill>
@@ -1960,7 +1716,7 @@
           <a:bodyPr wrap="square" rtlCol="0" anchor="ctr"/>
           <a:lstStyle/>
           <a:p>
-            <a:pPr indent="0" marL="0">
+            <a:pPr marL="0" indent="0">
               <a:buNone/>
             </a:pPr>
             <a:r>
@@ -2026,11 +1782,11 @@
           <a:bodyPr wrap="square" rtlCol="0" anchor="ctr"/>
           <a:lstStyle/>
           <a:p>
-            <a:pPr indent="0" marL="0">
-              <a:buNone/>
-            </a:pPr>
-            <a:r>
-              <a:rPr lang="en-US" sz="1300" b="1" spc="150" kern="0" dirty="0">
+            <a:pPr marL="0" indent="0">
+              <a:buNone/>
+            </a:pPr>
+            <a:r>
+              <a:rPr lang="en-US" sz="1300" b="1" kern="0" spc="150" dirty="0">
                 <a:solidFill>
                   <a:srgbClr val="EE6C4D"/>
                 </a:solidFill>
@@ -2065,7 +1821,7 @@
           <a:bodyPr wrap="square" rtlCol="0" anchor="ctr"/>
           <a:lstStyle/>
           <a:p>
-            <a:pPr indent="0" marL="0">
+            <a:pPr marL="0" indent="0">
               <a:lnSpc>
                 <a:spcPts val="2800"/>
               </a:lnSpc>
@@ -2085,7 +1841,7 @@
             <a:endParaRPr lang="en-US" sz="1500" dirty="0"/>
           </a:p>
           <a:p>
-            <a:pPr indent="0" marL="0">
+            <a:pPr marL="0" indent="0">
               <a:lnSpc>
                 <a:spcPts val="2800"/>
               </a:lnSpc>
@@ -2154,11 +1910,11 @@
           <a:bodyPr wrap="square" rtlCol="0" anchor="ctr"/>
           <a:lstStyle/>
           <a:p>
-            <a:pPr indent="0" marL="0">
-              <a:buNone/>
-            </a:pPr>
-            <a:r>
-              <a:rPr lang="en-US" sz="1300" b="1" spc="150" kern="0" dirty="0">
+            <a:pPr marL="0" indent="0">
+              <a:buNone/>
+            </a:pPr>
+            <a:r>
+              <a:rPr lang="en-US" sz="1300" b="1" kern="0" spc="150" dirty="0">
                 <a:solidFill>
                   <a:srgbClr val="1F6F78"/>
                 </a:solidFill>
@@ -2193,7 +1949,7 @@
           <a:bodyPr wrap="square" rtlCol="0" anchor="ctr"/>
           <a:lstStyle/>
           <a:p>
-            <a:pPr indent="0" marL="0">
+            <a:pPr marL="0" indent="0">
               <a:lnSpc>
                 <a:spcPts val="2800"/>
               </a:lnSpc>
@@ -2213,7 +1969,7 @@
             <a:endParaRPr lang="en-US" sz="1500" dirty="0"/>
           </a:p>
           <a:p>
-            <a:pPr indent="0" marL="0">
+            <a:pPr marL="0" indent="0">
               <a:lnSpc>
                 <a:spcPts val="2800"/>
               </a:lnSpc>
@@ -2277,7 +2033,7 @@
           <a:bodyPr wrap="square" rtlCol="0" anchor="ctr"/>
           <a:lstStyle/>
           <a:p>
-            <a:pPr indent="0" marL="0">
+            <a:pPr marL="0" indent="0">
               <a:buNone/>
             </a:pPr>
             <a:r>
@@ -2316,7 +2072,7 @@
           <a:bodyPr wrap="square" rtlCol="0" anchor="ctr"/>
           <a:lstStyle/>
           <a:p>
-            <a:pPr indent="0" marL="0">
+            <a:pPr marL="0" indent="0">
               <a:lnSpc>
                 <a:spcPts val="2600"/>
               </a:lnSpc>
@@ -2336,7 +2092,7 @@
             <a:endParaRPr lang="en-US" sz="1500" dirty="0"/>
           </a:p>
           <a:p>
-            <a:pPr indent="0" marL="0">
+            <a:pPr marL="0" indent="0">
               <a:lnSpc>
                 <a:spcPts val="2600"/>
               </a:lnSpc>
@@ -2381,14 +2137,14 @@
       </p:sp>
       <p:pic>
         <p:nvPicPr>
-          <p:cNvPr id="15" name="Image 0" descr="D:\Dev\02_UNIVERSIDAD\FrostPuno\.claude\worktrees\flutter-frost-prediction-puno-d1a1d7\docs\presentacion\img\chuno.png">    </p:cNvPr>
+          <p:cNvPr id="15" name="Image 0" descr="D:\Dev\02_UNIVERSIDAD\FrostPuno\.claude\worktrees\flutter-frost-prediction-puno-d1a1d7\docs\presentacion\img\chuno.png"/>
           <p:cNvPicPr>
             <a:picLocks noChangeAspect="1"/>
           </p:cNvPicPr>
           <p:nvPr/>
         </p:nvPicPr>
         <p:blipFill>
-          <a:blip r:embed="rId1"/>
+          <a:blip r:embed="rId3"/>
           <a:stretch>
             <a:fillRect/>
           </a:stretch>
@@ -2419,6 +2175,7 @@
         <a:solidFill>
           <a:srgbClr val="F9F9F9"/>
         </a:solidFill>
+        <a:effectLst/>
       </p:bgPr>
     </p:bg>
     <p:spTree>
@@ -2476,11 +2233,11 @@
           <a:bodyPr wrap="square" rtlCol="0" anchor="ctr"/>
           <a:lstStyle/>
           <a:p>
-            <a:pPr algn="ctr" indent="0" marL="0">
-              <a:buNone/>
-            </a:pPr>
-            <a:r>
-              <a:rPr lang="en-US" sz="1200" b="1" spc="200" kern="0" dirty="0">
+            <a:pPr marL="0" indent="0" algn="ctr">
+              <a:buNone/>
+            </a:pPr>
+            <a:r>
+              <a:rPr lang="en-US" sz="1200" b="1" kern="0" spc="200" dirty="0">
                 <a:solidFill>
                   <a:srgbClr val="E0FBFC"/>
                 </a:solidFill>
@@ -2515,7 +2272,7 @@
           <a:bodyPr wrap="square" rtlCol="0" anchor="ctr"/>
           <a:lstStyle/>
           <a:p>
-            <a:pPr indent="0" marL="0">
+            <a:pPr marL="0" indent="0">
               <a:buNone/>
             </a:pPr>
             <a:r>
@@ -2601,7 +2358,7 @@
           <a:bodyPr wrap="square" rtlCol="0" anchor="ctr"/>
           <a:lstStyle/>
           <a:p>
-            <a:pPr algn="ctr" indent="0" marL="0">
+            <a:pPr marL="0" indent="0" algn="ctr">
               <a:buNone/>
             </a:pPr>
             <a:r>
@@ -2640,7 +2397,7 @@
           <a:bodyPr wrap="square" rtlCol="0" anchor="ctr"/>
           <a:lstStyle/>
           <a:p>
-            <a:pPr indent="0" marL="0">
+            <a:pPr marL="0" indent="0">
               <a:buNone/>
             </a:pPr>
             <a:r>
@@ -2679,7 +2436,7 @@
           <a:bodyPr wrap="square" rtlCol="0" anchor="ctr"/>
           <a:lstStyle/>
           <a:p>
-            <a:pPr indent="0" marL="0">
+            <a:pPr marL="0" indent="0">
               <a:buNone/>
             </a:pPr>
             <a:r>
@@ -2718,7 +2475,7 @@
           <a:bodyPr wrap="square" rtlCol="0" anchor="ctr"/>
           <a:lstStyle/>
           <a:p>
-            <a:pPr algn="r" indent="0" marL="0">
+            <a:pPr marL="0" indent="0" algn="r">
               <a:buNone/>
             </a:pPr>
             <a:r>
@@ -2804,7 +2561,7 @@
           <a:bodyPr wrap="square" rtlCol="0" anchor="ctr"/>
           <a:lstStyle/>
           <a:p>
-            <a:pPr algn="ctr" indent="0" marL="0">
+            <a:pPr marL="0" indent="0" algn="ctr">
               <a:buNone/>
             </a:pPr>
             <a:r>
@@ -2843,7 +2600,7 @@
           <a:bodyPr wrap="square" rtlCol="0" anchor="ctr"/>
           <a:lstStyle/>
           <a:p>
-            <a:pPr indent="0" marL="0">
+            <a:pPr marL="0" indent="0">
               <a:buNone/>
             </a:pPr>
             <a:r>
@@ -2882,7 +2639,7 @@
           <a:bodyPr wrap="square" rtlCol="0" anchor="ctr"/>
           <a:lstStyle/>
           <a:p>
-            <a:pPr indent="0" marL="0">
+            <a:pPr marL="0" indent="0">
               <a:buNone/>
             </a:pPr>
             <a:r>
@@ -2921,7 +2678,7 @@
           <a:bodyPr wrap="square" rtlCol="0" anchor="ctr"/>
           <a:lstStyle/>
           <a:p>
-            <a:pPr algn="r" indent="0" marL="0">
+            <a:pPr marL="0" indent="0" algn="r">
               <a:buNone/>
             </a:pPr>
             <a:r>
@@ -3007,7 +2764,7 @@
           <a:bodyPr wrap="square" rtlCol="0" anchor="ctr"/>
           <a:lstStyle/>
           <a:p>
-            <a:pPr algn="ctr" indent="0" marL="0">
+            <a:pPr marL="0" indent="0" algn="ctr">
               <a:buNone/>
             </a:pPr>
             <a:r>
@@ -3046,7 +2803,7 @@
           <a:bodyPr wrap="square" rtlCol="0" anchor="ctr"/>
           <a:lstStyle/>
           <a:p>
-            <a:pPr indent="0" marL="0">
+            <a:pPr marL="0" indent="0">
               <a:buNone/>
             </a:pPr>
             <a:r>
@@ -3085,7 +2842,7 @@
           <a:bodyPr wrap="square" rtlCol="0" anchor="ctr"/>
           <a:lstStyle/>
           <a:p>
-            <a:pPr indent="0" marL="0">
+            <a:pPr marL="0" indent="0">
               <a:buNone/>
             </a:pPr>
             <a:r>
@@ -3124,7 +2881,7 @@
           <a:bodyPr wrap="square" rtlCol="0" anchor="ctr"/>
           <a:lstStyle/>
           <a:p>
-            <a:pPr algn="r" indent="0" marL="0">
+            <a:pPr marL="0" indent="0" algn="r">
               <a:buNone/>
             </a:pPr>
             <a:r>
@@ -3166,14 +2923,14 @@
       </p:sp>
       <p:pic>
         <p:nvPicPr>
-          <p:cNvPr id="24" name="Image 0" descr="D:\Dev\02_UNIVERSIDAD\FrostPuno\.claude\worktrees\flutter-frost-prediction-puno-d1a1d7\docs\presentacion\img\home_oscuro.png">    </p:cNvPr>
+          <p:cNvPr id="24" name="Image 0" descr="D:\Dev\02_UNIVERSIDAD\FrostPuno\.claude\worktrees\flutter-frost-prediction-puno-d1a1d7\docs\presentacion\img\home_oscuro.png"/>
           <p:cNvPicPr>
             <a:picLocks noChangeAspect="1"/>
           </p:cNvPicPr>
           <p:nvPr/>
         </p:nvPicPr>
         <p:blipFill>
-          <a:blip r:embed="rId1"/>
+          <a:blip r:embed="rId3"/>
           <a:stretch>
             <a:fillRect/>
           </a:stretch>
@@ -3209,7 +2966,7 @@
           <a:bodyPr wrap="square" rtlCol="0" anchor="ctr"/>
           <a:lstStyle/>
           <a:p>
-            <a:pPr algn="ctr" indent="0" marL="0">
+            <a:pPr marL="0" indent="0" algn="ctr">
               <a:buNone/>
             </a:pPr>
             <a:r>
@@ -3243,6 +3000,7 @@
         <a:solidFill>
           <a:srgbClr val="F9F9F9"/>
         </a:solidFill>
+        <a:effectLst/>
       </p:bgPr>
     </p:bg>
     <p:spTree>
@@ -3300,11 +3058,11 @@
           <a:bodyPr wrap="square" rtlCol="0" anchor="ctr"/>
           <a:lstStyle/>
           <a:p>
-            <a:pPr algn="ctr" indent="0" marL="0">
-              <a:buNone/>
-            </a:pPr>
-            <a:r>
-              <a:rPr lang="en-US" sz="1200" b="1" spc="200" kern="0" dirty="0">
+            <a:pPr marL="0" indent="0" algn="ctr">
+              <a:buNone/>
+            </a:pPr>
+            <a:r>
+              <a:rPr lang="en-US" sz="1200" b="1" kern="0" spc="200" dirty="0">
                 <a:solidFill>
                   <a:srgbClr val="E0FBFC"/>
                 </a:solidFill>
@@ -3339,7 +3097,7 @@
           <a:bodyPr wrap="square" rtlCol="0" anchor="ctr"/>
           <a:lstStyle/>
           <a:p>
-            <a:pPr indent="0" marL="0">
+            <a:pPr marL="0" indent="0">
               <a:buNone/>
             </a:pPr>
             <a:r>
@@ -3405,7 +3163,7 @@
           <a:bodyPr wrap="square" rtlCol="0" anchor="ctr"/>
           <a:lstStyle/>
           <a:p>
-            <a:pPr algn="ctr" indent="0" marL="0">
+            <a:pPr marL="0" indent="0" algn="ctr">
               <a:buNone/>
             </a:pPr>
             <a:r>
@@ -3444,7 +3202,7 @@
           <a:bodyPr wrap="square" rtlCol="0" anchor="ctr"/>
           <a:lstStyle/>
           <a:p>
-            <a:pPr algn="ctr" indent="0" marL="0">
+            <a:pPr marL="0" indent="0" algn="ctr">
               <a:lnSpc>
                 <a:spcPts val="2000"/>
               </a:lnSpc>
@@ -3464,7 +3222,7 @@
             <a:endParaRPr lang="en-US" sz="1300" dirty="0"/>
           </a:p>
           <a:p>
-            <a:pPr algn="ctr" indent="0" marL="0">
+            <a:pPr marL="0" indent="0" algn="ctr">
               <a:lnSpc>
                 <a:spcPts val="2000"/>
               </a:lnSpc>
@@ -3506,7 +3264,7 @@
           <a:bodyPr wrap="square" rtlCol="0" anchor="ctr"/>
           <a:lstStyle/>
           <a:p>
-            <a:pPr algn="ctr" indent="0" marL="0">
+            <a:pPr marL="0" indent="0" algn="ctr">
               <a:buNone/>
             </a:pPr>
             <a:r>
@@ -3572,7 +3330,7 @@
           <a:bodyPr wrap="square" rtlCol="0" anchor="ctr"/>
           <a:lstStyle/>
           <a:p>
-            <a:pPr algn="ctr" indent="0" marL="0">
+            <a:pPr marL="0" indent="0" algn="ctr">
               <a:buNone/>
             </a:pPr>
             <a:r>
@@ -3611,7 +3369,7 @@
           <a:bodyPr wrap="square" rtlCol="0" anchor="ctr"/>
           <a:lstStyle/>
           <a:p>
-            <a:pPr algn="ctr" indent="0" marL="0">
+            <a:pPr marL="0" indent="0" algn="ctr">
               <a:lnSpc>
                 <a:spcPts val="2000"/>
               </a:lnSpc>
@@ -3631,7 +3389,7 @@
             <a:endParaRPr lang="en-US" sz="1300" dirty="0"/>
           </a:p>
           <a:p>
-            <a:pPr algn="ctr" indent="0" marL="0">
+            <a:pPr marL="0" indent="0" algn="ctr">
               <a:lnSpc>
                 <a:spcPts val="2000"/>
               </a:lnSpc>
@@ -3673,7 +3431,7 @@
           <a:bodyPr wrap="square" rtlCol="0" anchor="ctr"/>
           <a:lstStyle/>
           <a:p>
-            <a:pPr algn="ctr" indent="0" marL="0">
+            <a:pPr marL="0" indent="0" algn="ctr">
               <a:buNone/>
             </a:pPr>
             <a:r>
@@ -3739,7 +3497,7 @@
           <a:bodyPr wrap="square" rtlCol="0" anchor="ctr"/>
           <a:lstStyle/>
           <a:p>
-            <a:pPr algn="ctr" indent="0" marL="0">
+            <a:pPr marL="0" indent="0" algn="ctr">
               <a:buNone/>
             </a:pPr>
             <a:r>
@@ -3778,7 +3536,7 @@
           <a:bodyPr wrap="square" rtlCol="0" anchor="ctr"/>
           <a:lstStyle/>
           <a:p>
-            <a:pPr algn="ctr" indent="0" marL="0">
+            <a:pPr marL="0" indent="0" algn="ctr">
               <a:lnSpc>
                 <a:spcPts val="2000"/>
               </a:lnSpc>
@@ -3798,7 +3556,7 @@
             <a:endParaRPr lang="en-US" sz="1300" dirty="0"/>
           </a:p>
           <a:p>
-            <a:pPr algn="ctr" indent="0" marL="0">
+            <a:pPr marL="0" indent="0" algn="ctr">
               <a:lnSpc>
                 <a:spcPts val="2000"/>
               </a:lnSpc>
@@ -3840,7 +3598,7 @@
           <a:bodyPr wrap="square" rtlCol="0" anchor="ctr"/>
           <a:lstStyle/>
           <a:p>
-            <a:pPr algn="ctr" indent="0" marL="0">
+            <a:pPr marL="0" indent="0" algn="ctr">
               <a:buNone/>
             </a:pPr>
             <a:r>
@@ -3906,7 +3664,7 @@
           <a:bodyPr wrap="square" rtlCol="0" anchor="ctr"/>
           <a:lstStyle/>
           <a:p>
-            <a:pPr algn="ctr" indent="0" marL="0">
+            <a:pPr marL="0" indent="0" algn="ctr">
               <a:buNone/>
             </a:pPr>
             <a:r>
@@ -3945,7 +3703,7 @@
           <a:bodyPr wrap="square" rtlCol="0" anchor="ctr"/>
           <a:lstStyle/>
           <a:p>
-            <a:pPr algn="ctr" indent="0" marL="0">
+            <a:pPr marL="0" indent="0" algn="ctr">
               <a:lnSpc>
                 <a:spcPts val="2000"/>
               </a:lnSpc>
@@ -3965,7 +3723,7 @@
             <a:endParaRPr lang="en-US" sz="1300" dirty="0"/>
           </a:p>
           <a:p>
-            <a:pPr algn="ctr" indent="0" marL="0">
+            <a:pPr marL="0" indent="0" algn="ctr">
               <a:lnSpc>
                 <a:spcPts val="2000"/>
               </a:lnSpc>
@@ -4029,7 +3787,7 @@
           <a:bodyPr wrap="square" rtlCol="0" anchor="ctr"/>
           <a:lstStyle/>
           <a:p>
-            <a:pPr indent="0" marL="0">
+            <a:pPr marL="0" indent="0">
               <a:lnSpc>
                 <a:spcPts val="2600"/>
               </a:lnSpc>
@@ -4046,12 +3804,6 @@
               </a:rPr>
               <a:t>La clave del diseño:  </a:t>
             </a:r>
-            <a:pPr indent="0" marL="0">
-              <a:lnSpc>
-                <a:spcPts val="2600"/>
-              </a:lnSpc>
-              <a:buNone/>
-            </a:pPr>
             <a:r>
               <a:rPr lang="en-US" sz="1600" dirty="0">
                 <a:solidFill>
@@ -4088,7 +3840,7 @@
           <a:bodyPr wrap="square" rtlCol="0" anchor="ctr"/>
           <a:lstStyle/>
           <a:p>
-            <a:pPr indent="0" marL="0">
+            <a:pPr marL="0" indent="0">
               <a:buNone/>
             </a:pPr>
             <a:r>
@@ -4122,6 +3874,7 @@
         <a:solidFill>
           <a:srgbClr val="F9F9F9"/>
         </a:solidFill>
+        <a:effectLst/>
       </p:bgPr>
     </p:bg>
     <p:spTree>
@@ -4179,11 +3932,11 @@
           <a:bodyPr wrap="square" rtlCol="0" anchor="ctr"/>
           <a:lstStyle/>
           <a:p>
-            <a:pPr algn="ctr" indent="0" marL="0">
-              <a:buNone/>
-            </a:pPr>
-            <a:r>
-              <a:rPr lang="en-US" sz="1200" b="1" spc="200" kern="0" dirty="0">
+            <a:pPr marL="0" indent="0" algn="ctr">
+              <a:buNone/>
+            </a:pPr>
+            <a:r>
+              <a:rPr lang="en-US" sz="1200" b="1" kern="0" spc="200" dirty="0">
                 <a:solidFill>
                   <a:srgbClr val="E0FBFC"/>
                 </a:solidFill>
@@ -4221,14 +3974,14 @@
       </p:sp>
       <p:pic>
         <p:nvPicPr>
-          <p:cNvPr id="5" name="Image 0" descr="D:\Dev\02_UNIVERSIDAD\FrostPuno\.claude\worktrees\flutter-frost-prediction-puno-d1a1d7\docs\presentacion\img\zonas_kmeans.png">    </p:cNvPr>
+          <p:cNvPr id="5" name="Image 0" descr="D:\Dev\02_UNIVERSIDAD\FrostPuno\.claude\worktrees\flutter-frost-prediction-puno-d1a1d7\docs\presentacion\img\zonas_kmeans.png"/>
           <p:cNvPicPr>
             <a:picLocks noChangeAspect="1"/>
           </p:cNvPicPr>
           <p:nvPr/>
         </p:nvPicPr>
         <p:blipFill>
-          <a:blip r:embed="rId1"/>
+          <a:blip r:embed="rId3"/>
           <a:stretch>
             <a:fillRect/>
           </a:stretch>
@@ -4264,7 +4017,7 @@
           <a:bodyPr wrap="square" rtlCol="0" anchor="ctr"/>
           <a:lstStyle/>
           <a:p>
-            <a:pPr indent="0" marL="0">
+            <a:pPr marL="0" indent="0">
               <a:buNone/>
             </a:pPr>
             <a:r>
@@ -4303,7 +4056,7 @@
           <a:bodyPr wrap="square" rtlCol="0" anchor="ctr"/>
           <a:lstStyle/>
           <a:p>
-            <a:pPr indent="0" marL="0">
+            <a:pPr marL="0" indent="0">
               <a:lnSpc>
                 <a:spcPts val="2400"/>
               </a:lnSpc>
@@ -4323,7 +4076,7 @@
             <a:endParaRPr lang="en-US" sz="1500" dirty="0"/>
           </a:p>
           <a:p>
-            <a:pPr indent="0" marL="0">
+            <a:pPr marL="0" indent="0">
               <a:lnSpc>
                 <a:spcPts val="2400"/>
               </a:lnSpc>
@@ -4387,7 +4140,7 @@
           <a:bodyPr wrap="square" rtlCol="0" anchor="ctr"/>
           <a:lstStyle/>
           <a:p>
-            <a:pPr algn="ctr" indent="0" marL="0">
+            <a:pPr marL="0" indent="0" algn="ctr">
               <a:buNone/>
             </a:pPr>
             <a:r>
@@ -4426,7 +4179,7 @@
           <a:bodyPr wrap="square" rtlCol="0" anchor="ctr"/>
           <a:lstStyle/>
           <a:p>
-            <a:pPr algn="ctr" indent="0" marL="0">
+            <a:pPr marL="0" indent="0" algn="ctr">
               <a:buNone/>
             </a:pPr>
             <a:r>
@@ -4487,7 +4240,7 @@
           <a:bodyPr wrap="square" rtlCol="0" anchor="ctr"/>
           <a:lstStyle/>
           <a:p>
-            <a:pPr algn="ctr" indent="0" marL="0">
+            <a:pPr marL="0" indent="0" algn="ctr">
               <a:buNone/>
             </a:pPr>
             <a:r>
@@ -4526,7 +4279,7 @@
           <a:bodyPr wrap="square" rtlCol="0" anchor="ctr"/>
           <a:lstStyle/>
           <a:p>
-            <a:pPr algn="ctr" indent="0" marL="0">
+            <a:pPr marL="0" indent="0" algn="ctr">
               <a:buNone/>
             </a:pPr>
             <a:r>
@@ -4587,7 +4340,7 @@
           <a:bodyPr wrap="square" rtlCol="0" anchor="ctr"/>
           <a:lstStyle/>
           <a:p>
-            <a:pPr algn="ctr" indent="0" marL="0">
+            <a:pPr marL="0" indent="0" algn="ctr">
               <a:buNone/>
             </a:pPr>
             <a:r>
@@ -4626,7 +4379,7 @@
           <a:bodyPr wrap="square" rtlCol="0" anchor="ctr"/>
           <a:lstStyle/>
           <a:p>
-            <a:pPr algn="ctr" indent="0" marL="0">
+            <a:pPr marL="0" indent="0" algn="ctr">
               <a:buNone/>
             </a:pPr>
             <a:r>
@@ -4692,7 +4445,7 @@
           <a:bodyPr wrap="square" rtlCol="0" anchor="ctr"/>
           <a:lstStyle/>
           <a:p>
-            <a:pPr indent="0" marL="0">
+            <a:pPr marL="0" indent="0">
               <a:lnSpc>
                 <a:spcPts val="2600"/>
               </a:lnSpc>
@@ -4709,12 +4462,6 @@
               </a:rPr>
               <a:t>Macusani</a:t>
             </a:r>
-            <a:pPr indent="0" marL="0">
-              <a:lnSpc>
-                <a:spcPts val="2600"/>
-              </a:lnSpc>
-              <a:buNone/>
-            </a:pPr>
             <a:r>
               <a:rPr lang="en-US" sz="1500" dirty="0">
                 <a:solidFill>
@@ -4727,12 +4474,6 @@
               <a:t> (4 315 m) queda en riesgo alto,
 </a:t>
             </a:r>
-            <a:pPr indent="0" marL="0">
-              <a:lnSpc>
-                <a:spcPts val="2600"/>
-              </a:lnSpc>
-              <a:buNone/>
-            </a:pPr>
             <a:r>
               <a:rPr lang="en-US" sz="1500" b="1" dirty="0">
                 <a:solidFill>
@@ -4744,12 +4485,6 @@
               </a:rPr>
               <a:t>Sandia</a:t>
             </a:r>
-            <a:pPr indent="0" marL="0">
-              <a:lnSpc>
-                <a:spcPts val="2600"/>
-              </a:lnSpc>
-              <a:buNone/>
-            </a:pPr>
             <a:r>
               <a:rPr lang="en-US" sz="1500" dirty="0">
                 <a:solidFill>
@@ -4760,24 +4495,7 @@
                 <a:cs typeface="Calibri" pitchFamily="34" charset="-120"/>
               </a:rPr>
               <a:t> (2 170 m, en valle) en riesgo bajo.
-</a:t>
-            </a:r>
-            <a:pPr indent="0" marL="0">
-              <a:lnSpc>
-                <a:spcPts val="2600"/>
-              </a:lnSpc>
-              <a:buNone/>
-            </a:pPr>
-            <a:r>
-              <a:rPr lang="en-US" sz="1500" dirty="0">
-                <a:solidFill>
-                  <a:srgbClr val="1A1C1C"/>
-                </a:solidFill>
-                <a:latin typeface="Calibri" pitchFamily="34" charset="0"/>
-                <a:ea typeface="Calibri" pitchFamily="34" charset="-122"/>
-                <a:cs typeface="Calibri" pitchFamily="34" charset="-120"/>
-              </a:rPr>
-              <a:t>Coincide con la geografia, y no lo programamos.</a:t>
+Coincide con la geografia, y no lo programamos.</a:t>
             </a:r>
             <a:endParaRPr lang="en-US" sz="1500" dirty="0"/>
           </a:p>
@@ -4799,6 +4517,7 @@
         <a:solidFill>
           <a:srgbClr val="F9F9F9"/>
         </a:solidFill>
+        <a:effectLst/>
       </p:bgPr>
     </p:bg>
     <p:spTree>
@@ -4856,11 +4575,11 @@
           <a:bodyPr wrap="square" rtlCol="0" anchor="ctr"/>
           <a:lstStyle/>
           <a:p>
-            <a:pPr algn="ctr" indent="0" marL="0">
-              <a:buNone/>
-            </a:pPr>
-            <a:r>
-              <a:rPr lang="en-US" sz="1200" b="1" spc="200" kern="0" dirty="0">
+            <a:pPr marL="0" indent="0" algn="ctr">
+              <a:buNone/>
+            </a:pPr>
+            <a:r>
+              <a:rPr lang="en-US" sz="1200" b="1" kern="0" spc="200" dirty="0">
                 <a:solidFill>
                   <a:srgbClr val="E0FBFC"/>
                 </a:solidFill>
@@ -4895,7 +4614,7 @@
           <a:bodyPr wrap="square" rtlCol="0" anchor="ctr"/>
           <a:lstStyle/>
           <a:p>
-            <a:pPr indent="0" marL="0">
+            <a:pPr marL="0" indent="0">
               <a:buNone/>
             </a:pPr>
             <a:r>
@@ -4921,7 +4640,7 @@
         </p:nvSpPr>
         <p:spPr>
           <a:xfrm>
-            <a:off x="1143000" y="1170432"/>
+            <a:off x="1150815" y="1178247"/>
             <a:ext cx="9921240" cy="411480"/>
           </a:xfrm>
           <a:prstGeom prst="rect">
@@ -4934,7 +4653,7 @@
           <a:bodyPr wrap="square" rtlCol="0" anchor="ctr"/>
           <a:lstStyle/>
           <a:p>
-            <a:pPr indent="0" marL="0">
+            <a:pPr marL="0" indent="0">
               <a:buNone/>
             </a:pPr>
             <a:r>
@@ -4975,9 +4694,27 @@
             <a:tbl>
               <a:tblPr/>
               <a:tblGrid>
-                <a:gridCol w="2148840"/>
-                <a:gridCol w="3017520"/>
-                <a:gridCol w="1371600"/>
+                <a:gridCol w="2148840">
+                  <a:extLst>
+                    <a:ext uri="{9D8B030D-6E8A-4147-A177-3AD203B41FA5}">
+                      <a16:colId xmlns:a16="http://schemas.microsoft.com/office/drawing/2014/main" val="20000"/>
+                    </a:ext>
+                  </a:extLst>
+                </a:gridCol>
+                <a:gridCol w="3017520">
+                  <a:extLst>
+                    <a:ext uri="{9D8B030D-6E8A-4147-A177-3AD203B41FA5}">
+                      <a16:colId xmlns:a16="http://schemas.microsoft.com/office/drawing/2014/main" val="20001"/>
+                    </a:ext>
+                  </a:extLst>
+                </a:gridCol>
+                <a:gridCol w="1371600">
+                  <a:extLst>
+                    <a:ext uri="{9D8B030D-6E8A-4147-A177-3AD203B41FA5}">
+                      <a16:colId xmlns:a16="http://schemas.microsoft.com/office/drawing/2014/main" val="20002"/>
+                    </a:ext>
+                  </a:extLst>
+                </a:gridCol>
               </a:tblGrid>
               <a:tr h="420624">
                 <a:tc>
@@ -4985,7 +4722,7 @@
                     <a:bodyPr/>
                     <a:lstStyle/>
                     <a:p>
-                      <a:pPr indent="0" marL="0">
+                      <a:pPr marL="0" indent="0">
                         <a:buNone/>
                       </a:pPr>
                       <a:r>
@@ -5006,7 +4743,7 @@
                       </a:endParaRPr>
                     </a:p>
                   </a:txBody>
-                  <a:tcPr marL="91440" marR="91440" marT="45720" marB="45720" anchor="ctr">
+                  <a:tcPr anchor="ctr">
                     <a:lnL w="12700" cap="flat" cmpd="sng" algn="ctr">
                       <a:solidFill>
                         <a:srgbClr val="E1E5E8"/>
@@ -5053,7 +4790,7 @@
                     <a:bodyPr/>
                     <a:lstStyle/>
                     <a:p>
-                      <a:pPr indent="0" marL="0">
+                      <a:pPr marL="0" indent="0">
                         <a:buNone/>
                       </a:pPr>
                       <a:r>
@@ -5074,7 +4811,7 @@
                       </a:endParaRPr>
                     </a:p>
                   </a:txBody>
-                  <a:tcPr marL="91440" marR="91440" marT="45720" marB="45720" anchor="ctr">
+                  <a:tcPr anchor="ctr">
                     <a:lnL w="12700" cap="flat" cmpd="sng" algn="ctr">
                       <a:solidFill>
                         <a:srgbClr val="E1E5E8"/>
@@ -5121,7 +4858,7 @@
                     <a:bodyPr/>
                     <a:lstStyle/>
                     <a:p>
-                      <a:pPr indent="0" marL="0">
+                      <a:pPr marL="0" indent="0">
                         <a:buNone/>
                       </a:pPr>
                       <a:r>
@@ -5142,7 +4879,7 @@
                       </a:endParaRPr>
                     </a:p>
                   </a:txBody>
-                  <a:tcPr marL="91440" marR="91440" marT="45720" marB="45720" anchor="ctr">
+                  <a:tcPr anchor="ctr">
                     <a:lnL w="12700" cap="flat" cmpd="sng" algn="ctr">
                       <a:solidFill>
                         <a:srgbClr val="E1E5E8"/>
@@ -5184,6 +4921,11 @@
                     </a:solidFill>
                   </a:tcPr>
                 </a:tc>
+                <a:extLst>
+                  <a:ext uri="{0D108BD9-81ED-4DB2-BD59-A6C34878D82A}">
+                    <a16:rowId xmlns:a16="http://schemas.microsoft.com/office/drawing/2014/main" val="10000"/>
+                  </a:ext>
+                </a:extLst>
               </a:tr>
               <a:tr h="420624">
                 <a:tc>
@@ -5191,7 +4933,7 @@
                     <a:bodyPr/>
                     <a:lstStyle/>
                     <a:p>
-                      <a:pPr indent="0" marL="0">
+                      <a:pPr marL="0" indent="0">
                         <a:buNone/>
                       </a:pPr>
                       <a:r>
@@ -5212,7 +4954,7 @@
                       </a:endParaRPr>
                     </a:p>
                   </a:txBody>
-                  <a:tcPr marL="91440" marR="91440" marT="45720" marB="45720" anchor="ctr">
+                  <a:tcPr anchor="ctr">
                     <a:lnL w="12700" cap="flat" cmpd="sng" algn="ctr">
                       <a:solidFill>
                         <a:srgbClr val="E1E5E8"/>
@@ -5259,7 +5001,7 @@
                     <a:bodyPr/>
                     <a:lstStyle/>
                     <a:p>
-                      <a:pPr indent="0" marL="0">
+                      <a:pPr marL="0" indent="0">
                         <a:buNone/>
                       </a:pPr>
                       <a:r>
@@ -5280,7 +5022,7 @@
                       </a:endParaRPr>
                     </a:p>
                   </a:txBody>
-                  <a:tcPr marL="91440" marR="91440" marT="45720" marB="45720" anchor="ctr">
+                  <a:tcPr anchor="ctr">
                     <a:lnL w="12700" cap="flat" cmpd="sng" algn="ctr">
                       <a:solidFill>
                         <a:srgbClr val="E1E5E8"/>
@@ -5327,7 +5069,7 @@
                     <a:bodyPr/>
                     <a:lstStyle/>
                     <a:p>
-                      <a:pPr indent="0" marL="0">
+                      <a:pPr marL="0" indent="0">
                         <a:buNone/>
                       </a:pPr>
                       <a:r>
@@ -5348,7 +5090,7 @@
                       </a:endParaRPr>
                     </a:p>
                   </a:txBody>
-                  <a:tcPr marL="91440" marR="91440" marT="45720" marB="45720" anchor="ctr">
+                  <a:tcPr anchor="ctr">
                     <a:lnL w="12700" cap="flat" cmpd="sng" algn="ctr">
                       <a:solidFill>
                         <a:srgbClr val="E1E5E8"/>
@@ -5390,6 +5132,11 @@
                     </a:solidFill>
                   </a:tcPr>
                 </a:tc>
+                <a:extLst>
+                  <a:ext uri="{0D108BD9-81ED-4DB2-BD59-A6C34878D82A}">
+                    <a16:rowId xmlns:a16="http://schemas.microsoft.com/office/drawing/2014/main" val="10001"/>
+                  </a:ext>
+                </a:extLst>
               </a:tr>
               <a:tr h="420624">
                 <a:tc>
@@ -5397,7 +5144,7 @@
                     <a:bodyPr/>
                     <a:lstStyle/>
                     <a:p>
-                      <a:pPr indent="0" marL="0">
+                      <a:pPr marL="0" indent="0">
                         <a:buNone/>
                       </a:pPr>
                       <a:r>
@@ -5418,7 +5165,7 @@
                       </a:endParaRPr>
                     </a:p>
                   </a:txBody>
-                  <a:tcPr marL="91440" marR="91440" marT="45720" marB="45720" anchor="ctr">
+                  <a:tcPr anchor="ctr">
                     <a:lnL w="12700" cap="flat" cmpd="sng" algn="ctr">
                       <a:solidFill>
                         <a:srgbClr val="E1E5E8"/>
@@ -5465,7 +5212,7 @@
                     <a:bodyPr/>
                     <a:lstStyle/>
                     <a:p>
-                      <a:pPr indent="0" marL="0">
+                      <a:pPr marL="0" indent="0">
                         <a:buNone/>
                       </a:pPr>
                       <a:r>
@@ -5486,7 +5233,7 @@
                       </a:endParaRPr>
                     </a:p>
                   </a:txBody>
-                  <a:tcPr marL="91440" marR="91440" marT="45720" marB="45720" anchor="ctr">
+                  <a:tcPr anchor="ctr">
                     <a:lnL w="12700" cap="flat" cmpd="sng" algn="ctr">
                       <a:solidFill>
                         <a:srgbClr val="E1E5E8"/>
@@ -5533,7 +5280,7 @@
                     <a:bodyPr/>
                     <a:lstStyle/>
                     <a:p>
-                      <a:pPr indent="0" marL="0">
+                      <a:pPr marL="0" indent="0">
                         <a:buNone/>
                       </a:pPr>
                       <a:r>
@@ -5554,7 +5301,7 @@
                       </a:endParaRPr>
                     </a:p>
                   </a:txBody>
-                  <a:tcPr marL="91440" marR="91440" marT="45720" marB="45720" anchor="ctr">
+                  <a:tcPr anchor="ctr">
                     <a:lnL w="12700" cap="flat" cmpd="sng" algn="ctr">
                       <a:solidFill>
                         <a:srgbClr val="E1E5E8"/>
@@ -5596,6 +5343,11 @@
                     </a:solidFill>
                   </a:tcPr>
                 </a:tc>
+                <a:extLst>
+                  <a:ext uri="{0D108BD9-81ED-4DB2-BD59-A6C34878D82A}">
+                    <a16:rowId xmlns:a16="http://schemas.microsoft.com/office/drawing/2014/main" val="10002"/>
+                  </a:ext>
+                </a:extLst>
               </a:tr>
               <a:tr h="420624">
                 <a:tc>
@@ -5603,7 +5355,7 @@
                     <a:bodyPr/>
                     <a:lstStyle/>
                     <a:p>
-                      <a:pPr indent="0" marL="0">
+                      <a:pPr marL="0" indent="0">
                         <a:buNone/>
                       </a:pPr>
                       <a:r>
@@ -5624,7 +5376,7 @@
                       </a:endParaRPr>
                     </a:p>
                   </a:txBody>
-                  <a:tcPr marL="91440" marR="91440" marT="45720" marB="45720" anchor="ctr">
+                  <a:tcPr anchor="ctr">
                     <a:lnL w="12700" cap="flat" cmpd="sng" algn="ctr">
                       <a:solidFill>
                         <a:srgbClr val="E1E5E8"/>
@@ -5671,7 +5423,7 @@
                     <a:bodyPr/>
                     <a:lstStyle/>
                     <a:p>
-                      <a:pPr indent="0" marL="0">
+                      <a:pPr marL="0" indent="0">
                         <a:buNone/>
                       </a:pPr>
                       <a:r>
@@ -5692,7 +5444,7 @@
                       </a:endParaRPr>
                     </a:p>
                   </a:txBody>
-                  <a:tcPr marL="91440" marR="91440" marT="45720" marB="45720" anchor="ctr">
+                  <a:tcPr anchor="ctr">
                     <a:lnL w="12700" cap="flat" cmpd="sng" algn="ctr">
                       <a:solidFill>
                         <a:srgbClr val="E1E5E8"/>
@@ -5739,7 +5491,7 @@
                     <a:bodyPr/>
                     <a:lstStyle/>
                     <a:p>
-                      <a:pPr indent="0" marL="0">
+                      <a:pPr marL="0" indent="0">
                         <a:buNone/>
                       </a:pPr>
                       <a:r>
@@ -5760,7 +5512,7 @@
                       </a:endParaRPr>
                     </a:p>
                   </a:txBody>
-                  <a:tcPr marL="91440" marR="91440" marT="45720" marB="45720" anchor="ctr">
+                  <a:tcPr anchor="ctr">
                     <a:lnL w="12700" cap="flat" cmpd="sng" algn="ctr">
                       <a:solidFill>
                         <a:srgbClr val="E1E5E8"/>
@@ -5802,6 +5554,11 @@
                     </a:solidFill>
                   </a:tcPr>
                 </a:tc>
+                <a:extLst>
+                  <a:ext uri="{0D108BD9-81ED-4DB2-BD59-A6C34878D82A}">
+                    <a16:rowId xmlns:a16="http://schemas.microsoft.com/office/drawing/2014/main" val="10003"/>
+                  </a:ext>
+                </a:extLst>
               </a:tr>
               <a:tr h="420624">
                 <a:tc>
@@ -5809,7 +5566,7 @@
                     <a:bodyPr/>
                     <a:lstStyle/>
                     <a:p>
-                      <a:pPr indent="0" marL="0">
+                      <a:pPr marL="0" indent="0">
                         <a:buNone/>
                       </a:pPr>
                       <a:r>
@@ -5830,7 +5587,7 @@
                       </a:endParaRPr>
                     </a:p>
                   </a:txBody>
-                  <a:tcPr marL="91440" marR="91440" marT="45720" marB="45720" anchor="ctr">
+                  <a:tcPr anchor="ctr">
                     <a:lnL w="12700" cap="flat" cmpd="sng" algn="ctr">
                       <a:solidFill>
                         <a:srgbClr val="E1E5E8"/>
@@ -5877,7 +5634,7 @@
                     <a:bodyPr/>
                     <a:lstStyle/>
                     <a:p>
-                      <a:pPr indent="0" marL="0">
+                      <a:pPr marL="0" indent="0">
                         <a:buNone/>
                       </a:pPr>
                       <a:r>
@@ -5898,7 +5655,7 @@
                       </a:endParaRPr>
                     </a:p>
                   </a:txBody>
-                  <a:tcPr marL="91440" marR="91440" marT="45720" marB="45720" anchor="ctr">
+                  <a:tcPr anchor="ctr">
                     <a:lnL w="12700" cap="flat" cmpd="sng" algn="ctr">
                       <a:solidFill>
                         <a:srgbClr val="E1E5E8"/>
@@ -5945,7 +5702,7 @@
                     <a:bodyPr/>
                     <a:lstStyle/>
                     <a:p>
-                      <a:pPr indent="0" marL="0">
+                      <a:pPr marL="0" indent="0">
                         <a:buNone/>
                       </a:pPr>
                       <a:r>
@@ -5966,7 +5723,7 @@
                       </a:endParaRPr>
                     </a:p>
                   </a:txBody>
-                  <a:tcPr marL="91440" marR="91440" marT="45720" marB="45720" anchor="ctr">
+                  <a:tcPr anchor="ctr">
                     <a:lnL w="12700" cap="flat" cmpd="sng" algn="ctr">
                       <a:solidFill>
                         <a:srgbClr val="E1E5E8"/>
@@ -6008,6 +5765,11 @@
                     </a:solidFill>
                   </a:tcPr>
                 </a:tc>
+                <a:extLst>
+                  <a:ext uri="{0D108BD9-81ED-4DB2-BD59-A6C34878D82A}">
+                    <a16:rowId xmlns:a16="http://schemas.microsoft.com/office/drawing/2014/main" val="10004"/>
+                  </a:ext>
+                </a:extLst>
               </a:tr>
             </a:tbl>
           </a:graphicData>
@@ -6015,7 +5777,7 @@
       </p:graphicFrame>
       <p:sp>
         <p:nvSpPr>
-          <p:cNvPr id="7" name="Shape 4"/>
+          <p:cNvPr id="6" name="Shape 4"/>
           <p:cNvSpPr/>
           <p:nvPr/>
         </p:nvSpPr>
@@ -6056,7 +5818,7 @@
           <a:bodyPr wrap="square" rtlCol="0" anchor="ctr"/>
           <a:lstStyle/>
           <a:p>
-            <a:pPr algn="ctr" indent="0" marL="0">
+            <a:pPr marL="0" indent="0" algn="ctr">
               <a:buNone/>
             </a:pPr>
             <a:r>
@@ -6095,7 +5857,7 @@
           <a:bodyPr wrap="square" rtlCol="0" anchor="ctr"/>
           <a:lstStyle/>
           <a:p>
-            <a:pPr indent="0" marL="0">
+            <a:pPr marL="0" indent="0">
               <a:buNone/>
             </a:pPr>
             <a:r>
@@ -6134,7 +5896,7 @@
           <a:bodyPr wrap="square" rtlCol="0" anchor="ctr"/>
           <a:lstStyle/>
           <a:p>
-            <a:pPr indent="0" marL="0">
+            <a:pPr marL="0" indent="0">
               <a:buNone/>
             </a:pPr>
             <a:r>
@@ -6195,7 +5957,7 @@
           <a:bodyPr wrap="square" rtlCol="0" anchor="ctr"/>
           <a:lstStyle/>
           <a:p>
-            <a:pPr algn="ctr" indent="0" marL="0">
+            <a:pPr marL="0" indent="0" algn="ctr">
               <a:buNone/>
             </a:pPr>
             <a:r>
@@ -6234,7 +5996,7 @@
           <a:bodyPr wrap="square" rtlCol="0" anchor="ctr"/>
           <a:lstStyle/>
           <a:p>
-            <a:pPr indent="0" marL="0">
+            <a:pPr marL="0" indent="0">
               <a:buNone/>
             </a:pPr>
             <a:r>
@@ -6273,7 +6035,7 @@
           <a:bodyPr wrap="square" rtlCol="0" anchor="ctr"/>
           <a:lstStyle/>
           <a:p>
-            <a:pPr indent="0" marL="0">
+            <a:pPr marL="0" indent="0">
               <a:buNone/>
             </a:pPr>
             <a:r>
@@ -6334,7 +6096,7 @@
           <a:bodyPr wrap="square" rtlCol="0" anchor="ctr"/>
           <a:lstStyle/>
           <a:p>
-            <a:pPr indent="0" marL="0">
+            <a:pPr marL="0" indent="0">
               <a:lnSpc>
                 <a:spcPts val="2600"/>
               </a:lnSpc>
@@ -6351,12 +6113,6 @@
               </a:rPr>
               <a:t>Por que no accuracy ni F1:  </a:t>
             </a:r>
-            <a:pPr indent="0" marL="0">
-              <a:lnSpc>
-                <a:spcPts val="2600"/>
-              </a:lnSpc>
-              <a:buNone/>
-            </a:pPr>
             <a:r>
               <a:rPr lang="en-US" sz="1500" dirty="0">
                 <a:solidFill>
@@ -6393,7 +6149,7 @@
           <a:bodyPr wrap="square" rtlCol="0" anchor="ctr"/>
           <a:lstStyle/>
           <a:p>
-            <a:pPr indent="0" marL="0">
+            <a:pPr marL="0" indent="0">
               <a:buNone/>
             </a:pPr>
             <a:r>
@@ -6427,6 +6183,7 @@
         <a:solidFill>
           <a:srgbClr val="F9F9F9"/>
         </a:solidFill>
+        <a:effectLst/>
       </p:bgPr>
     </p:bg>
     <p:spTree>
@@ -6484,11 +6241,11 @@
           <a:bodyPr wrap="square" rtlCol="0" anchor="ctr"/>
           <a:lstStyle/>
           <a:p>
-            <a:pPr algn="ctr" indent="0" marL="0">
-              <a:buNone/>
-            </a:pPr>
-            <a:r>
-              <a:rPr lang="en-US" sz="1200" b="1" spc="200" kern="0" dirty="0">
+            <a:pPr marL="0" indent="0" algn="ctr">
+              <a:buNone/>
+            </a:pPr>
+            <a:r>
+              <a:rPr lang="en-US" sz="1200" b="1" kern="0" spc="200" dirty="0">
                 <a:solidFill>
                   <a:srgbClr val="E0FBFC"/>
                 </a:solidFill>
@@ -6523,7 +6280,7 @@
           <a:bodyPr wrap="square" rtlCol="0" anchor="ctr"/>
           <a:lstStyle/>
           <a:p>
-            <a:pPr indent="0" marL="0">
+            <a:pPr marL="0" indent="0">
               <a:buNone/>
             </a:pPr>
             <a:r>
@@ -6562,7 +6319,7 @@
           <a:bodyPr wrap="square" rtlCol="0" anchor="ctr"/>
           <a:lstStyle/>
           <a:p>
-            <a:pPr indent="0" marL="0">
+            <a:pPr marL="0" indent="0">
               <a:buNone/>
             </a:pPr>
             <a:r>
@@ -6648,7 +6405,7 @@
           <a:bodyPr wrap="square" rtlCol="0" anchor="ctr"/>
           <a:lstStyle/>
           <a:p>
-            <a:pPr algn="ctr" indent="0" marL="0">
+            <a:pPr marL="0" indent="0" algn="ctr">
               <a:buNone/>
             </a:pPr>
             <a:r>
@@ -6687,7 +6444,7 @@
           <a:bodyPr wrap="square" rtlCol="0" anchor="ctr"/>
           <a:lstStyle/>
           <a:p>
-            <a:pPr indent="0" marL="0">
+            <a:pPr marL="0" indent="0">
               <a:buNone/>
             </a:pPr>
             <a:r>
@@ -6726,7 +6483,7 @@
           <a:bodyPr wrap="square" rtlCol="0" anchor="ctr"/>
           <a:lstStyle/>
           <a:p>
-            <a:pPr indent="0" marL="0">
+            <a:pPr marL="0" indent="0">
               <a:buNone/>
             </a:pPr>
             <a:r>
@@ -6812,7 +6569,7 @@
           <a:bodyPr wrap="square" rtlCol="0" anchor="ctr"/>
           <a:lstStyle/>
           <a:p>
-            <a:pPr algn="ctr" indent="0" marL="0">
+            <a:pPr marL="0" indent="0" algn="ctr">
               <a:buNone/>
             </a:pPr>
             <a:r>
@@ -6851,7 +6608,7 @@
           <a:bodyPr wrap="square" rtlCol="0" anchor="ctr"/>
           <a:lstStyle/>
           <a:p>
-            <a:pPr indent="0" marL="0">
+            <a:pPr marL="0" indent="0">
               <a:buNone/>
             </a:pPr>
             <a:r>
@@ -6890,7 +6647,7 @@
           <a:bodyPr wrap="square" rtlCol="0" anchor="ctr"/>
           <a:lstStyle/>
           <a:p>
-            <a:pPr indent="0" marL="0">
+            <a:pPr marL="0" indent="0">
               <a:buNone/>
             </a:pPr>
             <a:r>
@@ -6976,7 +6733,7 @@
           <a:bodyPr wrap="square" rtlCol="0" anchor="ctr"/>
           <a:lstStyle/>
           <a:p>
-            <a:pPr algn="ctr" indent="0" marL="0">
+            <a:pPr marL="0" indent="0" algn="ctr">
               <a:buNone/>
             </a:pPr>
             <a:r>
@@ -7015,7 +6772,7 @@
           <a:bodyPr wrap="square" rtlCol="0" anchor="ctr"/>
           <a:lstStyle/>
           <a:p>
-            <a:pPr indent="0" marL="0">
+            <a:pPr marL="0" indent="0">
               <a:buNone/>
             </a:pPr>
             <a:r>
@@ -7054,7 +6811,7 @@
           <a:bodyPr wrap="square" rtlCol="0" anchor="ctr"/>
           <a:lstStyle/>
           <a:p>
-            <a:pPr indent="0" marL="0">
+            <a:pPr marL="0" indent="0">
               <a:buNone/>
             </a:pPr>
             <a:r>
@@ -7093,7 +6850,7 @@
           <a:bodyPr wrap="square" rtlCol="0" anchor="ctr"/>
           <a:lstStyle/>
           <a:p>
-            <a:pPr indent="0" marL="0">
+            <a:pPr marL="0" indent="0">
               <a:buNone/>
             </a:pPr>
             <a:r>
@@ -7127,6 +6884,7 @@
         <a:solidFill>
           <a:srgbClr val="0D1B2A"/>
         </a:solidFill>
+        <a:effectLst/>
       </p:bgPr>
     </p:bg>
     <p:spTree>
@@ -7164,7 +6922,7 @@
           <a:bodyPr wrap="square" lIns="0" tIns="0" rIns="0" bIns="0" rtlCol="0" anchor="ctr"/>
           <a:lstStyle/>
           <a:p>
-            <a:pPr indent="0" marL="0">
+            <a:pPr marL="0" indent="0">
               <a:buNone/>
             </a:pPr>
             <a:r>
@@ -7225,7 +6983,7 @@
           <a:bodyPr wrap="square" rtlCol="0" anchor="ctr"/>
           <a:lstStyle/>
           <a:p>
-            <a:pPr algn="ctr" indent="0" marL="0">
+            <a:pPr marL="0" indent="0" algn="ctr">
               <a:buNone/>
             </a:pPr>
             <a:r>
@@ -7264,7 +7022,7 @@
           <a:bodyPr wrap="square" rtlCol="0" anchor="ctr"/>
           <a:lstStyle/>
           <a:p>
-            <a:pPr indent="0" marL="0">
+            <a:pPr marL="0" indent="0">
               <a:buNone/>
             </a:pPr>
             <a:r>
@@ -7303,7 +7061,7 @@
           <a:bodyPr wrap="square" rtlCol="0" anchor="ctr"/>
           <a:lstStyle/>
           <a:p>
-            <a:pPr indent="0" marL="0">
+            <a:pPr marL="0" indent="0">
               <a:buNone/>
             </a:pPr>
             <a:r>
@@ -7364,7 +7122,7 @@
           <a:bodyPr wrap="square" rtlCol="0" anchor="ctr"/>
           <a:lstStyle/>
           <a:p>
-            <a:pPr algn="ctr" indent="0" marL="0">
+            <a:pPr marL="0" indent="0" algn="ctr">
               <a:buNone/>
             </a:pPr>
             <a:r>
@@ -7403,7 +7161,7 @@
           <a:bodyPr wrap="square" rtlCol="0" anchor="ctr"/>
           <a:lstStyle/>
           <a:p>
-            <a:pPr indent="0" marL="0">
+            <a:pPr marL="0" indent="0">
               <a:buNone/>
             </a:pPr>
             <a:r>
@@ -7442,7 +7200,7 @@
           <a:bodyPr wrap="square" rtlCol="0" anchor="ctr"/>
           <a:lstStyle/>
           <a:p>
-            <a:pPr indent="0" marL="0">
+            <a:pPr marL="0" indent="0">
               <a:buNone/>
             </a:pPr>
             <a:r>
@@ -7503,7 +7261,7 @@
           <a:bodyPr wrap="square" rtlCol="0" anchor="ctr"/>
           <a:lstStyle/>
           <a:p>
-            <a:pPr algn="ctr" indent="0" marL="0">
+            <a:pPr marL="0" indent="0" algn="ctr">
               <a:buNone/>
             </a:pPr>
             <a:r>
@@ -7542,7 +7300,7 @@
           <a:bodyPr wrap="square" rtlCol="0" anchor="ctr"/>
           <a:lstStyle/>
           <a:p>
-            <a:pPr indent="0" marL="0">
+            <a:pPr marL="0" indent="0">
               <a:buNone/>
             </a:pPr>
             <a:r>
@@ -7581,7 +7339,7 @@
           <a:bodyPr wrap="square" rtlCol="0" anchor="ctr"/>
           <a:lstStyle/>
           <a:p>
-            <a:pPr indent="0" marL="0">
+            <a:pPr marL="0" indent="0">
               <a:buNone/>
             </a:pPr>
             <a:r>
@@ -7623,14 +7381,14 @@
       </p:sp>
       <p:pic>
         <p:nvPicPr>
-          <p:cNvPr id="16" name="Image 0" descr="D:\Dev\02_UNIVERSIDAD\FrostPuno\.claude\worktrees\flutter-frost-prediction-puno-d1a1d7\docs\presentacion\img\actions_detalle.png">    </p:cNvPr>
+          <p:cNvPr id="16" name="Image 0" descr="D:\Dev\02_UNIVERSIDAD\FrostPuno\.claude\worktrees\flutter-frost-prediction-puno-d1a1d7\docs\presentacion\img\actions_detalle.png"/>
           <p:cNvPicPr>
             <a:picLocks noChangeAspect="1"/>
           </p:cNvPicPr>
           <p:nvPr/>
         </p:nvPicPr>
         <p:blipFill>
-          <a:blip r:embed="rId1"/>
+          <a:blip r:embed="rId3"/>
           <a:stretch>
             <a:fillRect/>
           </a:stretch>
@@ -7666,7 +7424,7 @@
           <a:bodyPr wrap="square" rtlCol="0" anchor="ctr"/>
           <a:lstStyle/>
           <a:p>
-            <a:pPr algn="ctr" indent="0" marL="0">
+            <a:pPr marL="0" indent="0" algn="ctr">
               <a:buNone/>
             </a:pPr>
             <a:r>
@@ -7727,7 +7485,7 @@
           <a:bodyPr wrap="square" rtlCol="0" anchor="ctr"/>
           <a:lstStyle/>
           <a:p>
-            <a:pPr algn="ctr" indent="0" marL="0">
+            <a:pPr marL="0" indent="0" algn="ctr">
               <a:buNone/>
             </a:pPr>
             <a:r>
@@ -7766,7 +7524,7 @@
           <a:bodyPr wrap="square" rtlCol="0" anchor="ctr"/>
           <a:lstStyle/>
           <a:p>
-            <a:pPr algn="ctr" indent="0" marL="0">
+            <a:pPr marL="0" indent="0" algn="ctr">
               <a:buNone/>
             </a:pPr>
             <a:r>
@@ -7827,7 +7585,7 @@
           <a:bodyPr wrap="square" rtlCol="0" anchor="ctr"/>
           <a:lstStyle/>
           <a:p>
-            <a:pPr algn="ctr" indent="0" marL="0">
+            <a:pPr marL="0" indent="0" algn="ctr">
               <a:buNone/>
             </a:pPr>
             <a:r>
@@ -7866,7 +7624,7 @@
           <a:bodyPr wrap="square" rtlCol="0" anchor="ctr"/>
           <a:lstStyle/>
           <a:p>
-            <a:pPr algn="ctr" indent="0" marL="0">
+            <a:pPr marL="0" indent="0" algn="ctr">
               <a:buNone/>
             </a:pPr>
             <a:r>
@@ -7927,7 +7685,7 @@
           <a:bodyPr wrap="square" rtlCol="0" anchor="ctr"/>
           <a:lstStyle/>
           <a:p>
-            <a:pPr algn="ctr" indent="0" marL="0">
+            <a:pPr marL="0" indent="0" algn="ctr">
               <a:buNone/>
             </a:pPr>
             <a:r>
@@ -7966,7 +7724,7 @@
           <a:bodyPr wrap="square" rtlCol="0" anchor="ctr"/>
           <a:lstStyle/>
           <a:p>
-            <a:pPr algn="ctr" indent="0" marL="0">
+            <a:pPr marL="0" indent="0" algn="ctr">
               <a:buNone/>
             </a:pPr>
             <a:r>
@@ -8025,7 +7783,7 @@
           <a:bodyPr wrap="square" lIns="0" tIns="0" rIns="0" bIns="0" rtlCol="0" anchor="ctr"/>
           <a:lstStyle/>
           <a:p>
-            <a:pPr indent="0" marL="0">
+            <a:pPr marL="0" indent="0">
               <a:buNone/>
             </a:pPr>
             <a:r>
@@ -8064,7 +7822,7 @@
           <a:bodyPr wrap="square" rtlCol="0" anchor="ctr"/>
           <a:lstStyle/>
           <a:p>
-            <a:pPr algn="r" indent="0" marL="0">
+            <a:pPr marL="0" indent="0" algn="r">
               <a:buNone/>
             </a:pPr>
             <a:r>
@@ -8383,4 +8141,299 @@
     </a:ext>
   </a:extLst>
 </a:theme>
+</file>
+
+<file path=ppt/theme/theme2.xml><?xml version="1.0" encoding="utf-8"?>
+<a:theme xmlns:a="http://schemas.openxmlformats.org/drawingml/2006/main" name="Tema de Office">
+  <a:themeElements>
+    <a:clrScheme name="Office">
+      <a:dk1>
+        <a:sysClr val="windowText" lastClr="000000"/>
+      </a:dk1>
+      <a:lt1>
+        <a:sysClr val="window" lastClr="FFFFFF"/>
+      </a:lt1>
+      <a:dk2>
+        <a:srgbClr val="44546A"/>
+      </a:dk2>
+      <a:lt2>
+        <a:srgbClr val="E7E6E6"/>
+      </a:lt2>
+      <a:accent1>
+        <a:srgbClr val="4472C4"/>
+      </a:accent1>
+      <a:accent2>
+        <a:srgbClr val="ED7D31"/>
+      </a:accent2>
+      <a:accent3>
+        <a:srgbClr val="A5A5A5"/>
+      </a:accent3>
+      <a:accent4>
+        <a:srgbClr val="FFC000"/>
+      </a:accent4>
+      <a:accent5>
+        <a:srgbClr val="5B9BD5"/>
+      </a:accent5>
+      <a:accent6>
+        <a:srgbClr val="70AD47"/>
+      </a:accent6>
+      <a:hlink>
+        <a:srgbClr val="0563C1"/>
+      </a:hlink>
+      <a:folHlink>
+        <a:srgbClr val="954F72"/>
+      </a:folHlink>
+    </a:clrScheme>
+    <a:fontScheme name="Office">
+      <a:majorFont>
+        <a:latin typeface="Calibri Light" panose="020F0302020204030204"/>
+        <a:ea typeface=""/>
+        <a:cs typeface=""/>
+        <a:font script="Jpan" typeface="游ゴシック Light"/>
+        <a:font script="Hang" typeface="맑은 고딕"/>
+        <a:font script="Hans" typeface="等线 Light"/>
+        <a:font script="Hant" typeface="新細明體"/>
+        <a:font script="Arab" typeface="Times New Roman"/>
+        <a:font script="Hebr" typeface="Times New Roman"/>
+        <a:font script="Thai" typeface="Angsana New"/>
+        <a:font script="Ethi" typeface="Nyala"/>
+        <a:font script="Beng" typeface="Vrinda"/>
+        <a:font script="Gujr" typeface="Shruti"/>
+        <a:font script="Khmr" typeface="MoolBoran"/>
+        <a:font script="Knda" typeface="Tunga"/>
+        <a:font script="Guru" typeface="Raavi"/>
+        <a:font script="Cans" typeface="Euphemia"/>
+        <a:font script="Cher" typeface="Plantagenet Cherokee"/>
+        <a:font script="Yiii" typeface="Microsoft Yi Baiti"/>
+        <a:font script="Tibt" typeface="Microsoft Himalaya"/>
+        <a:font script="Thaa" typeface="MV Boli"/>
+        <a:font script="Deva" typeface="Mangal"/>
+        <a:font script="Telu" typeface="Gautami"/>
+        <a:font script="Taml" typeface="Latha"/>
+        <a:font script="Syrc" typeface="Estrangelo Edessa"/>
+        <a:font script="Orya" typeface="Kalinga"/>
+        <a:font script="Mlym" typeface="Kartika"/>
+        <a:font script="Laoo" typeface="DokChampa"/>
+        <a:font script="Sinh" typeface="Iskoola Pota"/>
+        <a:font script="Mong" typeface="Mongolian Baiti"/>
+        <a:font script="Viet" typeface="Times New Roman"/>
+        <a:font script="Uigh" typeface="Microsoft Uighur"/>
+        <a:font script="Geor" typeface="Sylfaen"/>
+        <a:font script="Armn" typeface="Arial"/>
+        <a:font script="Bugi" typeface="Leelawadee UI"/>
+        <a:font script="Bopo" typeface="Microsoft JhengHei"/>
+        <a:font script="Java" typeface="Javanese Text"/>
+        <a:font script="Lisu" typeface="Segoe UI"/>
+        <a:font script="Mymr" typeface="Myanmar Text"/>
+        <a:font script="Nkoo" typeface="Ebrima"/>
+        <a:font script="Olck" typeface="Nirmala UI"/>
+        <a:font script="Osma" typeface="Ebrima"/>
+        <a:font script="Phag" typeface="Phagspa"/>
+        <a:font script="Syrn" typeface="Estrangelo Edessa"/>
+        <a:font script="Syrj" typeface="Estrangelo Edessa"/>
+        <a:font script="Syre" typeface="Estrangelo Edessa"/>
+        <a:font script="Sora" typeface="Nirmala UI"/>
+        <a:font script="Tale" typeface="Microsoft Tai Le"/>
+        <a:font script="Talu" typeface="Microsoft New Tai Lue"/>
+        <a:font script="Tfng" typeface="Ebrima"/>
+      </a:majorFont>
+      <a:minorFont>
+        <a:latin typeface="Calibri" panose="020F0502020204030204"/>
+        <a:ea typeface=""/>
+        <a:cs typeface=""/>
+        <a:font script="Jpan" typeface="游ゴシック"/>
+        <a:font script="Hang" typeface="맑은 고딕"/>
+        <a:font script="Hans" typeface="等线"/>
+        <a:font script="Hant" typeface="新細明體"/>
+        <a:font script="Arab" typeface="Arial"/>
+        <a:font script="Hebr" typeface="Arial"/>
+        <a:font script="Thai" typeface="Cordia New"/>
+        <a:font script="Ethi" typeface="Nyala"/>
+        <a:font script="Beng" typeface="Vrinda"/>
+        <a:font script="Gujr" typeface="Shruti"/>
+        <a:font script="Khmr" typeface="DaunPenh"/>
+        <a:font script="Knda" typeface="Tunga"/>
+        <a:font script="Guru" typeface="Raavi"/>
+        <a:font script="Cans" typeface="Euphemia"/>
+        <a:font script="Cher" typeface="Plantagenet Cherokee"/>
+        <a:font script="Yiii" typeface="Microsoft Yi Baiti"/>
+        <a:font script="Tibt" typeface="Microsoft Himalaya"/>
+        <a:font script="Thaa" typeface="MV Boli"/>
+        <a:font script="Deva" typeface="Mangal"/>
+        <a:font script="Telu" typeface="Gautami"/>
+        <a:font script="Taml" typeface="Latha"/>
+        <a:font script="Syrc" typeface="Estrangelo Edessa"/>
+        <a:font script="Orya" typeface="Kalinga"/>
+        <a:font script="Mlym" typeface="Kartika"/>
+        <a:font script="Laoo" typeface="DokChampa"/>
+        <a:font script="Sinh" typeface="Iskoola Pota"/>
+        <a:font script="Mong" typeface="Mongolian Baiti"/>
+        <a:font script="Viet" typeface="Arial"/>
+        <a:font script="Uigh" typeface="Microsoft Uighur"/>
+        <a:font script="Geor" typeface="Sylfaen"/>
+        <a:font script="Armn" typeface="Arial"/>
+        <a:font script="Bugi" typeface="Leelawadee UI"/>
+        <a:font script="Bopo" typeface="Microsoft JhengHei"/>
+        <a:font script="Java" typeface="Javanese Text"/>
+        <a:font script="Lisu" typeface="Segoe UI"/>
+        <a:font script="Mymr" typeface="Myanmar Text"/>
+        <a:font script="Nkoo" typeface="Ebrima"/>
+        <a:font script="Olck" typeface="Nirmala UI"/>
+        <a:font script="Osma" typeface="Ebrima"/>
+        <a:font script="Phag" typeface="Phagspa"/>
+        <a:font script="Syrn" typeface="Estrangelo Edessa"/>
+        <a:font script="Syrj" typeface="Estrangelo Edessa"/>
+        <a:font script="Syre" typeface="Estrangelo Edessa"/>
+        <a:font script="Sora" typeface="Nirmala UI"/>
+        <a:font script="Tale" typeface="Microsoft Tai Le"/>
+        <a:font script="Talu" typeface="Microsoft New Tai Lue"/>
+        <a:font script="Tfng" typeface="Ebrima"/>
+      </a:minorFont>
+    </a:fontScheme>
+    <a:fmtScheme name="Office">
+      <a:fillStyleLst>
+        <a:solidFill>
+          <a:schemeClr val="phClr"/>
+        </a:solidFill>
+        <a:gradFill rotWithShape="1">
+          <a:gsLst>
+            <a:gs pos="0">
+              <a:schemeClr val="phClr">
+                <a:lumMod val="110000"/>
+                <a:satMod val="105000"/>
+                <a:tint val="67000"/>
+              </a:schemeClr>
+            </a:gs>
+            <a:gs pos="50000">
+              <a:schemeClr val="phClr">
+                <a:lumMod val="105000"/>
+                <a:satMod val="103000"/>
+                <a:tint val="73000"/>
+              </a:schemeClr>
+            </a:gs>
+            <a:gs pos="100000">
+              <a:schemeClr val="phClr">
+                <a:lumMod val="105000"/>
+                <a:satMod val="109000"/>
+                <a:tint val="81000"/>
+              </a:schemeClr>
+            </a:gs>
+          </a:gsLst>
+          <a:lin ang="5400000" scaled="0"/>
+        </a:gradFill>
+        <a:gradFill rotWithShape="1">
+          <a:gsLst>
+            <a:gs pos="0">
+              <a:schemeClr val="phClr">
+                <a:satMod val="103000"/>
+                <a:lumMod val="102000"/>
+                <a:tint val="94000"/>
+              </a:schemeClr>
+            </a:gs>
+            <a:gs pos="50000">
+              <a:schemeClr val="phClr">
+                <a:satMod val="110000"/>
+                <a:lumMod val="100000"/>
+                <a:shade val="100000"/>
+              </a:schemeClr>
+            </a:gs>
+            <a:gs pos="100000">
+              <a:schemeClr val="phClr">
+                <a:lumMod val="99000"/>
+                <a:satMod val="120000"/>
+                <a:shade val="78000"/>
+              </a:schemeClr>
+            </a:gs>
+          </a:gsLst>
+          <a:lin ang="5400000" scaled="0"/>
+        </a:gradFill>
+      </a:fillStyleLst>
+      <a:lnStyleLst>
+        <a:ln w="6350" cap="flat" cmpd="sng" algn="ctr">
+          <a:solidFill>
+            <a:schemeClr val="phClr"/>
+          </a:solidFill>
+          <a:prstDash val="solid"/>
+          <a:miter lim="800000"/>
+        </a:ln>
+        <a:ln w="12700" cap="flat" cmpd="sng" algn="ctr">
+          <a:solidFill>
+            <a:schemeClr val="phClr"/>
+          </a:solidFill>
+          <a:prstDash val="solid"/>
+          <a:miter lim="800000"/>
+        </a:ln>
+        <a:ln w="19050" cap="flat" cmpd="sng" algn="ctr">
+          <a:solidFill>
+            <a:schemeClr val="phClr"/>
+          </a:solidFill>
+          <a:prstDash val="solid"/>
+          <a:miter lim="800000"/>
+        </a:ln>
+      </a:lnStyleLst>
+      <a:effectStyleLst>
+        <a:effectStyle>
+          <a:effectLst/>
+        </a:effectStyle>
+        <a:effectStyle>
+          <a:effectLst/>
+        </a:effectStyle>
+        <a:effectStyle>
+          <a:effectLst>
+            <a:outerShdw blurRad="57150" dist="19050" dir="5400000" algn="ctr" rotWithShape="0">
+              <a:srgbClr val="000000">
+                <a:alpha val="63000"/>
+              </a:srgbClr>
+            </a:outerShdw>
+          </a:effectLst>
+        </a:effectStyle>
+      </a:effectStyleLst>
+      <a:bgFillStyleLst>
+        <a:solidFill>
+          <a:schemeClr val="phClr"/>
+        </a:solidFill>
+        <a:solidFill>
+          <a:schemeClr val="phClr">
+            <a:tint val="95000"/>
+            <a:satMod val="170000"/>
+          </a:schemeClr>
+        </a:solidFill>
+        <a:gradFill rotWithShape="1">
+          <a:gsLst>
+            <a:gs pos="0">
+              <a:schemeClr val="phClr">
+                <a:tint val="93000"/>
+                <a:satMod val="150000"/>
+                <a:shade val="98000"/>
+                <a:lumMod val="102000"/>
+              </a:schemeClr>
+            </a:gs>
+            <a:gs pos="50000">
+              <a:schemeClr val="phClr">
+                <a:tint val="98000"/>
+                <a:satMod val="130000"/>
+                <a:shade val="90000"/>
+                <a:lumMod val="103000"/>
+              </a:schemeClr>
+            </a:gs>
+            <a:gs pos="100000">
+              <a:schemeClr val="phClr">
+                <a:shade val="63000"/>
+                <a:satMod val="120000"/>
+              </a:schemeClr>
+            </a:gs>
+          </a:gsLst>
+          <a:lin ang="5400000" scaled="0"/>
+        </a:gradFill>
+      </a:bgFillStyleLst>
+    </a:fmtScheme>
+  </a:themeElements>
+  <a:objectDefaults/>
+  <a:extraClrSchemeLst/>
+  <a:extLst>
+    <a:ext uri="{05A4C25C-085E-4340-85A3-A5531E510DB2}">
+      <thm15:themeFamily xmlns:thm15="http://schemas.microsoft.com/office/thememl/2012/main" name="Office Theme" id="{62F939B6-93AF-4DB8-9C6B-D6C7DFDC589F}" vid="{4A3C46E8-61CC-4603-A589-7422A47A8E4A}"/>
+    </a:ext>
+  </a:extLst>
+</a:theme>
 </file>
</xml_diff>